<commit_message>
Add live URL (tys-fintech.vercel.app) to README and deck; site QR on demo slide
</commit_message>
<xml_diff>
--- a/deck/Daromad_TYS_deck.pptx
+++ b/deck/Daromad_TYS_deck.pptx
@@ -119,41 +119,41 @@
   <p:extLst>
     <p:ext uri="{521415D9-36F7-43E2-AB2F-B90AF26B5E84}">
       <p14:sectionLst xmlns:p14="http://schemas.microsoft.com/office/powerpoint/2010/main">
-        <p14:section name="Opening" id="{dc736943-4a73-6104-1241-5aa3dcec2526}">
+        <p14:section name="Opening" id="{2c9433c9-3d1f-dec7-e971-e968730de954}">
           <p14:sldIdLst>
             <p14:sldId id="256"/>
           </p14:sldIdLst>
         </p14:section>
-        <p14:section name="Problem" id="{d4a81f66-6575-b73b-0227-99e3a944a8ec}">
+        <p14:section name="Problem" id="{86f9ce27-2306-6a6e-a3d6-7fac8f1bdff4}">
           <p14:sldIdLst>
             <p14:sldId id="257"/>
           </p14:sldIdLst>
         </p14:section>
-        <p14:section name="Product" id="{71312454-ed6a-0756-0134-b77108f996fe}">
+        <p14:section name="Product" id="{26dd9a4d-ca88-abee-e6c7-934bece0931e}">
           <p14:sldIdLst>
             <p14:sldId id="258"/>
             <p14:sldId id="259"/>
           </p14:sldIdLst>
         </p14:section>
-        <p14:section name="Technology" id="{0ff2d4d2-0213-254e-d16d-c0c5b944cac7}">
+        <p14:section name="Technology" id="{4547765b-28a7-a95d-bb32-4f980ffdc14c}">
           <p14:sldIdLst>
             <p14:sldId id="260"/>
             <p14:sldId id="261"/>
             <p14:sldId id="262"/>
           </p14:sldIdLst>
         </p14:section>
-        <p14:section name="Business" id="{004e4952-f6ee-f1ed-00dc-79606ea51893}">
+        <p14:section name="Business" id="{eda98a38-1a1e-8e2e-6a58-ec571812a06c}">
           <p14:sldIdLst>
             <p14:sldId id="263"/>
             <p14:sldId id="264"/>
           </p14:sldIdLst>
         </p14:section>
-        <p14:section name="Closing" id="{a7ebaadc-e1e4-731a-2671-894049048641}">
+        <p14:section name="Closing" id="{c8be60b1-cbf4-6417-7a4e-0dc9e4680e2c}">
           <p14:sldIdLst>
             <p14:sldId id="265"/>
           </p14:sldIdLst>
         </p14:section>
-        <p14:section name="Appendix" id="{3efe21ce-4c21-909e-920d-7f7560d02a9c}">
+        <p14:section name="Appendix" id="{2b58fb64-16ee-028b-f3da-4fd90c3b0e17}">
           <p14:sldIdLst>
             <p14:sldId id="266"/>
             <p14:sldId id="267"/>
@@ -2928,7 +2928,7 @@
                   <a:srgbClr val="8FB8A5"/>
                 </a:solidFill>
               </a:rPr>
-              <a:t>https://&lt;your-project&gt;.vercel.app    </a:t>
+              <a:t>https://tys-fintech.vercel.app    </a:t>
             </a:r>
             <a:pPr indent="0" marL="0">
               <a:buNone/>
@@ -3194,7 +3194,7 @@
                   <a:srgbClr val="8FB8A5"/>
                 </a:solidFill>
               </a:rPr>
-              <a:t>https://&lt;your-project&gt;.vercel.app
+              <a:t>https://tys-fintech.vercel.app
 </a:t>
             </a:r>
             <a:pPr indent="0" marL="0">
@@ -9129,7 +9129,7 @@
                   <a:srgbClr val="FFFFFF"/>
                 </a:solidFill>
               </a:rPr>
-              <a:t>https://&lt;your-project&gt;.vercel.app</a:t>
+              <a:t>https://tys-fintech.vercel.app</a:t>
             </a:r>
             <a:endParaRPr lang="en-US" sz="1200" dirty="0"/>
           </a:p>
@@ -9309,7 +9309,7 @@
       </p:pic>
       <p:pic>
         <p:nvPicPr>
-          <p:cNvPr id="10" name="qr repo" descr="/home/claude/daromad/deck/img/qr_repo.png">    </p:cNvPr>
+          <p:cNvPr id="10" name="qr site" descr="/home/claude/daromad/deck/img/qr_site.png">    </p:cNvPr>
           <p:cNvPicPr>
             <a:picLocks noChangeAspect="1"/>
           </p:cNvPicPr>
@@ -9323,8 +9323,8 @@
         </p:blipFill>
         <p:spPr>
           <a:xfrm>
-            <a:off x="9966960" y="3794760"/>
-            <a:ext cx="1600200" cy="1600200"/>
+            <a:off x="9692640" y="3703320"/>
+            <a:ext cx="1828800" cy="1828800"/>
           </a:xfrm>
           <a:prstGeom prst="rect">
             <a:avLst/>
@@ -9339,7 +9339,7 @@
         </p:nvSpPr>
         <p:spPr>
           <a:xfrm>
-            <a:off x="6400800" y="5486400"/>
+            <a:off x="6400800" y="5577840"/>
             <a:ext cx="5303520" cy="457200"/>
           </a:xfrm>
           <a:prstGeom prst="rect">
@@ -9361,7 +9361,7 @@
                   <a:srgbClr val="5C6B63"/>
                 </a:solidFill>
               </a:rPr>
-              <a:t>Scan for the repository; the live site link is on the title slide and in the README</a:t>
+              <a:t>Scan to open the live prototype on your phone (New case → Load sample A)</a:t>
             </a:r>
             <a:endParaRPr lang="en-US" sz="1000" dirty="0"/>
           </a:p>

</xml_diff>

<commit_message>
Deck and script: corrected ROI arithmetic and addressable share, slide 2 reasons, OOD and CI on the numbers slide, appendix clauses; README known items
</commit_message>
<xml_diff>
--- a/deck/Daromad_TYS_deck.pptx
+++ b/deck/Daromad_TYS_deck.pptx
@@ -119,41 +119,41 @@
   <p:extLst>
     <p:ext uri="{521415D9-36F7-43E2-AB2F-B90AF26B5E84}">
       <p14:sectionLst xmlns:p14="http://schemas.microsoft.com/office/powerpoint/2010/main">
-        <p14:section name="Opening" id="{2c9433c9-3d1f-dec7-e971-e968730de954}">
+        <p14:section name="Opening" id="{de89c4e0-9772-7da7-4b7c-25f1ccb825cd}">
           <p14:sldIdLst>
             <p14:sldId id="256"/>
           </p14:sldIdLst>
         </p14:section>
-        <p14:section name="Problem" id="{86f9ce27-2306-6a6e-a3d6-7fac8f1bdff4}">
+        <p14:section name="Problem" id="{0f9db429-52f8-4f01-a60e-bb9af2cface0}">
           <p14:sldIdLst>
             <p14:sldId id="257"/>
           </p14:sldIdLst>
         </p14:section>
-        <p14:section name="Product" id="{26dd9a4d-ca88-abee-e6c7-934bece0931e}">
+        <p14:section name="Product" id="{7c107e09-6934-b995-7391-b967f057d447}">
           <p14:sldIdLst>
             <p14:sldId id="258"/>
             <p14:sldId id="259"/>
           </p14:sldIdLst>
         </p14:section>
-        <p14:section name="Technology" id="{4547765b-28a7-a95d-bb32-4f980ffdc14c}">
+        <p14:section name="Technology" id="{871b2d10-a7df-0940-4b52-c34ab4fd922e}">
           <p14:sldIdLst>
             <p14:sldId id="260"/>
             <p14:sldId id="261"/>
             <p14:sldId id="262"/>
           </p14:sldIdLst>
         </p14:section>
-        <p14:section name="Business" id="{eda98a38-1a1e-8e2e-6a58-ec571812a06c}">
+        <p14:section name="Business" id="{87164faa-dd57-d805-88e1-b715ce87d522}">
           <p14:sldIdLst>
             <p14:sldId id="263"/>
             <p14:sldId id="264"/>
           </p14:sldIdLst>
         </p14:section>
-        <p14:section name="Closing" id="{c8be60b1-cbf4-6417-7a4e-0dc9e4680e2c}">
+        <p14:section name="Closing" id="{f699e712-d37b-6afc-5f71-2b8e4311386c}">
           <p14:sldIdLst>
             <p14:sldId id="265"/>
           </p14:sldIdLst>
         </p14:section>
-        <p14:section name="Appendix" id="{2b58fb64-16ee-028b-f3da-4fd90c3b0e17}">
+        <p14:section name="Appendix" id="{b1f89bf7-0ca2-054b-7d6a-0e477dfaf0ef}">
           <p14:sldIdLst>
             <p14:sldId id="266"/>
             <p14:sldId id="267"/>
@@ -1378,7 +1378,7 @@
           <a:p>
             <a:r>
               <a:rPr lang="en-US" dirty="0"/>
-              <a:t>Show the regulation's list of acceptable income evidence. For a self-employed borrower only one line exists: income credited to bank accounts. No payslip, no tax return, no receipts required by law. MKBANK targets about 140,000 micro-projects this year. Every one needs a 12-month income mean and a ПДН under 50 percent, computed from documents like these. [0:45]</a:t>
+              <a:t>Show the regulation's list of acceptable income evidence. For a self-employed borrower only one line exists: income credited to bank accounts — no employer, no pension, income untaxed and unfiled. MKBANK targets about 140,000 micro-projects this year, by its own figures. Every one of them needs a documented income assessment; the ones outside the family programme and above 50 BRV also need a ПДН under 50 percent — computed from documents like these. Fiscal receipts exist only where the business uses an online cash register; we read them as corroboration, not as the income figure. [0:45]</a:t>
             </a:r>
             <a:endParaRPr lang="en-US" dirty="0"/>
           </a:p>
@@ -1554,7 +1554,7 @@
           <a:p>
             <a:r>
               <a:rPr lang="en-US" dirty="0"/>
-              <a:t>Open the public URL. Load sample A. Narrate: statement parsed, certificate read, receipt OCR'd in Uzbek; twelve months of income; ПДН 50.4 percent, max affordable 24.7 million; drag the slider; integrity checks; memo badge: 26 numbers, zero unsourced; click a citation; record the decision; export. If a judge hands you a receipt photo or a statement, upload it. Finish with the tampered statement: balance chain broken at the inflated row. Keep the backup video open in a second tab. [2:00]</a:t>
+              <a:t>Open the public URL. Load sample A. Narrate: statement parsed, certificate read, receipt OCR'd in Uzbek; twelve months of income; ПДН just above 50 percent, so the engine computes the maximum affordable amount; drag the slider under it; integrity checks; the memo badge shows how many numbers were checked and that none is unsourced; click a citation to open the statement lines behind a figure; record the decision; export. If a judge hands you a receipt photo or a statement, upload it. Finish with Load tampered statement (it starts a fresh case): the balance-chain check fails and names the edited line. Keep the backup video open in a second tab. [2:00]</a:t>
             </a:r>
             <a:endParaRPr lang="en-US" dirty="0"/>
           </a:p>
@@ -1730,7 +1730,7 @@
           <a:p>
             <a:r>
               <a:rPr lang="en-US" dirty="0"/>
-              <a:t>Statement parsing exact on 60 of 60 PDFs in two layouts; tamper recall 40 of 40 by type; receipt OCR 95% on totals, 100% on INN; categoriser 99.96% on synthetic vocabulary — that will fall on real data, growing the lexicon is week one. Risk model: AUC 0.965 on our declared synthetic population — proves the pipeline, not the world. So we ran the same 18 features on real anonymised bank data, 443 loans from PKDD'99: AUC 0.90 out-of-fold versus 0.74 for the ratio alone. Cash-flow features carry signal on real statements. [0:45]</a:t>
+              <a:t>Measured through the real app: statement parsing exact on 60 of 60 generator PDFs — and, more importantly, exact on 6 of 6 layouts the parser had never seen: signed-amount CSV, Kirim/Chiqim Excel, quoted English CSV with a type column, Unicode minus, headerless, Приход/Расход TSV. Tamper recall 40 of 40 with no false alarms on clean statements; receipt OCR 95% on totals, 100% on INN. Risk model: AUC 0.965 on our declared synthetic population — proves the pipeline, not the world. So we ran the same 18 features on real anonymised bank data, 443 loans from PKDD'99, 44 of them bad: AUC 0.90 out-of-fold, confidence interval roughly 0.86 to 0.94, versus 0.74 for the ratio alone. Logistic regression is close — we keep the trees for monotone constraints and thresholds, not for the last hundredth. [0:45]</a:t>
             </a:r>
             <a:endParaRPr lang="en-US" dirty="0"/>
           </a:p>
@@ -1906,7 +1906,7 @@
           <a:p>
             <a:r>
               <a:rPr lang="en-US" dirty="0"/>
-              <a:t>Cost: our three people plus one bank analyst, one small VM — no GPU, no licences, no API spend; marginal cost per application is zero. Value: if document handling drops from about 90 to 25 minutes, 140,000 applications a year is roughly 150,000 officer-hours — about 75 FTE-years — plus faster time-to-decision and a clean ПДН audit trail. Month one shadow mode: we measure agreement and minutes; months two and three assisted. Payback inside the first year under those assumptions; every assumption is on the slide and movable. [1:30]</a:t>
+              <a:t>Cost: our three people plus one bank analyst, one small VM — no GPU, no licences, no API spend; marginal cost per application is zero; about 190 million for three months. Value, with two assumptions the pilot exists to measure: document handling falls from about 90 to 25 minutes, and about 30 percent of MKBANK's 140,000 micro-project applications are addressable — outside the family programme and above the 50-BRV threshold. That is 42,000 applications, 45,000 officer-hours, 23 full-time officers, about 4 billion sum a year at a 15-million loaded monthly cost. The pilot does not pay for itself in five branches; the roll-out does, within its first month. Even at a 10 percent addressable share it pays back within two months. Every term is a slider. [1:30]</a:t>
             </a:r>
             <a:endParaRPr lang="en-US" dirty="0"/>
           </a:p>
@@ -3336,7 +3336,7 @@
                 <a:gridCol w="7680960"/>
                 <a:gridCol w="2560320"/>
               </a:tblGrid>
-              <a:tr h="457200">
+              <a:tr h="384048">
                 <a:tc>
                   <a:txBody>
                     <a:bodyPr/>
@@ -3346,14 +3346,14 @@
                         <a:buNone/>
                       </a:pPr>
                       <a:r>
-                        <a:rPr lang="en-US" sz="1000" b="1" dirty="0">
+                        <a:rPr lang="en-US" sz="900" b="1" dirty="0">
                           <a:solidFill>
                             <a:srgbClr val="FFFFFF"/>
                           </a:solidFill>
                         </a:rPr>
                         <a:t>Clause</a:t>
                       </a:r>
-                      <a:endParaRPr lang="en-US" sz="1000" dirty="0"/>
+                      <a:endParaRPr lang="en-US" sz="900" dirty="0"/>
                     </a:p>
                   </a:txBody>
                   <a:tcPr marL="91440" marR="91440" marT="45720" marB="45720">
@@ -3407,14 +3407,14 @@
                         <a:buNone/>
                       </a:pPr>
                       <a:r>
-                        <a:rPr lang="en-US" sz="1000" b="1" dirty="0">
+                        <a:rPr lang="en-US" sz="900" b="1" dirty="0">
                           <a:solidFill>
                             <a:srgbClr val="FFFFFF"/>
                           </a:solidFill>
                         </a:rPr>
                         <a:t>Rule as implemented</a:t>
                       </a:r>
-                      <a:endParaRPr lang="en-US" sz="1000" dirty="0"/>
+                      <a:endParaRPr lang="en-US" sz="900" dirty="0"/>
                     </a:p>
                   </a:txBody>
                   <a:tcPr marL="91440" marR="91440" marT="45720" marB="45720">
@@ -3468,14 +3468,14 @@
                         <a:buNone/>
                       </a:pPr>
                       <a:r>
-                        <a:rPr lang="en-US" sz="1000" b="1" dirty="0">
+                        <a:rPr lang="en-US" sz="900" b="1" dirty="0">
                           <a:solidFill>
                             <a:srgbClr val="FFFFFF"/>
                           </a:solidFill>
                         </a:rPr>
                         <a:t>Where it shows</a:t>
                       </a:r>
-                      <a:endParaRPr lang="en-US" sz="1000" dirty="0"/>
+                      <a:endParaRPr lang="en-US" sz="900" dirty="0"/>
                     </a:p>
                   </a:txBody>
                   <a:tcPr marL="91440" marR="91440" marT="45720" marB="45720">
@@ -3521,7 +3521,7 @@
                   </a:tcPr>
                 </a:tc>
               </a:tr>
-              <a:tr h="457200">
+              <a:tr h="384048">
                 <a:tc>
                   <a:txBody>
                     <a:bodyPr/>
@@ -3531,14 +3531,14 @@
                         <a:buNone/>
                       </a:pPr>
                       <a:r>
-                        <a:rPr lang="en-US" sz="1000" b="1" dirty="0">
+                        <a:rPr lang="en-US" sz="900" b="1" dirty="0">
                           <a:solidFill>
                             <a:srgbClr val="17201B"/>
                           </a:solidFill>
                         </a:rPr>
                         <a:t>cl.1</a:t>
                       </a:r>
-                      <a:endParaRPr lang="en-US" sz="1000" dirty="0"/>
+                      <a:endParaRPr lang="en-US" sz="900" dirty="0"/>
                     </a:p>
                   </a:txBody>
                   <a:tcPr marL="91440" marR="91440" marT="45720" marB="45720">
@@ -3592,14 +3592,14 @@
                         <a:buNone/>
                       </a:pPr>
                       <a:r>
-                        <a:rPr lang="en-US" sz="1000" dirty="0">
+                        <a:rPr lang="en-US" sz="900" dirty="0">
                           <a:solidFill>
                             <a:srgbClr val="17201B"/>
                           </a:solidFill>
                         </a:rPr>
                         <a:t>ПДН = average monthly payments on loans/microloans ÷ average monthly income (borrower + co-borrower)</a:t>
                       </a:r>
-                      <a:endParaRPr lang="en-US" sz="1000" dirty="0"/>
+                      <a:endParaRPr lang="en-US" sz="900" dirty="0"/>
                     </a:p>
                   </a:txBody>
                   <a:tcPr marL="91440" marR="91440" marT="45720" marB="45720">
@@ -3653,14 +3653,14 @@
                         <a:buNone/>
                       </a:pPr>
                       <a:r>
-                        <a:rPr lang="en-US" sz="1000" dirty="0">
+                        <a:rPr lang="en-US" sz="900" dirty="0">
                           <a:solidFill>
                             <a:srgbClr val="17201B"/>
                           </a:solidFill>
                         </a:rPr>
                         <a:t>formula panel</a:t>
                       </a:r>
-                      <a:endParaRPr lang="en-US" sz="1000" dirty="0"/>
+                      <a:endParaRPr lang="en-US" sz="900" dirty="0"/>
                     </a:p>
                   </a:txBody>
                   <a:tcPr marL="91440" marR="91440" marT="45720" marB="45720">
@@ -3706,7 +3706,7 @@
                   </a:tcPr>
                 </a:tc>
               </a:tr>
-              <a:tr h="457200">
+              <a:tr h="384048">
                 <a:tc>
                   <a:txBody>
                     <a:bodyPr/>
@@ -3716,14 +3716,14 @@
                         <a:buNone/>
                       </a:pPr>
                       <a:r>
-                        <a:rPr lang="en-US" sz="1000" b="1" dirty="0">
+                        <a:rPr lang="en-US" sz="900" b="1" dirty="0">
                           <a:solidFill>
                             <a:srgbClr val="17201B"/>
                           </a:solidFill>
                         </a:rPr>
                         <a:t>cl.2</a:t>
                       </a:r>
-                      <a:endParaRPr lang="en-US" sz="1000" dirty="0"/>
+                      <a:endParaRPr lang="en-US" sz="900" dirty="0"/>
                     </a:p>
                   </a:txBody>
                   <a:tcPr marL="91440" marR="91440" marT="45720" marB="45720">
@@ -3777,14 +3777,14 @@
                         <a:buNone/>
                       </a:pPr>
                       <a:r>
-                        <a:rPr lang="en-US" sz="1000" dirty="0">
+                        <a:rPr lang="en-US" sz="900" dirty="0">
                           <a:solidFill>
                             <a:srgbClr val="17201B"/>
                           </a:solidFill>
                         </a:rPr>
-                        <a:t>Includes the application under review and all loan agreements with all lenders; co-borrower loans counted; guarantor loans only if &gt; 30 days overdue; excluded if amount + outstanding principal ≤ 50 BRV</a:t>
+                        <a:t>Includes the application under review and all loan agreements with all lenders; co-borrower loans counted; excluded if amount + outstanding principal ≤ 50 BRV («…50 бараваридан ошмаганда»); 75 BRV for self-employed at MFOs; bank-level allowance: up to 15% of the number of loans to individuals may be issued outside the requirement — a quota the bank tracks, not a per-application rule</a:t>
                       </a:r>
-                      <a:endParaRPr lang="en-US" sz="1000" dirty="0"/>
+                      <a:endParaRPr lang="en-US" sz="900" dirty="0"/>
                     </a:p>
                   </a:txBody>
                   <a:tcPr marL="91440" marR="91440" marT="45720" marB="45720">
@@ -3838,14 +3838,14 @@
                         <a:buNone/>
                       </a:pPr>
                       <a:r>
-                        <a:rPr lang="en-US" sz="1000" dirty="0">
+                        <a:rPr lang="en-US" sz="900" dirty="0">
                           <a:solidFill>
                             <a:srgbClr val="17201B"/>
                           </a:solidFill>
                         </a:rPr>
                         <a:t>obligations table, exemption badge</a:t>
                       </a:r>
-                      <a:endParaRPr lang="en-US" sz="1000" dirty="0"/>
+                      <a:endParaRPr lang="en-US" sz="900" dirty="0"/>
                     </a:p>
                   </a:txBody>
                   <a:tcPr marL="91440" marR="91440" marT="45720" marB="45720">
@@ -3891,7 +3891,7 @@
                   </a:tcPr>
                 </a:tc>
               </a:tr>
-              <a:tr h="457200">
+              <a:tr h="384048">
                 <a:tc>
                   <a:txBody>
                     <a:bodyPr/>
@@ -3901,14 +3901,14 @@
                         <a:buNone/>
                       </a:pPr>
                       <a:r>
-                        <a:rPr lang="en-US" sz="1000" b="1" dirty="0">
+                        <a:rPr lang="en-US" sz="900" b="1" dirty="0">
                           <a:solidFill>
                             <a:srgbClr val="17201B"/>
                           </a:solidFill>
                         </a:rPr>
-                        <a:t>cl.4¹</a:t>
+                        <a:t>cl.4</a:t>
                       </a:r>
-                      <a:endParaRPr lang="en-US" sz="1000" dirty="0"/>
+                      <a:endParaRPr lang="en-US" sz="900" dirty="0"/>
                     </a:p>
                   </a:txBody>
                   <a:tcPr marL="91440" marR="91440" marT="45720" marB="45720">
@@ -3962,14 +3962,14 @@
                         <a:buNone/>
                       </a:pPr>
                       <a:r>
-                        <a:rPr lang="en-US" sz="1000" dirty="0">
+                        <a:rPr lang="en-US" sz="900" dirty="0">
                           <a:solidFill>
                             <a:srgbClr val="17201B"/>
                           </a:solidFill>
                         </a:rPr>
-                        <a:t>Terms over 36 months: total payments spread over 36 (annuity); mortgages over 180 months spread over 180</a:t>
+                        <a:t>Guarantor loans count only when payments are more than 30 days overdue («30 кундан ортиқ муддати ўтган тўловлари мавжуд бўлса»)</a:t>
                       </a:r>
-                      <a:endParaRPr lang="en-US" sz="1000" dirty="0"/>
+                      <a:endParaRPr lang="en-US" sz="900" dirty="0"/>
                     </a:p>
                   </a:txBody>
                   <a:tcPr marL="91440" marR="91440" marT="45720" marB="45720">
@@ -4023,14 +4023,14 @@
                         <a:buNone/>
                       </a:pPr>
                       <a:r>
-                        <a:rPr lang="en-US" sz="1000" dirty="0">
+                        <a:rPr lang="en-US" sz="900" dirty="0">
                           <a:solidFill>
                             <a:srgbClr val="17201B"/>
                           </a:solidFill>
                         </a:rPr>
-                        <a:t>per-line note</a:t>
+                        <a:t>obligations table, DPD column</a:t>
                       </a:r>
-                      <a:endParaRPr lang="en-US" sz="1000" dirty="0"/>
+                      <a:endParaRPr lang="en-US" sz="900" dirty="0"/>
                     </a:p>
                   </a:txBody>
                   <a:tcPr marL="91440" marR="91440" marT="45720" marB="45720">
@@ -4076,7 +4076,7 @@
                   </a:tcPr>
                 </a:tc>
               </a:tr>
-              <a:tr h="457200">
+              <a:tr h="384048">
                 <a:tc>
                   <a:txBody>
                     <a:bodyPr/>
@@ -4086,14 +4086,14 @@
                         <a:buNone/>
                       </a:pPr>
                       <a:r>
-                        <a:rPr lang="en-US" sz="1000" b="1" dirty="0">
+                        <a:rPr lang="en-US" sz="900" b="1" dirty="0">
                           <a:solidFill>
                             <a:srgbClr val="17201B"/>
                           </a:solidFill>
                         </a:rPr>
-                        <a:t>cl.6</a:t>
+                        <a:t>cl.4¹</a:t>
                       </a:r>
-                      <a:endParaRPr lang="en-US" sz="1000" dirty="0"/>
+                      <a:endParaRPr lang="en-US" sz="900" dirty="0"/>
                     </a:p>
                   </a:txBody>
                   <a:tcPr marL="91440" marR="91440" marT="45720" marB="45720">
@@ -4147,14 +4147,14 @@
                         <a:buNone/>
                       </a:pPr>
                       <a:r>
-                        <a:rPr lang="en-US" sz="1000" dirty="0">
+                        <a:rPr lang="en-US" sz="900" dirty="0">
                           <a:solidFill>
                             <a:srgbClr val="17201B"/>
                           </a:solidFill>
                         </a:rPr>
-                        <a:t>Calculation date within 10 calendar days of the loan date</a:t>
+                        <a:t>Terms over 36 months: total payments spread over 36 («барча тўловлар 36 ойга тенг миқдорда тақсимланади»); mortgages over 180 months spread over 180</a:t>
                       </a:r>
-                      <a:endParaRPr lang="en-US" sz="1000" dirty="0"/>
+                      <a:endParaRPr lang="en-US" sz="900" dirty="0"/>
                     </a:p>
                   </a:txBody>
                   <a:tcPr marL="91440" marR="91440" marT="45720" marB="45720">
@@ -4208,14 +4208,14 @@
                         <a:buNone/>
                       </a:pPr>
                       <a:r>
-                        <a:rPr lang="en-US" sz="1000" dirty="0">
+                        <a:rPr lang="en-US" sz="900" dirty="0">
                           <a:solidFill>
                             <a:srgbClr val="17201B"/>
                           </a:solidFill>
                         </a:rPr>
-                        <a:t>case date</a:t>
+                        <a:t>per-line note</a:t>
                       </a:r>
-                      <a:endParaRPr lang="en-US" sz="1000" dirty="0"/>
+                      <a:endParaRPr lang="en-US" sz="900" dirty="0"/>
                     </a:p>
                   </a:txBody>
                   <a:tcPr marL="91440" marR="91440" marT="45720" marB="45720">
@@ -4261,7 +4261,7 @@
                   </a:tcPr>
                 </a:tc>
               </a:tr>
-              <a:tr h="457200">
+              <a:tr h="384048">
                 <a:tc>
                   <a:txBody>
                     <a:bodyPr/>
@@ -4271,14 +4271,14 @@
                         <a:buNone/>
                       </a:pPr>
                       <a:r>
-                        <a:rPr lang="en-US" sz="1000" b="1" dirty="0">
+                        <a:rPr lang="en-US" sz="900" b="1" dirty="0">
                           <a:solidFill>
                             <a:srgbClr val="17201B"/>
                           </a:solidFill>
                         </a:rPr>
-                        <a:t>cl.7</a:t>
+                        <a:t>cl.6</a:t>
                       </a:r>
-                      <a:endParaRPr lang="en-US" sz="1000" dirty="0"/>
+                      <a:endParaRPr lang="en-US" sz="900" dirty="0"/>
                     </a:p>
                   </a:txBody>
                   <a:tcPr marL="91440" marR="91440" marT="45720" marB="45720">
@@ -4332,14 +4332,14 @@
                         <a:buNone/>
                       </a:pPr>
                       <a:r>
-                        <a:rPr lang="en-US" sz="1000" dirty="0">
+                        <a:rPr lang="en-US" sz="900" dirty="0">
                           <a:solidFill>
                             <a:srgbClr val="17201B"/>
                           </a:solidFill>
                         </a:rPr>
-                        <a:t>Average monthly income = arithmetic mean of the last 12 months; co-borrower income added</a:t>
+                        <a:t>Calculation date within 10 calendar days of the loan date</a:t>
                       </a:r>
-                      <a:endParaRPr lang="en-US" sz="1000" dirty="0"/>
+                      <a:endParaRPr lang="en-US" sz="900" dirty="0"/>
                     </a:p>
                   </a:txBody>
                   <a:tcPr marL="91440" marR="91440" marT="45720" marB="45720">
@@ -4393,14 +4393,14 @@
                         <a:buNone/>
                       </a:pPr>
                       <a:r>
-                        <a:rPr lang="en-US" sz="1000" dirty="0">
+                        <a:rPr lang="en-US" sz="900" dirty="0">
                           <a:solidFill>
                             <a:srgbClr val="17201B"/>
                           </a:solidFill>
                         </a:rPr>
-                        <a:t>income base</a:t>
+                        <a:t>case date</a:t>
                       </a:r>
-                      <a:endParaRPr lang="en-US" sz="1000" dirty="0"/>
+                      <a:endParaRPr lang="en-US" sz="900" dirty="0"/>
                     </a:p>
                   </a:txBody>
                   <a:tcPr marL="91440" marR="91440" marT="45720" marB="45720">
@@ -4446,7 +4446,7 @@
                   </a:tcPr>
                 </a:tc>
               </a:tr>
-              <a:tr h="457200">
+              <a:tr h="384048">
                 <a:tc>
                   <a:txBody>
                     <a:bodyPr/>
@@ -4456,14 +4456,14 @@
                         <a:buNone/>
                       </a:pPr>
                       <a:r>
-                        <a:rPr lang="en-US" sz="1000" b="1" dirty="0">
+                        <a:rPr lang="en-US" sz="900" b="1" dirty="0">
                           <a:solidFill>
                             <a:srgbClr val="17201B"/>
                           </a:solidFill>
                         </a:rPr>
-                        <a:t>cl.9</a:t>
+                        <a:t>cl.7</a:t>
                       </a:r>
-                      <a:endParaRPr lang="en-US" sz="1000" dirty="0"/>
+                      <a:endParaRPr lang="en-US" sz="900" dirty="0"/>
                     </a:p>
                   </a:txBody>
                   <a:tcPr marL="91440" marR="91440" marT="45720" marB="45720">
@@ -4517,14 +4517,14 @@
                         <a:buNone/>
                       </a:pPr>
                       <a:r>
-                        <a:rPr lang="en-US" sz="1000" dirty="0">
+                        <a:rPr lang="en-US" sz="900" dirty="0">
                           <a:solidFill>
                             <a:srgbClr val="17201B"/>
                           </a:solidFill>
                         </a:rPr>
-                        <a:t>Evidence: employer salary data, pension, funded-pension contributions, income credited to bank accounts, taxes paid, interest/dividends/rent; other data allowed</a:t>
+                        <a:t>Average monthly income = arithmetic mean of the last 12 months; co-borrower income added</a:t>
                       </a:r>
-                      <a:endParaRPr lang="en-US" sz="1000" dirty="0"/>
+                      <a:endParaRPr lang="en-US" sz="900" dirty="0"/>
                     </a:p>
                   </a:txBody>
                   <a:tcPr marL="91440" marR="91440" marT="45720" marB="45720">
@@ -4578,14 +4578,14 @@
                         <a:buNone/>
                       </a:pPr>
                       <a:r>
-                        <a:rPr lang="en-US" sz="1000" dirty="0">
+                        <a:rPr lang="en-US" sz="900" dirty="0">
                           <a:solidFill>
                             <a:srgbClr val="17201B"/>
                           </a:solidFill>
                         </a:rPr>
-                        <a:t>memo section 2</a:t>
+                        <a:t>income base</a:t>
                       </a:r>
-                      <a:endParaRPr lang="en-US" sz="1000" dirty="0"/>
+                      <a:endParaRPr lang="en-US" sz="900" dirty="0"/>
                     </a:p>
                   </a:txBody>
                   <a:tcPr marL="91440" marR="91440" marT="45720" marB="45720">
@@ -4631,7 +4631,7 @@
                   </a:tcPr>
                 </a:tc>
               </a:tr>
-              <a:tr h="457200">
+              <a:tr h="384048">
                 <a:tc>
                   <a:txBody>
                     <a:bodyPr/>
@@ -4641,14 +4641,14 @@
                         <a:buNone/>
                       </a:pPr>
                       <a:r>
-                        <a:rPr lang="en-US" sz="1000" b="1" dirty="0">
+                        <a:rPr lang="en-US" sz="900" b="1" dirty="0">
                           <a:solidFill>
                             <a:srgbClr val="17201B"/>
                           </a:solidFill>
                         </a:rPr>
-                        <a:t>cl.10</a:t>
+                        <a:t>cl.9</a:t>
                       </a:r>
-                      <a:endParaRPr lang="en-US" sz="1000" dirty="0"/>
+                      <a:endParaRPr lang="en-US" sz="900" dirty="0"/>
                     </a:p>
                   </a:txBody>
                   <a:tcPr marL="91440" marR="91440" marT="45720" marB="45720">
@@ -4702,14 +4702,14 @@
                         <a:buNone/>
                       </a:pPr>
                       <a:r>
-                        <a:rPr lang="en-US" sz="1000" dirty="0">
+                        <a:rPr lang="en-US" sz="900" dirty="0">
                           <a:solidFill>
                             <a:srgbClr val="17201B"/>
                           </a:solidFill>
                         </a:rPr>
-                        <a:t>Ratio ≤ 50% from 1 January 2025 (60% between 1 July 2024 and 1 January 2025)</a:t>
+                        <a:t>Evidence: employer salary data, pension, funded-pension contributions, income credited to bank accounts, taxes paid, interest/dividends/rent; other data allowed</a:t>
                       </a:r>
-                      <a:endParaRPr lang="en-US" sz="1000" dirty="0"/>
+                      <a:endParaRPr lang="en-US" sz="900" dirty="0"/>
                     </a:p>
                   </a:txBody>
                   <a:tcPr marL="91440" marR="91440" marT="45720" marB="45720">
@@ -4763,14 +4763,14 @@
                         <a:buNone/>
                       </a:pPr>
                       <a:r>
-                        <a:rPr lang="en-US" sz="1000" dirty="0">
+                        <a:rPr lang="en-US" sz="900" dirty="0">
                           <a:solidFill>
                             <a:srgbClr val="17201B"/>
                           </a:solidFill>
                         </a:rPr>
-                        <a:t>cap, pass/fail</a:t>
+                        <a:t>memo section 2</a:t>
                       </a:r>
-                      <a:endParaRPr lang="en-US" sz="1000" dirty="0"/>
+                      <a:endParaRPr lang="en-US" sz="900" dirty="0"/>
                     </a:p>
                   </a:txBody>
                   <a:tcPr marL="91440" marR="91440" marT="45720" marB="45720">
@@ -4816,7 +4816,7 @@
                   </a:tcPr>
                 </a:tc>
               </a:tr>
-              <a:tr h="457200">
+              <a:tr h="384048">
                 <a:tc>
                   <a:txBody>
                     <a:bodyPr/>
@@ -4826,14 +4826,14 @@
                         <a:buNone/>
                       </a:pPr>
                       <a:r>
-                        <a:rPr lang="en-US" sz="1000" b="1" dirty="0">
+                        <a:rPr lang="en-US" sz="900" b="1" dirty="0">
                           <a:solidFill>
                             <a:srgbClr val="17201B"/>
                           </a:solidFill>
                         </a:rPr>
-                        <a:t>cl.11</a:t>
+                        <a:t>cl.10</a:t>
                       </a:r>
-                      <a:endParaRPr lang="en-US" sz="1000" dirty="0"/>
+                      <a:endParaRPr lang="en-US" sz="900" dirty="0"/>
                     </a:p>
                   </a:txBody>
                   <a:tcPr marL="91440" marR="91440" marT="45720" marB="45720">
@@ -4887,14 +4887,14 @@
                         <a:buNone/>
                       </a:pPr>
                       <a:r>
-                        <a:rPr lang="en-US" sz="1000" dirty="0">
+                        <a:rPr lang="en-US" sz="900" dirty="0">
                           <a:solidFill>
                             <a:srgbClr val="17201B"/>
                           </a:solidFill>
                         </a:rPr>
-                        <a:t>Family-entrepreneurship programme loans exempt from the ratio requirement</a:t>
+                        <a:t>Ratio ≤ 50% from 1 January 2025 (60% between 1 July 2024 and 1 January 2025)</a:t>
                       </a:r>
-                      <a:endParaRPr lang="en-US" sz="1000" dirty="0"/>
+                      <a:endParaRPr lang="en-US" sz="900" dirty="0"/>
                     </a:p>
                   </a:txBody>
                   <a:tcPr marL="91440" marR="91440" marT="45720" marB="45720">
@@ -4948,14 +4948,199 @@
                         <a:buNone/>
                       </a:pPr>
                       <a:r>
-                        <a:rPr lang="en-US" sz="1000" dirty="0">
+                        <a:rPr lang="en-US" sz="900" dirty="0">
+                          <a:solidFill>
+                            <a:srgbClr val="17201B"/>
+                          </a:solidFill>
+                        </a:rPr>
+                        <a:t>cap, pass/fail</a:t>
+                      </a:r>
+                      <a:endParaRPr lang="en-US" sz="900" dirty="0"/>
+                    </a:p>
+                  </a:txBody>
+                  <a:tcPr marL="91440" marR="91440" marT="45720" marB="45720">
+                    <a:lnL w="6350" cap="flat" cmpd="sng" algn="ctr">
+                      <a:solidFill>
+                        <a:srgbClr val="E9F1EC"/>
+                      </a:solidFill>
+                      <a:prstDash val="solid"/>
+                      <a:round/>
+                      <a:headEnd type="none" w="med" len="med"/>
+                      <a:tailEnd type="none" w="med" len="med"/>
+                    </a:lnL>
+                    <a:lnR w="6350" cap="flat" cmpd="sng" algn="ctr">
+                      <a:solidFill>
+                        <a:srgbClr val="E9F1EC"/>
+                      </a:solidFill>
+                      <a:prstDash val="solid"/>
+                      <a:round/>
+                      <a:headEnd type="none" w="med" len="med"/>
+                      <a:tailEnd type="none" w="med" len="med"/>
+                    </a:lnR>
+                    <a:lnT w="6350" cap="flat" cmpd="sng" algn="ctr">
+                      <a:solidFill>
+                        <a:srgbClr val="E9F1EC"/>
+                      </a:solidFill>
+                      <a:prstDash val="solid"/>
+                      <a:round/>
+                      <a:headEnd type="none" w="med" len="med"/>
+                      <a:tailEnd type="none" w="med" len="med"/>
+                    </a:lnT>
+                    <a:lnB w="6350" cap="flat" cmpd="sng" algn="ctr">
+                      <a:solidFill>
+                        <a:srgbClr val="E9F1EC"/>
+                      </a:solidFill>
+                      <a:prstDash val="solid"/>
+                      <a:round/>
+                      <a:headEnd type="none" w="med" len="med"/>
+                      <a:tailEnd type="none" w="med" len="med"/>
+                    </a:lnB>
+                    <a:solidFill>
+                      <a:srgbClr val="E9F1EC"/>
+                    </a:solidFill>
+                  </a:tcPr>
+                </a:tc>
+              </a:tr>
+              <a:tr h="384048">
+                <a:tc>
+                  <a:txBody>
+                    <a:bodyPr/>
+                    <a:lstStyle/>
+                    <a:p>
+                      <a:pPr indent="0" marL="0">
+                        <a:buNone/>
+                      </a:pPr>
+                      <a:r>
+                        <a:rPr lang="en-US" sz="900" b="1" dirty="0">
+                          <a:solidFill>
+                            <a:srgbClr val="17201B"/>
+                          </a:solidFill>
+                        </a:rPr>
+                        <a:t>cl.11</a:t>
+                      </a:r>
+                      <a:endParaRPr lang="en-US" sz="900" dirty="0"/>
+                    </a:p>
+                  </a:txBody>
+                  <a:tcPr marL="91440" marR="91440" marT="45720" marB="45720">
+                    <a:lnL w="6350" cap="flat" cmpd="sng" algn="ctr">
+                      <a:solidFill>
+                        <a:srgbClr val="E9F1EC"/>
+                      </a:solidFill>
+                      <a:prstDash val="solid"/>
+                      <a:round/>
+                      <a:headEnd type="none" w="med" len="med"/>
+                      <a:tailEnd type="none" w="med" len="med"/>
+                    </a:lnL>
+                    <a:lnR w="6350" cap="flat" cmpd="sng" algn="ctr">
+                      <a:solidFill>
+                        <a:srgbClr val="E9F1EC"/>
+                      </a:solidFill>
+                      <a:prstDash val="solid"/>
+                      <a:round/>
+                      <a:headEnd type="none" w="med" len="med"/>
+                      <a:tailEnd type="none" w="med" len="med"/>
+                    </a:lnR>
+                    <a:lnT w="6350" cap="flat" cmpd="sng" algn="ctr">
+                      <a:solidFill>
+                        <a:srgbClr val="E9F1EC"/>
+                      </a:solidFill>
+                      <a:prstDash val="solid"/>
+                      <a:round/>
+                      <a:headEnd type="none" w="med" len="med"/>
+                      <a:tailEnd type="none" w="med" len="med"/>
+                    </a:lnT>
+                    <a:lnB w="6350" cap="flat" cmpd="sng" algn="ctr">
+                      <a:solidFill>
+                        <a:srgbClr val="E9F1EC"/>
+                      </a:solidFill>
+                      <a:prstDash val="solid"/>
+                      <a:round/>
+                      <a:headEnd type="none" w="med" len="med"/>
+                      <a:tailEnd type="none" w="med" len="med"/>
+                    </a:lnB>
+                    <a:solidFill>
+                      <a:srgbClr val="FFFFFF"/>
+                    </a:solidFill>
+                  </a:tcPr>
+                </a:tc>
+                <a:tc>
+                  <a:txBody>
+                    <a:bodyPr/>
+                    <a:lstStyle/>
+                    <a:p>
+                      <a:pPr indent="0" marL="0">
+                        <a:buNone/>
+                      </a:pPr>
+                      <a:r>
+                        <a:rPr lang="en-US" sz="900" dirty="0">
+                          <a:solidFill>
+                            <a:srgbClr val="17201B"/>
+                          </a:solidFill>
+                        </a:rPr>
+                        <a:t>Family-entrepreneurship programme loans exempt from the ratio requirement</a:t>
+                      </a:r>
+                      <a:endParaRPr lang="en-US" sz="900" dirty="0"/>
+                    </a:p>
+                  </a:txBody>
+                  <a:tcPr marL="91440" marR="91440" marT="45720" marB="45720">
+                    <a:lnL w="6350" cap="flat" cmpd="sng" algn="ctr">
+                      <a:solidFill>
+                        <a:srgbClr val="E9F1EC"/>
+                      </a:solidFill>
+                      <a:prstDash val="solid"/>
+                      <a:round/>
+                      <a:headEnd type="none" w="med" len="med"/>
+                      <a:tailEnd type="none" w="med" len="med"/>
+                    </a:lnL>
+                    <a:lnR w="6350" cap="flat" cmpd="sng" algn="ctr">
+                      <a:solidFill>
+                        <a:srgbClr val="E9F1EC"/>
+                      </a:solidFill>
+                      <a:prstDash val="solid"/>
+                      <a:round/>
+                      <a:headEnd type="none" w="med" len="med"/>
+                      <a:tailEnd type="none" w="med" len="med"/>
+                    </a:lnR>
+                    <a:lnT w="6350" cap="flat" cmpd="sng" algn="ctr">
+                      <a:solidFill>
+                        <a:srgbClr val="E9F1EC"/>
+                      </a:solidFill>
+                      <a:prstDash val="solid"/>
+                      <a:round/>
+                      <a:headEnd type="none" w="med" len="med"/>
+                      <a:tailEnd type="none" w="med" len="med"/>
+                    </a:lnT>
+                    <a:lnB w="6350" cap="flat" cmpd="sng" algn="ctr">
+                      <a:solidFill>
+                        <a:srgbClr val="E9F1EC"/>
+                      </a:solidFill>
+                      <a:prstDash val="solid"/>
+                      <a:round/>
+                      <a:headEnd type="none" w="med" len="med"/>
+                      <a:tailEnd type="none" w="med" len="med"/>
+                    </a:lnB>
+                    <a:solidFill>
+                      <a:srgbClr val="FFFFFF"/>
+                    </a:solidFill>
+                  </a:tcPr>
+                </a:tc>
+                <a:tc>
+                  <a:txBody>
+                    <a:bodyPr/>
+                    <a:lstStyle/>
+                    <a:p>
+                      <a:pPr indent="0" marL="0">
+                        <a:buNone/>
+                      </a:pPr>
+                      <a:r>
+                        <a:rPr lang="en-US" sz="900" dirty="0">
                           <a:solidFill>
                             <a:srgbClr val="17201B"/>
                           </a:solidFill>
                         </a:rPr>
                         <a:t>exemption badge</a:t>
                       </a:r>
-                      <a:endParaRPr lang="en-US" sz="1000" dirty="0"/>
+                      <a:endParaRPr lang="en-US" sz="900" dirty="0"/>
                     </a:p>
                   </a:txBody>
                   <a:tcPr marL="91440" marR="91440" marT="45720" marB="45720">
@@ -4996,7 +5181,7 @@
                       <a:tailEnd type="none" w="med" len="med"/>
                     </a:lnB>
                     <a:solidFill>
-                      <a:srgbClr val="E9F1EC"/>
+                      <a:srgbClr val="FFFFFF"/>
                     </a:solidFill>
                   </a:tcPr>
                 </a:tc>
@@ -5014,7 +5199,7 @@
         <p:spPr>
           <a:xfrm>
             <a:off x="548640" y="5989320"/>
-            <a:ext cx="10972800" cy="274320"/>
+            <a:ext cx="10972800" cy="365760"/>
           </a:xfrm>
           <a:prstGeom prst="rect">
             <a:avLst/>
@@ -5035,7 +5220,7 @@
                   <a:srgbClr val="5C6B63"/>
                 </a:solidFill>
               </a:rPr>
-              <a:t>BRV (базовая расчётная величина) is a configuration value; update from lex.uz. Verified 10 Oct 2026.</a:t>
+              <a:t>BRV = 440,000 UZS from 1 September 2026 (previously 412,000); 50 BRV = 22,000,000 UZS. Clause mapping checked against lex.uz/docs/4654149 and 6809992 on 10 Oct 2026; quotes verbatim in docs/REGULATION_QUOTES.md.</a:t>
             </a:r>
             <a:endParaRPr lang="en-US" sz="900" dirty="0"/>
           </a:p>
@@ -7410,12 +7595,23 @@
               <a:buNone/>
             </a:pPr>
             <a:r>
+              <a:rPr lang="en-US" sz="1200" b="1" dirty="0">
+                <a:solidFill>
+                  <a:srgbClr val="17201B"/>
+                </a:solidFill>
+              </a:rPr>
+              <a:t>Employer-confirmed salary</a:t>
+            </a:r>
+            <a:pPr indent="0" marL="0">
+              <a:buNone/>
+            </a:pPr>
+            <a:r>
               <a:rPr lang="en-US" sz="1200" dirty="0">
                 <a:solidFill>
                   <a:srgbClr val="17201B"/>
                 </a:solidFill>
               </a:rPr>
-              <a:t>Employer-confirmed salary  — does not exist: income untaxed, no returns, no receipts required</a:t>
+              <a:t>  — no employer — the borrower is the business</a:t>
             </a:r>
             <a:endParaRPr lang="en-US" sz="1200" dirty="0"/>
           </a:p>
@@ -7497,12 +7693,23 @@
               <a:buNone/>
             </a:pPr>
             <a:r>
+              <a:rPr lang="en-US" sz="1200" b="1" dirty="0">
+                <a:solidFill>
+                  <a:srgbClr val="17201B"/>
+                </a:solidFill>
+              </a:rPr>
+              <a:t>Pension</a:t>
+            </a:r>
+            <a:pPr indent="0" marL="0">
+              <a:buNone/>
+            </a:pPr>
+            <a:r>
               <a:rPr lang="en-US" sz="1200" dirty="0">
                 <a:solidFill>
                   <a:srgbClr val="17201B"/>
                 </a:solidFill>
               </a:rPr>
-              <a:t>Pension  — does not exist: income untaxed, no returns, no receipts required</a:t>
+              <a:t>  — working-age applicant, not a pensioner</a:t>
             </a:r>
             <a:endParaRPr lang="en-US" sz="1200" dirty="0"/>
           </a:p>
@@ -7584,12 +7791,23 @@
               <a:buNone/>
             </a:pPr>
             <a:r>
+              <a:rPr lang="en-US" sz="1200" b="1" dirty="0">
+                <a:solidFill>
+                  <a:srgbClr val="17201B"/>
+                </a:solidFill>
+              </a:rPr>
+              <a:t>Funded-pension contributions</a:t>
+            </a:r>
+            <a:pPr indent="0" marL="0">
+              <a:buNone/>
+            </a:pPr>
+            <a:r>
               <a:rPr lang="en-US" sz="1200" dirty="0">
                 <a:solidFill>
                   <a:srgbClr val="17201B"/>
                 </a:solidFill>
               </a:rPr>
-              <a:t>Funded-pension contributions  — does not exist: income untaxed, no returns, no receipts required</a:t>
+              <a:t>  — none: contributions come through an employer</a:t>
             </a:r>
             <a:endParaRPr lang="en-US" sz="1200" dirty="0"/>
           </a:p>
@@ -7671,14 +7889,25 @@
               <a:buNone/>
             </a:pPr>
             <a:r>
-              <a:rPr lang="en-US" sz="1400" b="1" dirty="0">
+              <a:rPr lang="en-US" sz="1350" b="1" dirty="0">
                 <a:solidFill>
                   <a:srgbClr val="17201B"/>
                 </a:solidFill>
               </a:rPr>
-              <a:t>Income credited to the borrower's bank accounts  — the only one a self-employed borrower has</a:t>
-            </a:r>
-            <a:endParaRPr lang="en-US" sz="1400" dirty="0"/>
+              <a:t>Income credited to the borrower's bank accounts</a:t>
+            </a:r>
+            <a:pPr indent="0" marL="0">
+              <a:buNone/>
+            </a:pPr>
+            <a:r>
+              <a:rPr lang="en-US" sz="1350" dirty="0">
+                <a:solidFill>
+                  <a:srgbClr val="17201B"/>
+                </a:solidFill>
+              </a:rPr>
+              <a:t>  — the only line a self-employed borrower has</a:t>
+            </a:r>
+            <a:endParaRPr lang="en-US" sz="1350" dirty="0"/>
           </a:p>
         </p:txBody>
       </p:sp>
@@ -7758,12 +7987,23 @@
               <a:buNone/>
             </a:pPr>
             <a:r>
+              <a:rPr lang="en-US" sz="1200" b="1" dirty="0">
+                <a:solidFill>
+                  <a:srgbClr val="17201B"/>
+                </a:solidFill>
+              </a:rPr>
+              <a:t>Taxes paid</a:t>
+            </a:r>
+            <a:pPr indent="0" marL="0">
+              <a:buNone/>
+            </a:pPr>
+            <a:r>
               <a:rPr lang="en-US" sz="1200" dirty="0">
                 <a:solidFill>
                   <a:srgbClr val="17201B"/>
                 </a:solidFill>
               </a:rPr>
-              <a:t>Taxes paid  — does not exist: income untaxed, no returns, no receipts required</a:t>
+              <a:t>  — self-employed income is untaxed; no return is filed</a:t>
             </a:r>
             <a:endParaRPr lang="en-US" sz="1200" dirty="0"/>
           </a:p>
@@ -7845,12 +8085,23 @@
               <a:buNone/>
             </a:pPr>
             <a:r>
+              <a:rPr lang="en-US" sz="1200" b="1" dirty="0">
+                <a:solidFill>
+                  <a:srgbClr val="17201B"/>
+                </a:solidFill>
+              </a:rPr>
+              <a:t>Interest, dividends, rental income</a:t>
+            </a:r>
+            <a:pPr indent="0" marL="0">
+              <a:buNone/>
+            </a:pPr>
+            <a:r>
               <a:rPr lang="en-US" sz="1200" dirty="0">
                 <a:solidFill>
                   <a:srgbClr val="17201B"/>
                 </a:solidFill>
               </a:rPr>
-              <a:t>Interest, dividends, rental income  — does not exist: income untaxed, no returns, no receipts required</a:t>
+              <a:t>  — rarely applicable; easy to document when it is</a:t>
             </a:r>
             <a:endParaRPr lang="en-US" sz="1200" dirty="0"/>
           </a:p>
@@ -8155,7 +8406,7 @@
       </p:sp>
       <p:sp>
         <p:nvSpPr>
-          <p:cNvPr id="32" name="tile of official income records for ~790k registered self-employed (untaxed, unfiled)"/>
+          <p:cNvPr id="32" name="tile of official income records for ~790k registered self-employed (untaxed, unfiled, no cash register required)"/>
           <p:cNvSpPr/>
           <p:nvPr/>
         </p:nvSpPr>
@@ -8182,7 +8433,7 @@
       </p:sp>
       <p:sp>
         <p:nvSpPr>
-          <p:cNvPr id="33" name="tile value of official income records for ~790k registered self-employed (untaxed, unfiled)"/>
+          <p:cNvPr id="33" name="tile value of official income records for ~790k registered self-employed (untaxed, unfiled, no cash register required)"/>
           <p:cNvSpPr txBox="1"/>
           <p:nvPr/>
         </p:nvSpPr>
@@ -8218,7 +8469,7 @@
       </p:sp>
       <p:sp>
         <p:nvSpPr>
-          <p:cNvPr id="34" name="tile label of official income records for ~790k registered self-employed (untaxed, unfiled)"/>
+          <p:cNvPr id="34" name="tile label of official income records for ~790k registered self-employed (untaxed, unfiled, no cash register required)"/>
           <p:cNvSpPr txBox="1"/>
           <p:nvPr/>
         </p:nvSpPr>
@@ -8246,7 +8497,7 @@
                   <a:srgbClr val="5C6B63"/>
                 </a:solidFill>
               </a:rPr>
-              <a:t>of official income records for ~790k registered self-employed (untaxed, unfiled)</a:t>
+              <a:t>of official income records for ~790k registered self-employed (untaxed, unfiled, no cash register required)</a:t>
             </a:r>
             <a:endParaRPr lang="en-US" sz="1100" dirty="0"/>
           </a:p>
@@ -8922,7 +9173,7 @@
                   <a:srgbClr val="17201B"/>
                 </a:solidFill>
               </a:rPr>
-              <a:t>every number traceable to a document line; the verifier refuses unsourced numbers; hash-chained audit log</a:t>
+              <a:t>every number traces to its source — statement lines (click to open them), a clause, or the model; the verifier refuses unsourced numbers; hash-chained audit log</a:t>
             </a:r>
             <a:endParaRPr lang="en-US" sz="1050" dirty="0"/>
           </a:p>
@@ -10816,7 +11067,7 @@
       </p:sp>
       <p:sp>
         <p:nvSpPr>
-          <p:cNvPr id="4" name="tile statement PDFs parsed with exact row count and reconciled balance chain (2 layouts, RU/UZ)"/>
+          <p:cNvPr id="4" name="tile generator statement PDFs parsed with exact row count and reconciled balance chain (2 layouts, RU/UZ)"/>
           <p:cNvSpPr/>
           <p:nvPr/>
         </p:nvSpPr>
@@ -10843,7 +11094,7 @@
       </p:sp>
       <p:sp>
         <p:nvSpPr>
-          <p:cNvPr id="5" name="tile value statement PDFs parsed with exact row count and reconciled balance chain (2 layouts, RU/UZ)"/>
+          <p:cNvPr id="5" name="tile value generator statement PDFs parsed with exact row count and reconciled balance chain (2 layouts, RU/UZ)"/>
           <p:cNvSpPr txBox="1"/>
           <p:nvPr/>
         </p:nvSpPr>
@@ -10879,7 +11130,7 @@
       </p:sp>
       <p:sp>
         <p:nvSpPr>
-          <p:cNvPr id="6" name="tile label statement PDFs parsed with exact row count and reconciled balance chain (2 layouts, RU/UZ)"/>
+          <p:cNvPr id="6" name="tile label generator statement PDFs parsed with exact row count and reconciled balance chain (2 layouts, RU/UZ)"/>
           <p:cNvSpPr txBox="1"/>
           <p:nvPr/>
         </p:nvSpPr>
@@ -10907,7 +11158,7 @@
                   <a:srgbClr val="5C6B63"/>
                 </a:solidFill>
               </a:rPr>
-              <a:t>statement PDFs parsed with exact row count and reconciled balance chain (2 layouts, RU/UZ)</a:t>
+              <a:t>generator statement PDFs parsed with exact row count and reconciled balance chain (2 layouts, RU/UZ)</a:t>
             </a:r>
             <a:endParaRPr lang="en-US" sz="950" dirty="0"/>
           </a:p>
@@ -10915,7 +11166,7 @@
       </p:sp>
       <p:sp>
         <p:nvSpPr>
-          <p:cNvPr id="7" name="tile tampered statements caught: inflated inflow, deleted debit, duplicated row, window dressing"/>
+          <p:cNvPr id="7" name="tile unseen layouts exact: signed-amount CSV, Kirim/Chiqim XLSX, quoted EN CSV + type column, Unicode minus, headerless, Приход/Расход TSV"/>
           <p:cNvSpPr/>
           <p:nvPr/>
         </p:nvSpPr>
@@ -10942,7 +11193,7 @@
       </p:sp>
       <p:sp>
         <p:nvSpPr>
-          <p:cNvPr id="8" name="tile value tampered statements caught: inflated inflow, deleted debit, duplicated row, window dressing"/>
+          <p:cNvPr id="8" name="tile value unseen layouts exact: signed-amount CSV, Kirim/Chiqim XLSX, quoted EN CSV + type column, Unicode minus, headerless, Приход/Расход TSV"/>
           <p:cNvSpPr txBox="1"/>
           <p:nvPr/>
         </p:nvSpPr>
@@ -10970,7 +11221,7 @@
                   <a:srgbClr val="1F4E3D"/>
                 </a:solidFill>
               </a:rPr>
-              <a:t>40/40</a:t>
+              <a:t>6/6</a:t>
             </a:r>
             <a:endParaRPr lang="en-US" sz="2600" dirty="0"/>
           </a:p>
@@ -10978,7 +11229,7 @@
       </p:sp>
       <p:sp>
         <p:nvSpPr>
-          <p:cNvPr id="9" name="tile label tampered statements caught: inflated inflow, deleted debit, duplicated row, window dressing"/>
+          <p:cNvPr id="9" name="tile label unseen layouts exact: signed-amount CSV, Kirim/Chiqim XLSX, quoted EN CSV + type column, Unicode minus, headerless, Приход/Расход TSV"/>
           <p:cNvSpPr txBox="1"/>
           <p:nvPr/>
         </p:nvSpPr>
@@ -11006,7 +11257,7 @@
                   <a:srgbClr val="5C6B63"/>
                 </a:solidFill>
               </a:rPr>
-              <a:t>tampered statements caught: inflated inflow, deleted debit, duplicated row, window dressing</a:t>
+              <a:t>unseen layouts exact: signed-amount CSV, Kirim/Chiqim XLSX, quoted EN CSV + type column, Unicode minus, headerless, Приход/Расход TSV</a:t>
             </a:r>
             <a:endParaRPr lang="en-US" sz="950" dirty="0"/>
           </a:p>
@@ -11014,7 +11265,7 @@
       </p:sp>
       <p:sp>
         <p:nvSpPr>
-          <p:cNvPr id="10" name="tile receipt OCR — total amount exact on 60 camera-augmented photos; INN 100%, date 97%"/>
+          <p:cNvPr id="10" name="tile tampered statements caught: inflated inflow, deleted debit, duplicated row, window dressing; 0 false alarms on clean ones"/>
           <p:cNvSpPr/>
           <p:nvPr/>
         </p:nvSpPr>
@@ -11041,7 +11292,7 @@
       </p:sp>
       <p:sp>
         <p:nvSpPr>
-          <p:cNvPr id="11" name="tile value receipt OCR — total amount exact on 60 camera-augmented photos; INN 100%, date 97%"/>
+          <p:cNvPr id="11" name="tile value tampered statements caught: inflated inflow, deleted debit, duplicated row, window dressing; 0 false alarms on clean ones"/>
           <p:cNvSpPr txBox="1"/>
           <p:nvPr/>
         </p:nvSpPr>
@@ -11069,7 +11320,7 @@
                   <a:srgbClr val="1F4E3D"/>
                 </a:solidFill>
               </a:rPr>
-              <a:t>95%</a:t>
+              <a:t>40/40</a:t>
             </a:r>
             <a:endParaRPr lang="en-US" sz="2600" dirty="0"/>
           </a:p>
@@ -11077,7 +11328,7 @@
       </p:sp>
       <p:sp>
         <p:nvSpPr>
-          <p:cNvPr id="12" name="tile label receipt OCR — total amount exact on 60 camera-augmented photos; INN 100%, date 97%"/>
+          <p:cNvPr id="12" name="tile label tampered statements caught: inflated inflow, deleted debit, duplicated row, window dressing; 0 false alarms on clean ones"/>
           <p:cNvSpPr txBox="1"/>
           <p:nvPr/>
         </p:nvSpPr>
@@ -11105,7 +11356,7 @@
                   <a:srgbClr val="5C6B63"/>
                 </a:solidFill>
               </a:rPr>
-              <a:t>receipt OCR — total amount exact on 60 camera-augmented photos; INN 100%, date 97%</a:t>
+              <a:t>tampered statements caught: inflated inflow, deleted debit, duplicated row, window dressing; 0 false alarms on clean ones</a:t>
             </a:r>
             <a:endParaRPr lang="en-US" sz="950" dirty="0"/>
           </a:p>
@@ -11113,7 +11364,7 @@
       </p:sp>
       <p:sp>
         <p:nvSpPr>
-          <p:cNvPr id="13" name="tile categoriser vs ground truth on 10,481 lines — synthetic vocabulary; expect lower on real data"/>
+          <p:cNvPr id="13" name="tile receipt OCR — total exact on 60 camera-augmented photos; INN 100%, date 97%"/>
           <p:cNvSpPr/>
           <p:nvPr/>
         </p:nvSpPr>
@@ -11140,7 +11391,7 @@
       </p:sp>
       <p:sp>
         <p:nvSpPr>
-          <p:cNvPr id="14" name="tile value categoriser vs ground truth on 10,481 lines — synthetic vocabulary; expect lower on real data"/>
+          <p:cNvPr id="14" name="tile value receipt OCR — total exact on 60 camera-augmented photos; INN 100%, date 97%"/>
           <p:cNvSpPr txBox="1"/>
           <p:nvPr/>
         </p:nvSpPr>
@@ -11168,7 +11419,7 @@
                   <a:srgbClr val="1F4E3D"/>
                 </a:solidFill>
               </a:rPr>
-              <a:t>99.96%</a:t>
+              <a:t>95%</a:t>
             </a:r>
             <a:endParaRPr lang="en-US" sz="2600" dirty="0"/>
           </a:p>
@@ -11176,7 +11427,7 @@
       </p:sp>
       <p:sp>
         <p:nvSpPr>
-          <p:cNvPr id="15" name="tile label categoriser vs ground truth on 10,481 lines — synthetic vocabulary; expect lower on real data"/>
+          <p:cNvPr id="15" name="tile label receipt OCR — total exact on 60 camera-augmented photos; INN 100%, date 97%"/>
           <p:cNvSpPr txBox="1"/>
           <p:nvPr/>
         </p:nvSpPr>
@@ -11204,7 +11455,7 @@
                   <a:srgbClr val="5C6B63"/>
                 </a:solidFill>
               </a:rPr>
-              <a:t>categoriser vs ground truth on 10,481 lines — synthetic vocabulary; expect lower on real data</a:t>
+              <a:t>receipt OCR — total exact on 60 camera-augmented photos; INN 100%, date 97%</a:t>
             </a:r>
             <a:endParaRPr lang="en-US" sz="950" dirty="0"/>
           </a:p>
@@ -11311,7 +11562,7 @@
       </p:sp>
       <p:sp>
         <p:nvSpPr>
-          <p:cNvPr id="19" name="tile ROC-AUC on real anonymised bank data (Berka, 443 loans, 5-fold) vs 0.735 for the ratio alone"/>
+          <p:cNvPr id="19" name="tile ROC-AUC on real bank data (Berka, 443 loans, 44 bad, 5-fold; 95% CI ≈ 0.86–0.94) vs 0.735 for the ratio alone"/>
           <p:cNvSpPr/>
           <p:nvPr/>
         </p:nvSpPr>
@@ -11338,7 +11589,7 @@
       </p:sp>
       <p:sp>
         <p:nvSpPr>
-          <p:cNvPr id="20" name="tile value ROC-AUC on real anonymised bank data (Berka, 443 loans, 5-fold) vs 0.735 for the ratio alone"/>
+          <p:cNvPr id="20" name="tile value ROC-AUC on real bank data (Berka, 443 loans, 44 bad, 5-fold; 95% CI ≈ 0.86–0.94) vs 0.735 for the ratio alone"/>
           <p:cNvSpPr txBox="1"/>
           <p:nvPr/>
         </p:nvSpPr>
@@ -11374,7 +11625,7 @@
       </p:sp>
       <p:sp>
         <p:nvSpPr>
-          <p:cNvPr id="21" name="tile label ROC-AUC on real anonymised bank data (Berka, 443 loans, 5-fold) vs 0.735 for the ratio alone"/>
+          <p:cNvPr id="21" name="tile label ROC-AUC on real bank data (Berka, 443 loans, 44 bad, 5-fold; 95% CI ≈ 0.86–0.94) vs 0.735 for the ratio alone"/>
           <p:cNvSpPr txBox="1"/>
           <p:nvPr/>
         </p:nvSpPr>
@@ -11402,7 +11653,7 @@
                   <a:srgbClr val="8FB8A5"/>
                 </a:solidFill>
               </a:rPr>
-              <a:t>ROC-AUC on real anonymised bank data (Berka, 443 loans, 5-fold) vs 0.735 for the ratio alone</a:t>
+              <a:t>ROC-AUC on real bank data (Berka, 443 loans, 44 bad, 5-fold; 95% CI ≈ 0.86–0.94) vs 0.735 for the ratio alone</a:t>
             </a:r>
             <a:endParaRPr lang="en-US" sz="950" dirty="0"/>
           </a:p>
@@ -11433,7 +11684,7 @@
         <p:spPr>
           <a:xfrm>
             <a:off x="548640" y="4343400"/>
-            <a:ext cx="6583680" cy="822960"/>
+            <a:ext cx="6583680" cy="914400"/>
           </a:xfrm>
           <a:prstGeom prst="rect">
             <a:avLst/>
@@ -11449,14 +11700,14 @@
               <a:buNone/>
             </a:pPr>
             <a:r>
-              <a:rPr lang="en-US" sz="1100" dirty="0">
+              <a:rPr lang="en-US" sz="1000" dirty="0">
                 <a:solidFill>
                   <a:srgbClr val="17201B"/>
                 </a:solidFill>
               </a:rPr>
-              <a:t>Honest reading: on synthetic data the ratio already carries most of the signal by construction; on real statements the cash-flow features add +0.17 AUC over the ratio. Memo faithfulness: 0 unsourced numbers on every sample case (enforced at run time).</a:t>
-            </a:r>
-            <a:endParaRPr lang="en-US" sz="1100" dirty="0"/>
+              <a:t>Honest reading: on synthetic data the ratio already carries most of the signal by construction; on real statements the cash-flow features add +0.17 AUC over the ratio, and logistic regression comes close to the trees — we ship the trees for the monotone constraints and non-linear thresholds, not for the last 0.01. Categoriser: 99.96% on 10,481 lines of the generator's own vocabulary — will fall on real data. Memo verifier: 0 unsourced numbers across a 300-scenario sweep (amounts × terms × products × borrowers), enforced at run time.</a:t>
+            </a:r>
+            <a:endParaRPr lang="en-US" sz="1000" dirty="0"/>
           </a:p>
         </p:txBody>
       </p:sp>
@@ -11476,8 +11727,8 @@
         </p:blipFill>
         <p:spPr>
           <a:xfrm>
-            <a:off x="548640" y="5120640"/>
-            <a:ext cx="6583680" cy="1234440"/>
+            <a:off x="548640" y="5257800"/>
+            <a:ext cx="5852160" cy="1097280"/>
           </a:xfrm>
           <a:prstGeom prst="rect">
             <a:avLst/>
@@ -14060,7 +14311,7 @@
       </p:sp>
       <p:sp>
         <p:nvSpPr>
-          <p:cNvPr id="9" name="tile document handling per application, before → with Daromad (assumption; pilot measures it)"/>
+          <p:cNvPr id="9" name="tile document handling per application, before → with Daromad (assumption 1; the pilot measures it)"/>
           <p:cNvSpPr/>
           <p:nvPr/>
         </p:nvSpPr>
@@ -14087,7 +14338,7 @@
       </p:sp>
       <p:sp>
         <p:nvSpPr>
-          <p:cNvPr id="10" name="tile value document handling per application, before → with Daromad (assumption; pilot measures it)"/>
+          <p:cNvPr id="10" name="tile value document handling per application, before → with Daromad (assumption 1; the pilot measures it)"/>
           <p:cNvSpPr txBox="1"/>
           <p:nvPr/>
         </p:nvSpPr>
@@ -14123,7 +14374,7 @@
       </p:sp>
       <p:sp>
         <p:nvSpPr>
-          <p:cNvPr id="11" name="tile label document handling per application, before → with Daromad (assumption; pilot measures it)"/>
+          <p:cNvPr id="11" name="tile label document handling per application, before → with Daromad (assumption 1; the pilot measures it)"/>
           <p:cNvSpPr txBox="1"/>
           <p:nvPr/>
         </p:nvSpPr>
@@ -14151,7 +14402,7 @@
                   <a:srgbClr val="5C6B63"/>
                 </a:solidFill>
               </a:rPr>
-              <a:t>document handling per application, before → with Daromad (assumption; pilot measures it)</a:t>
+              <a:t>document handling per application, before → with Daromad (assumption 1; the pilot measures it)</a:t>
             </a:r>
             <a:endParaRPr lang="en-US" sz="950" dirty="0"/>
           </a:p>
@@ -14159,7 +14410,7 @@
       </p:sp>
       <p:sp>
         <p:nvSpPr>
-          <p:cNvPr id="12" name="tile micro-project applications per year — MKBANK's own 2026 target"/>
+          <p:cNvPr id="12" name="tile addressable applications: 30% of MKBANK's 140,000 micro-projects (bank's own 2026 target) — those outside the family programme and above 50 BRV (assumption 2)"/>
           <p:cNvSpPr/>
           <p:nvPr/>
         </p:nvSpPr>
@@ -14186,7 +14437,7 @@
       </p:sp>
       <p:sp>
         <p:nvSpPr>
-          <p:cNvPr id="13" name="tile value micro-project applications per year — MKBANK&amp;apos;s own 2026 target"/>
+          <p:cNvPr id="13" name="tile value addressable applications: 30% of MKBANK&amp;apos;s 140,000 micro-projects (bank&amp;apos;s own 2026 target) — those outside the family programme and above 50 BRV (assumption 2)"/>
           <p:cNvSpPr txBox="1"/>
           <p:nvPr/>
         </p:nvSpPr>
@@ -14214,7 +14465,7 @@
                   <a:srgbClr val="1F4E3D"/>
                 </a:solidFill>
               </a:rPr>
-              <a:t>140,000</a:t>
+              <a:t>≈ 42,000 / yr</a:t>
             </a:r>
             <a:endParaRPr lang="en-US" sz="2200" dirty="0"/>
           </a:p>
@@ -14222,7 +14473,7 @@
       </p:sp>
       <p:sp>
         <p:nvSpPr>
-          <p:cNvPr id="14" name="tile label micro-project applications per year — MKBANK&amp;apos;s own 2026 target"/>
+          <p:cNvPr id="14" name="tile label addressable applications: 30% of MKBANK&amp;apos;s 140,000 micro-projects (bank&amp;apos;s own 2026 target) — those outside the family programme and above 50 BRV (assumption 2)"/>
           <p:cNvSpPr txBox="1"/>
           <p:nvPr/>
         </p:nvSpPr>
@@ -14245,20 +14496,20 @@
               <a:buNone/>
             </a:pPr>
             <a:r>
-              <a:rPr lang="en-US" sz="950" dirty="0">
+              <a:rPr lang="en-US" sz="850" dirty="0">
                 <a:solidFill>
                   <a:srgbClr val="5C6B63"/>
                 </a:solidFill>
               </a:rPr>
-              <a:t>micro-project applications per year — MKBANK's own 2026 target</a:t>
-            </a:r>
-            <a:endParaRPr lang="en-US" sz="950" dirty="0"/>
-          </a:p>
-        </p:txBody>
-      </p:sp>
-      <p:sp>
-        <p:nvSpPr>
-          <p:cNvPr id="15" name="tile officer-hours saved per year = 140,000 × 65 min"/>
+              <a:t>addressable applications: 30% of MKBANK's 140,000 micro-projects (bank's own 2026 target) — those outside the family programme and above 50 BRV (assumption 2)</a:t>
+            </a:r>
+            <a:endParaRPr lang="en-US" sz="850" dirty="0"/>
+          </a:p>
+        </p:txBody>
+      </p:sp>
+      <p:sp>
+        <p:nvSpPr>
+          <p:cNvPr id="15" name="tile officer-hours saved per year = 42,000 × 65 min ≈ 23 FTE-years at 2,000 h"/>
           <p:cNvSpPr/>
           <p:nvPr/>
         </p:nvSpPr>
@@ -14285,7 +14536,7 @@
       </p:sp>
       <p:sp>
         <p:nvSpPr>
-          <p:cNvPr id="16" name="tile value officer-hours saved per year = 140,000 × 65 min"/>
+          <p:cNvPr id="16" name="tile value officer-hours saved per year = 42,000 × 65 min ≈ 23 FTE-years at 2,000 h"/>
           <p:cNvSpPr txBox="1"/>
           <p:nvPr/>
         </p:nvSpPr>
@@ -14313,7 +14564,7 @@
                   <a:srgbClr val="FFFFFF"/>
                 </a:solidFill>
               </a:rPr>
-              <a:t>≈ 150,000 h</a:t>
+              <a:t>≈ 45,000 h</a:t>
             </a:r>
             <a:endParaRPr lang="en-US" sz="2200" dirty="0"/>
           </a:p>
@@ -14321,7 +14572,7 @@
       </p:sp>
       <p:sp>
         <p:nvSpPr>
-          <p:cNvPr id="17" name="tile label officer-hours saved per year = 140,000 × 65 min"/>
+          <p:cNvPr id="17" name="tile label officer-hours saved per year = 42,000 × 65 min ≈ 23 FTE-years at 2,000 h"/>
           <p:cNvSpPr txBox="1"/>
           <p:nvPr/>
         </p:nvSpPr>
@@ -14349,7 +14600,7 @@
                   <a:srgbClr val="8FB8A5"/>
                 </a:solidFill>
               </a:rPr>
-              <a:t>officer-hours saved per year = 140,000 × 65 min</a:t>
+              <a:t>officer-hours saved per year = 42,000 × 65 min ≈ 23 FTE-years at 2,000 h</a:t>
             </a:r>
             <a:endParaRPr lang="en-US" sz="950" dirty="0"/>
           </a:p>
@@ -14357,7 +14608,7 @@
       </p:sp>
       <p:sp>
         <p:nvSpPr>
-          <p:cNvPr id="18" name="tile at 2,000 working hours per FTE ≈ 1.3 bn UZS/yr at 15M/month loaded cost"/>
+          <p:cNvPr id="18" name="tile 23 FTE × 15M/month × 12 — officer time only; at a 10% addressable share ≈ 1.4 bn"/>
           <p:cNvSpPr/>
           <p:nvPr/>
         </p:nvSpPr>
@@ -14384,7 +14635,7 @@
       </p:sp>
       <p:sp>
         <p:nvSpPr>
-          <p:cNvPr id="19" name="tile value at 2,000 working hours per FTE ≈ 1.3 bn UZS/yr at 15M/month loaded cost"/>
+          <p:cNvPr id="19" name="tile value 23 FTE × 15M/month × 12 — officer time only; at a 10% addressable share ≈ 1.4 bn"/>
           <p:cNvSpPr txBox="1"/>
           <p:nvPr/>
         </p:nvSpPr>
@@ -14412,7 +14663,7 @@
                   <a:srgbClr val="FFFFFF"/>
                 </a:solidFill>
               </a:rPr>
-              <a:t>≈ 75 FTE-years</a:t>
+              <a:t>≈ 4.1 bn UZS/yr</a:t>
             </a:r>
             <a:endParaRPr lang="en-US" sz="2000" dirty="0"/>
           </a:p>
@@ -14420,7 +14671,7 @@
       </p:sp>
       <p:sp>
         <p:nvSpPr>
-          <p:cNvPr id="20" name="tile label at 2,000 working hours per FTE ≈ 1.3 bn UZS/yr at 15M/month loaded cost"/>
+          <p:cNvPr id="20" name="tile label 23 FTE × 15M/month × 12 — officer time only; at a 10% addressable share ≈ 1.4 bn"/>
           <p:cNvSpPr txBox="1"/>
           <p:nvPr/>
         </p:nvSpPr>
@@ -14448,7 +14699,7 @@
                   <a:srgbClr val="8FB8A5"/>
                 </a:solidFill>
               </a:rPr>
-              <a:t>at 2,000 working hours per FTE ≈ 1.3 bn UZS/yr at 15M/month loaded cost</a:t>
+              <a:t>23 FTE × 15M/month × 12 — officer time only; at a 10% addressable share ≈ 1.4 bn</a:t>
             </a:r>
             <a:endParaRPr lang="en-US" sz="950" dirty="0"/>
           </a:p>
@@ -14479,7 +14730,7 @@
               <a:buNone/>
             </a:pPr>
             <a:r>
-              <a:rPr lang="en-US" sz="1100" b="1" dirty="0">
+              <a:rPr lang="en-US" sz="1050" b="1" dirty="0">
                 <a:solidFill>
                   <a:srgbClr val="17201B"/>
                 </a:solidFill>
@@ -14490,14 +14741,14 @@
               <a:buNone/>
             </a:pPr>
             <a:r>
-              <a:rPr lang="en-US" sz="1100" dirty="0">
+              <a:rPr lang="en-US" sz="1050" dirty="0">
                 <a:solidFill>
                   <a:srgbClr val="17201B"/>
                 </a:solidFill>
               </a:rPr>
-              <a:t>pilot cost ≈ 190M against ≈ 1.3 bn/yr of officer time at full roll-out → under 3 months after roll-out; even at one-tenth of the time saving, under a year. Not counted: faster time-to-decision for the borrower, fewer ПДН compliance findings, and better risk selection — which we will only claim after the pilot measures it.</a:t>
-            </a:r>
-            <a:endParaRPr lang="en-US" sz="1100" dirty="0"/>
+              <a:t>the ≈ 190M pilot itself (5 of 181 branches, 3 months) does not pay back — it measures the two assumptions. After roll-out the saving of ≈ 4.1 bn/yr repays the pilot within its first month; at a 10% addressable share, within two months. Not counted: faster time-to-decision for the borrower, fewer ПДН compliance findings, better risk selection — claimed only after the pilot measures them.</a:t>
+            </a:r>
+            <a:endParaRPr lang="en-US" sz="1050" dirty="0"/>
           </a:p>
         </p:txBody>
       </p:sp>

</xml_diff>

<commit_message>
Deck/docs: seventh unseen layout on the numbers slide
</commit_message>
<xml_diff>
--- a/deck/Daromad_TYS_deck.pptx
+++ b/deck/Daromad_TYS_deck.pptx
@@ -119,41 +119,41 @@
   <p:extLst>
     <p:ext uri="{521415D9-36F7-43E2-AB2F-B90AF26B5E84}">
       <p14:sectionLst xmlns:p14="http://schemas.microsoft.com/office/powerpoint/2010/main">
-        <p14:section name="Opening" id="{de89c4e0-9772-7da7-4b7c-25f1ccb825cd}">
+        <p14:section name="Opening" id="{fb6d195b-94ea-f14f-1730-959c58071a82}">
           <p14:sldIdLst>
             <p14:sldId id="256"/>
           </p14:sldIdLst>
         </p14:section>
-        <p14:section name="Problem" id="{0f9db429-52f8-4f01-a60e-bb9af2cface0}">
+        <p14:section name="Problem" id="{c6b174bd-da3e-a57e-7e6f-06d2bda689a1}">
           <p14:sldIdLst>
             <p14:sldId id="257"/>
           </p14:sldIdLst>
         </p14:section>
-        <p14:section name="Product" id="{7c107e09-6934-b995-7391-b967f057d447}">
+        <p14:section name="Product" id="{2e77964c-09a0-d6d5-142f-77603c90ce97}">
           <p14:sldIdLst>
             <p14:sldId id="258"/>
             <p14:sldId id="259"/>
           </p14:sldIdLst>
         </p14:section>
-        <p14:section name="Technology" id="{871b2d10-a7df-0940-4b52-c34ab4fd922e}">
+        <p14:section name="Technology" id="{1278013d-1ea9-164b-8d1e-1461e7ffbd48}">
           <p14:sldIdLst>
             <p14:sldId id="260"/>
             <p14:sldId id="261"/>
             <p14:sldId id="262"/>
           </p14:sldIdLst>
         </p14:section>
-        <p14:section name="Business" id="{87164faa-dd57-d805-88e1-b715ce87d522}">
+        <p14:section name="Business" id="{f8963342-830f-6159-166a-c3e47e7e9da5}">
           <p14:sldIdLst>
             <p14:sldId id="263"/>
             <p14:sldId id="264"/>
           </p14:sldIdLst>
         </p14:section>
-        <p14:section name="Closing" id="{f699e712-d37b-6afc-5f71-2b8e4311386c}">
+        <p14:section name="Closing" id="{c88c5934-2a31-d08b-354c-c61093df2455}">
           <p14:sldIdLst>
             <p14:sldId id="265"/>
           </p14:sldIdLst>
         </p14:section>
-        <p14:section name="Appendix" id="{b1f89bf7-0ca2-054b-7d6a-0e477dfaf0ef}">
+        <p14:section name="Appendix" id="{063dc7c9-baa5-941d-e05b-7948ec6e619d}">
           <p14:sldIdLst>
             <p14:sldId id="266"/>
             <p14:sldId id="267"/>
@@ -1730,7 +1730,7 @@
           <a:p>
             <a:r>
               <a:rPr lang="en-US" dirty="0"/>
-              <a:t>Measured through the real app: statement parsing exact on 60 of 60 generator PDFs — and, more importantly, exact on 6 of 6 layouts the parser had never seen: signed-amount CSV, Kirim/Chiqim Excel, quoted English CSV with a type column, Unicode minus, headerless, Приход/Расход TSV. Tamper recall 40 of 40 with no false alarms on clean statements; receipt OCR 95% on totals, 100% on INN. Risk model: AUC 0.965 on our declared synthetic population — proves the pipeline, not the world. So we ran the same 18 features on real anonymised bank data, 443 loans from PKDD'99, 44 of them bad: AUC 0.90 out-of-fold, confidence interval roughly 0.86 to 0.94, versus 0.74 for the ratio alone. Logistic regression is close — we keep the trees for monotone constraints and thresholds, not for the last hundredth. [0:45]</a:t>
+              <a:t>Measured through the real app: statement parsing exact on 60 of 60 generator PDFs — and, more importantly, exact on 7 of 7 layouts the parser had never seen: signed-amount CSV, Kirim/Chiqim Excel, quoted English CSV with a type column, Unicode minus, headerless, Приход/Расход TSV, and a Payme-style wallet export with a plus/minus type column and no balance. Tamper recall 40 of 40 with no false alarms on clean statements; receipt OCR 95% on totals, 100% on INN. Risk model: AUC 0.965 on our declared synthetic population — proves the pipeline, not the world. So we ran the same 18 features on real anonymised bank data, 443 loans from PKDD'99, 44 of them bad: AUC 0.90 out-of-fold, confidence interval roughly 0.86 to 0.94, versus 0.74 for the ratio alone. Logistic regression is close — we keep the trees for monotone constraints and thresholds, not for the last hundredth. [0:45]</a:t>
             </a:r>
             <a:endParaRPr lang="en-US" dirty="0"/>
           </a:p>
@@ -11166,7 +11166,7 @@
       </p:sp>
       <p:sp>
         <p:nvSpPr>
-          <p:cNvPr id="7" name="tile unseen layouts exact: signed-amount CSV, Kirim/Chiqim XLSX, quoted EN CSV + type column, Unicode minus, headerless, Приход/Расход TSV"/>
+          <p:cNvPr id="7" name="tile unseen layouts exact: signed-amount CSV, Kirim/Chiqim XLSX, quoted EN CSV + type column, Unicode minus, headerless, Приход/Расход TSV, Payme-style wallet export"/>
           <p:cNvSpPr/>
           <p:nvPr/>
         </p:nvSpPr>
@@ -11193,7 +11193,7 @@
       </p:sp>
       <p:sp>
         <p:nvSpPr>
-          <p:cNvPr id="8" name="tile value unseen layouts exact: signed-amount CSV, Kirim/Chiqim XLSX, quoted EN CSV + type column, Unicode minus, headerless, Приход/Расход TSV"/>
+          <p:cNvPr id="8" name="tile value unseen layouts exact: signed-amount CSV, Kirim/Chiqim XLSX, quoted EN CSV + type column, Unicode minus, headerless, Приход/Расход TSV, Payme-style wallet export"/>
           <p:cNvSpPr txBox="1"/>
           <p:nvPr/>
         </p:nvSpPr>
@@ -11221,7 +11221,7 @@
                   <a:srgbClr val="1F4E3D"/>
                 </a:solidFill>
               </a:rPr>
-              <a:t>6/6</a:t>
+              <a:t>7/7</a:t>
             </a:r>
             <a:endParaRPr lang="en-US" sz="2600" dirty="0"/>
           </a:p>
@@ -11229,7 +11229,7 @@
       </p:sp>
       <p:sp>
         <p:nvSpPr>
-          <p:cNvPr id="9" name="tile label unseen layouts exact: signed-amount CSV, Kirim/Chiqim XLSX, quoted EN CSV + type column, Unicode minus, headerless, Приход/Расход TSV"/>
+          <p:cNvPr id="9" name="tile label unseen layouts exact: signed-amount CSV, Kirim/Chiqim XLSX, quoted EN CSV + type column, Unicode minus, headerless, Приход/Расход TSV, Payme-style wallet export"/>
           <p:cNvSpPr txBox="1"/>
           <p:nvPr/>
         </p:nvSpPr>
@@ -11257,7 +11257,7 @@
                   <a:srgbClr val="5C6B63"/>
                 </a:solidFill>
               </a:rPr>
-              <a:t>unseen layouts exact: signed-amount CSV, Kirim/Chiqim XLSX, quoted EN CSV + type column, Unicode minus, headerless, Приход/Расход TSV</a:t>
+              <a:t>unseen layouts exact: signed-amount CSV, Kirim/Chiqim XLSX, quoted EN CSV + type column, Unicode minus, headerless, Приход/Расход TSV, Payme-style wallet export</a:t>
             </a:r>
             <a:endParaRPr lang="en-US" sz="950" dirty="0"/>
           </a:p>

</xml_diff>

<commit_message>
Deck/docs: lender-type rules on slides 3/5/8 and Appendix A; shorter tiles on the numbers slide; script and README updated
</commit_message>
<xml_diff>
--- a/deck/Daromad_TYS_deck.pptx
+++ b/deck/Daromad_TYS_deck.pptx
@@ -119,41 +119,41 @@
   <p:extLst>
     <p:ext uri="{521415D9-36F7-43E2-AB2F-B90AF26B5E84}">
       <p14:sectionLst xmlns:p14="http://schemas.microsoft.com/office/powerpoint/2010/main">
-        <p14:section name="Opening" id="{fb6d195b-94ea-f14f-1730-959c58071a82}">
+        <p14:section name="Opening" id="{7043f6e1-5069-579b-6fb1-a9274fd6b9fd}">
           <p14:sldIdLst>
             <p14:sldId id="256"/>
           </p14:sldIdLst>
         </p14:section>
-        <p14:section name="Problem" id="{c6b174bd-da3e-a57e-7e6f-06d2bda689a1}">
+        <p14:section name="Problem" id="{951a0779-f0a0-7c2d-674d-1e77427ce038}">
           <p14:sldIdLst>
             <p14:sldId id="257"/>
           </p14:sldIdLst>
         </p14:section>
-        <p14:section name="Product" id="{2e77964c-09a0-d6d5-142f-77603c90ce97}">
+        <p14:section name="Product" id="{20937490-f892-7737-63b2-8b85633888ed}">
           <p14:sldIdLst>
             <p14:sldId id="258"/>
             <p14:sldId id="259"/>
           </p14:sldIdLst>
         </p14:section>
-        <p14:section name="Technology" id="{1278013d-1ea9-164b-8d1e-1461e7ffbd48}">
+        <p14:section name="Technology" id="{a518607e-06d8-a3de-0149-97c66fe6d774}">
           <p14:sldIdLst>
             <p14:sldId id="260"/>
             <p14:sldId id="261"/>
             <p14:sldId id="262"/>
           </p14:sldIdLst>
         </p14:section>
-        <p14:section name="Business" id="{f8963342-830f-6159-166a-c3e47e7e9da5}">
+        <p14:section name="Business" id="{f620084c-fd95-1947-c80c-7fb8ea0814e9}">
           <p14:sldIdLst>
             <p14:sldId id="263"/>
             <p14:sldId id="264"/>
           </p14:sldIdLst>
         </p14:section>
-        <p14:section name="Closing" id="{c88c5934-2a31-d08b-354c-c61093df2455}">
+        <p14:section name="Closing" id="{477f4e6d-ee63-ecf9-39e5-cd5eced515ad}">
           <p14:sldIdLst>
             <p14:sldId id="265"/>
           </p14:sldIdLst>
         </p14:section>
-        <p14:section name="Appendix" id="{063dc7c9-baa5-941d-e05b-7948ec6e619d}">
+        <p14:section name="Appendix" id="{c7813272-489e-17e3-ea66-1dc1ae41d8fb}">
           <p14:sldIdLst>
             <p14:sldId id="266"/>
             <p14:sldId id="267"/>
@@ -1378,7 +1378,7 @@
           <a:p>
             <a:r>
               <a:rPr lang="en-US" dirty="0"/>
-              <a:t>Show the regulation's list of acceptable income evidence. For a self-employed borrower only one line exists: income credited to bank accounts — no employer, no pension, income untaxed and unfiled. MKBANK targets about 140,000 micro-projects this year, by its own figures. Every one of them needs a documented income assessment; the ones outside the family programme and above 50 BRV also need a ПДН under 50 percent — computed from documents like these. Fiscal receipts exist only where the business uses an online cash register; we read them as corroboration, not as the income figure. [0:45]</a:t>
+              <a:t>Show the regulation's list of acceptable income evidence. For a self-employed borrower only one line exists: income credited to bank accounts — no employer, no pension, income untaxed and unfiled. MKBANK targets about 140,000 micro-projects this year, by its own figures. Every one of them needs a documented income assessment, and every one outside the family programme needs a ПДН under 50 percent — for a bank there is no small-loan exclusion — computed from documents like these. Fiscal receipts exist only where the business uses an online cash register; we read them as corroboration, not as the income figure. [0:45]</a:t>
             </a:r>
             <a:endParaRPr lang="en-US" dirty="0"/>
           </a:p>
@@ -1906,7 +1906,7 @@
           <a:p>
             <a:r>
               <a:rPr lang="en-US" dirty="0"/>
-              <a:t>Cost: our three people plus one bank analyst, one small VM — no GPU, no licences, no API spend; marginal cost per application is zero; about 190 million for three months. Value, with two assumptions the pilot exists to measure: document handling falls from about 90 to 25 minutes, and about 30 percent of MKBANK's 140,000 micro-project applications are addressable — outside the family programme and above the 50-BRV threshold. That is 42,000 applications, 45,000 officer-hours, 23 full-time officers, about 4 billion sum a year at a 15-million loaded monthly cost. The pilot does not pay for itself in five branches; the roll-out does, within its first month. Even at a 10 percent addressable share it pays back within two months. Every term is a slider. [1:30]</a:t>
+              <a:t>Cost: our three people plus one bank analyst, one small VM — no GPU, no licences, no API spend; marginal cost per application is zero; about 190 million for three months. Value, with two assumptions the pilot exists to measure: document handling falls from about 90 to 25 minutes, and about 30 percent of MKBANK's 140,000 micro-project applications are addressable — those outside the ПДН-exempt family programme; for a bank there is no small-loan threshold. That is 42,000 applications, 45,000 officer-hours, 23 full-time officers, about 4 billion sum a year at a 15-million loaded monthly cost. The pilot does not pay for itself in five branches; the roll-out does, within its first month. Even at a 10 percent addressable share it pays back within two months. Every term is a slider. [1:30]</a:t>
             </a:r>
             <a:endParaRPr lang="en-US" dirty="0"/>
           </a:p>
@@ -3782,7 +3782,7 @@
                             <a:srgbClr val="17201B"/>
                           </a:solidFill>
                         </a:rPr>
-                        <a:t>Includes the application under review and all loan agreements with all lenders; co-borrower loans counted; excluded if amount + outstanding principal ≤ 50 BRV («…50 бараваридан ошмаганда»); 75 BRV for self-employed at MFOs; bank-level allowance: up to 15% of the number of loans to individuals may be issued outside the requirement — a quota the bank tracks, not a per-application rule</a:t>
+                        <a:t>Includes the application under review and all loan agreements with all lenders; co-borrower loans counted. Lender-type reliefs (2024): banks («банк томонидан…») — only a portfolio quota, up to 15% of the number of loans to individuals outside the requirement; MFOs and pawnshops («микромолия ташкилоти ва ломбард томонидан…») — excluded when amount + outstanding principal ≤ 50 BRV; MFOs lending to the self-employed — 75 BRV. Daromad defaults to bank: ratio always computed, quota shown as a note</a:t>
                       </a:r>
                       <a:endParaRPr lang="en-US" sz="900" dirty="0"/>
                     </a:p>
@@ -3843,7 +3843,7 @@
                             <a:srgbClr val="17201B"/>
                           </a:solidFill>
                         </a:rPr>
-                        <a:t>obligations table, exemption badge</a:t>
+                        <a:t>lender-type selector, ПДН panel note</a:t>
                       </a:r>
                       <a:endParaRPr lang="en-US" sz="900" dirty="0"/>
                     </a:p>
@@ -8931,7 +8931,7 @@
                   <a:srgbClr val="17201B"/>
                 </a:solidFill>
               </a:rPr>
-              <a:t>36-month spreading, guarantor rule, 50-BRV and family-programme exemptions, 50% cap, maximum affordable amount</a:t>
+              <a:t>36-month spreading, guarantor rule, family-programme exemption, lender-type rules (banks: no small-loan exclusion, 15% quota is portfolio-level), 50% cap, maximum affordable amount</a:t>
             </a:r>
             <a:endParaRPr lang="en-US" sz="1050" dirty="0"/>
           </a:p>
@@ -10312,7 +10312,7 @@
                   <a:srgbClr val="17201B"/>
                 </a:solidFill>
               </a:rPr>
-              <a:t>ПДН clause by clause: 36/180-month spreading, guarantor rule, exemptions, 50% cap, back-solved amount</a:t>
+              <a:t>ПДН clause by clause: 36/180-month spreading, guarantor rule, lender-type exclusions, family-programme exemption, 50% cap, back-solved amount</a:t>
             </a:r>
             <a:endParaRPr lang="en-US" sz="1050" dirty="0"/>
           </a:p>
@@ -11067,18 +11067,18 @@
       </p:sp>
       <p:sp>
         <p:nvSpPr>
-          <p:cNvPr id="4" name="tile generator statement PDFs parsed with exact row count and reconciled balance chain (2 layouts, RU/UZ)"/>
+          <p:cNvPr id="4" name="tile generator PDFs: exact rows, balance chain reconciled (2 layouts, RU/UZ)"/>
           <p:cNvSpPr/>
           <p:nvPr/>
         </p:nvSpPr>
         <p:spPr>
           <a:xfrm>
             <a:off x="548640" y="1325880"/>
-            <a:ext cx="2103120" cy="1280160"/>
+            <a:ext cx="2103120" cy="1353312"/>
           </a:xfrm>
           <a:prstGeom prst="roundRect">
             <a:avLst>
-              <a:gd name="adj" fmla="val 5714"/>
+              <a:gd name="adj" fmla="val 5405"/>
             </a:avLst>
           </a:prstGeom>
           <a:solidFill>
@@ -11094,14 +11094,14 @@
       </p:sp>
       <p:sp>
         <p:nvSpPr>
-          <p:cNvPr id="5" name="tile value generator statement PDFs parsed with exact row count and reconciled balance chain (2 layouts, RU/UZ)"/>
+          <p:cNvPr id="5" name="tile value generator PDFs: exact rows, balance chain reconciled (2 layouts, RU/UZ)"/>
           <p:cNvSpPr txBox="1"/>
           <p:nvPr/>
         </p:nvSpPr>
         <p:spPr>
           <a:xfrm>
             <a:off x="685800" y="1399032"/>
-            <a:ext cx="1828800" cy="704088"/>
+            <a:ext cx="1828800" cy="744322"/>
           </a:xfrm>
           <a:prstGeom prst="rect">
             <a:avLst/>
@@ -11117,27 +11117,27 @@
               <a:buNone/>
             </a:pPr>
             <a:r>
-              <a:rPr lang="en-US" sz="2600" b="1" dirty="0">
+              <a:rPr lang="en-US" sz="2400" b="1" dirty="0">
                 <a:solidFill>
                   <a:srgbClr val="1F4E3D"/>
                 </a:solidFill>
               </a:rPr>
               <a:t>60/60</a:t>
             </a:r>
-            <a:endParaRPr lang="en-US" sz="2600" dirty="0"/>
-          </a:p>
-        </p:txBody>
-      </p:sp>
-      <p:sp>
-        <p:nvSpPr>
-          <p:cNvPr id="6" name="tile label generator statement PDFs parsed with exact row count and reconciled balance chain (2 layouts, RU/UZ)"/>
+            <a:endParaRPr lang="en-US" sz="2400" dirty="0"/>
+          </a:p>
+        </p:txBody>
+      </p:sp>
+      <p:sp>
+        <p:nvSpPr>
+          <p:cNvPr id="6" name="tile label generator PDFs: exact rows, balance chain reconciled (2 layouts, RU/UZ)"/>
           <p:cNvSpPr txBox="1"/>
           <p:nvPr/>
         </p:nvSpPr>
         <p:spPr>
           <a:xfrm>
-            <a:off x="685800" y="2068373"/>
-            <a:ext cx="1828800" cy="512064"/>
+            <a:off x="685800" y="2110801"/>
+            <a:ext cx="1828800" cy="541325"/>
           </a:xfrm>
           <a:prstGeom prst="rect">
             <a:avLst/>
@@ -11153,31 +11153,31 @@
               <a:buNone/>
             </a:pPr>
             <a:r>
-              <a:rPr lang="en-US" sz="950" dirty="0">
+              <a:rPr lang="en-US" sz="900" dirty="0">
                 <a:solidFill>
                   <a:srgbClr val="5C6B63"/>
                 </a:solidFill>
               </a:rPr>
-              <a:t>generator statement PDFs parsed with exact row count and reconciled balance chain (2 layouts, RU/UZ)</a:t>
-            </a:r>
-            <a:endParaRPr lang="en-US" sz="950" dirty="0"/>
-          </a:p>
-        </p:txBody>
-      </p:sp>
-      <p:sp>
-        <p:nvSpPr>
-          <p:cNvPr id="7" name="tile unseen layouts exact: signed-amount CSV, Kirim/Chiqim XLSX, quoted EN CSV + type column, Unicode minus, headerless, Приход/Расход TSV, Payme-style wallet export"/>
+              <a:t>generator PDFs: exact rows, balance chain reconciled (2 layouts, RU/UZ)</a:t>
+            </a:r>
+            <a:endParaRPr lang="en-US" sz="900" dirty="0"/>
+          </a:p>
+        </p:txBody>
+      </p:sp>
+      <p:sp>
+        <p:nvSpPr>
+          <p:cNvPr id="7" name="tile unseen layouts exact — CSV/XLSX/TSV variants incl. a wallet export (list on the model card)"/>
           <p:cNvSpPr/>
           <p:nvPr/>
         </p:nvSpPr>
         <p:spPr>
           <a:xfrm>
             <a:off x="2788920" y="1325880"/>
-            <a:ext cx="2103120" cy="1280160"/>
+            <a:ext cx="2103120" cy="1353312"/>
           </a:xfrm>
           <a:prstGeom prst="roundRect">
             <a:avLst>
-              <a:gd name="adj" fmla="val 5714"/>
+              <a:gd name="adj" fmla="val 5405"/>
             </a:avLst>
           </a:prstGeom>
           <a:solidFill>
@@ -11193,14 +11193,14 @@
       </p:sp>
       <p:sp>
         <p:nvSpPr>
-          <p:cNvPr id="8" name="tile value unseen layouts exact: signed-amount CSV, Kirim/Chiqim XLSX, quoted EN CSV + type column, Unicode minus, headerless, Приход/Расход TSV, Payme-style wallet export"/>
+          <p:cNvPr id="8" name="tile value unseen layouts exact — CSV/XLSX/TSV variants incl. a wallet export (list on the model card)"/>
           <p:cNvSpPr txBox="1"/>
           <p:nvPr/>
         </p:nvSpPr>
         <p:spPr>
           <a:xfrm>
             <a:off x="2926080" y="1399032"/>
-            <a:ext cx="1828800" cy="704088"/>
+            <a:ext cx="1828800" cy="744322"/>
           </a:xfrm>
           <a:prstGeom prst="rect">
             <a:avLst/>
@@ -11216,27 +11216,27 @@
               <a:buNone/>
             </a:pPr>
             <a:r>
-              <a:rPr lang="en-US" sz="2600" b="1" dirty="0">
+              <a:rPr lang="en-US" sz="2400" b="1" dirty="0">
                 <a:solidFill>
                   <a:srgbClr val="1F4E3D"/>
                 </a:solidFill>
               </a:rPr>
               <a:t>7/7</a:t>
             </a:r>
-            <a:endParaRPr lang="en-US" sz="2600" dirty="0"/>
-          </a:p>
-        </p:txBody>
-      </p:sp>
-      <p:sp>
-        <p:nvSpPr>
-          <p:cNvPr id="9" name="tile label unseen layouts exact: signed-amount CSV, Kirim/Chiqim XLSX, quoted EN CSV + type column, Unicode minus, headerless, Приход/Расход TSV, Payme-style wallet export"/>
+            <a:endParaRPr lang="en-US" sz="2400" dirty="0"/>
+          </a:p>
+        </p:txBody>
+      </p:sp>
+      <p:sp>
+        <p:nvSpPr>
+          <p:cNvPr id="9" name="tile label unseen layouts exact — CSV/XLSX/TSV variants incl. a wallet export (list on the model card)"/>
           <p:cNvSpPr txBox="1"/>
           <p:nvPr/>
         </p:nvSpPr>
         <p:spPr>
           <a:xfrm>
-            <a:off x="2926080" y="2068373"/>
-            <a:ext cx="1828800" cy="512064"/>
+            <a:off x="2926080" y="2110801"/>
+            <a:ext cx="1828800" cy="541325"/>
           </a:xfrm>
           <a:prstGeom prst="rect">
             <a:avLst/>
@@ -11252,31 +11252,31 @@
               <a:buNone/>
             </a:pPr>
             <a:r>
-              <a:rPr lang="en-US" sz="950" dirty="0">
+              <a:rPr lang="en-US" sz="900" dirty="0">
                 <a:solidFill>
                   <a:srgbClr val="5C6B63"/>
                 </a:solidFill>
               </a:rPr>
-              <a:t>unseen layouts exact: signed-amount CSV, Kirim/Chiqim XLSX, quoted EN CSV + type column, Unicode minus, headerless, Приход/Расход TSV, Payme-style wallet export</a:t>
-            </a:r>
-            <a:endParaRPr lang="en-US" sz="950" dirty="0"/>
-          </a:p>
-        </p:txBody>
-      </p:sp>
-      <p:sp>
-        <p:nvSpPr>
-          <p:cNvPr id="10" name="tile tampered statements caught: inflated inflow, deleted debit, duplicated row, window dressing; 0 false alarms on clean ones"/>
+              <a:t>unseen layouts exact — CSV/XLSX/TSV variants incl. a wallet export (list on the model card)</a:t>
+            </a:r>
+            <a:endParaRPr lang="en-US" sz="900" dirty="0"/>
+          </a:p>
+        </p:txBody>
+      </p:sp>
+      <p:sp>
+        <p:nvSpPr>
+          <p:cNvPr id="10" name="tile tampered statements caught, 4 tamper types; 0 false alarms on clean ones"/>
           <p:cNvSpPr/>
           <p:nvPr/>
         </p:nvSpPr>
         <p:spPr>
           <a:xfrm>
             <a:off x="5029200" y="1325880"/>
-            <a:ext cx="2103120" cy="1280160"/>
+            <a:ext cx="2103120" cy="1353312"/>
           </a:xfrm>
           <a:prstGeom prst="roundRect">
             <a:avLst>
-              <a:gd name="adj" fmla="val 5714"/>
+              <a:gd name="adj" fmla="val 5405"/>
             </a:avLst>
           </a:prstGeom>
           <a:solidFill>
@@ -11292,14 +11292,14 @@
       </p:sp>
       <p:sp>
         <p:nvSpPr>
-          <p:cNvPr id="11" name="tile value tampered statements caught: inflated inflow, deleted debit, duplicated row, window dressing; 0 false alarms on clean ones"/>
+          <p:cNvPr id="11" name="tile value tampered statements caught, 4 tamper types; 0 false alarms on clean ones"/>
           <p:cNvSpPr txBox="1"/>
           <p:nvPr/>
         </p:nvSpPr>
         <p:spPr>
           <a:xfrm>
             <a:off x="5166360" y="1399032"/>
-            <a:ext cx="1828800" cy="704088"/>
+            <a:ext cx="1828800" cy="744322"/>
           </a:xfrm>
           <a:prstGeom prst="rect">
             <a:avLst/>
@@ -11315,27 +11315,27 @@
               <a:buNone/>
             </a:pPr>
             <a:r>
-              <a:rPr lang="en-US" sz="2600" b="1" dirty="0">
+              <a:rPr lang="en-US" sz="2400" b="1" dirty="0">
                 <a:solidFill>
                   <a:srgbClr val="1F4E3D"/>
                 </a:solidFill>
               </a:rPr>
               <a:t>40/40</a:t>
             </a:r>
-            <a:endParaRPr lang="en-US" sz="2600" dirty="0"/>
-          </a:p>
-        </p:txBody>
-      </p:sp>
-      <p:sp>
-        <p:nvSpPr>
-          <p:cNvPr id="12" name="tile label tampered statements caught: inflated inflow, deleted debit, duplicated row, window dressing; 0 false alarms on clean ones"/>
+            <a:endParaRPr lang="en-US" sz="2400" dirty="0"/>
+          </a:p>
+        </p:txBody>
+      </p:sp>
+      <p:sp>
+        <p:nvSpPr>
+          <p:cNvPr id="12" name="tile label tampered statements caught, 4 tamper types; 0 false alarms on clean ones"/>
           <p:cNvSpPr txBox="1"/>
           <p:nvPr/>
         </p:nvSpPr>
         <p:spPr>
           <a:xfrm>
-            <a:off x="5166360" y="2068373"/>
-            <a:ext cx="1828800" cy="512064"/>
+            <a:off x="5166360" y="2110801"/>
+            <a:ext cx="1828800" cy="541325"/>
           </a:xfrm>
           <a:prstGeom prst="rect">
             <a:avLst/>
@@ -11351,31 +11351,31 @@
               <a:buNone/>
             </a:pPr>
             <a:r>
-              <a:rPr lang="en-US" sz="950" dirty="0">
+              <a:rPr lang="en-US" sz="900" dirty="0">
                 <a:solidFill>
                   <a:srgbClr val="5C6B63"/>
                 </a:solidFill>
               </a:rPr>
-              <a:t>tampered statements caught: inflated inflow, deleted debit, duplicated row, window dressing; 0 false alarms on clean ones</a:t>
-            </a:r>
-            <a:endParaRPr lang="en-US" sz="950" dirty="0"/>
-          </a:p>
-        </p:txBody>
-      </p:sp>
-      <p:sp>
-        <p:nvSpPr>
-          <p:cNvPr id="13" name="tile receipt OCR — total exact on 60 camera-augmented photos; INN 100%, date 97%"/>
+              <a:t>tampered statements caught, 4 tamper types; 0 false alarms on clean ones</a:t>
+            </a:r>
+            <a:endParaRPr lang="en-US" sz="900" dirty="0"/>
+          </a:p>
+        </p:txBody>
+      </p:sp>
+      <p:sp>
+        <p:nvSpPr>
+          <p:cNvPr id="13" name="tile receipt OCR total exact, 60 camera-augmented photos; INN 100%, date 97%"/>
           <p:cNvSpPr/>
           <p:nvPr/>
         </p:nvSpPr>
         <p:spPr>
           <a:xfrm>
-            <a:off x="548640" y="2743200"/>
-            <a:ext cx="2103120" cy="1280160"/>
+            <a:off x="548640" y="2788920"/>
+            <a:ext cx="2103120" cy="1353312"/>
           </a:xfrm>
           <a:prstGeom prst="roundRect">
             <a:avLst>
-              <a:gd name="adj" fmla="val 5714"/>
+              <a:gd name="adj" fmla="val 5405"/>
             </a:avLst>
           </a:prstGeom>
           <a:solidFill>
@@ -11391,14 +11391,14 @@
       </p:sp>
       <p:sp>
         <p:nvSpPr>
-          <p:cNvPr id="14" name="tile value receipt OCR — total exact on 60 camera-augmented photos; INN 100%, date 97%"/>
+          <p:cNvPr id="14" name="tile value receipt OCR total exact, 60 camera-augmented photos; INN 100%, date 97%"/>
           <p:cNvSpPr txBox="1"/>
           <p:nvPr/>
         </p:nvSpPr>
         <p:spPr>
           <a:xfrm>
-            <a:off x="685800" y="2816352"/>
-            <a:ext cx="1828800" cy="704088"/>
+            <a:off x="685800" y="2862072"/>
+            <a:ext cx="1828800" cy="744322"/>
           </a:xfrm>
           <a:prstGeom prst="rect">
             <a:avLst/>
@@ -11414,27 +11414,27 @@
               <a:buNone/>
             </a:pPr>
             <a:r>
-              <a:rPr lang="en-US" sz="2600" b="1" dirty="0">
+              <a:rPr lang="en-US" sz="2400" b="1" dirty="0">
                 <a:solidFill>
                   <a:srgbClr val="1F4E3D"/>
                 </a:solidFill>
               </a:rPr>
               <a:t>95%</a:t>
             </a:r>
-            <a:endParaRPr lang="en-US" sz="2600" dirty="0"/>
-          </a:p>
-        </p:txBody>
-      </p:sp>
-      <p:sp>
-        <p:nvSpPr>
-          <p:cNvPr id="15" name="tile label receipt OCR — total exact on 60 camera-augmented photos; INN 100%, date 97%"/>
+            <a:endParaRPr lang="en-US" sz="2400" dirty="0"/>
+          </a:p>
+        </p:txBody>
+      </p:sp>
+      <p:sp>
+        <p:nvSpPr>
+          <p:cNvPr id="15" name="tile label receipt OCR total exact, 60 camera-augmented photos; INN 100%, date 97%"/>
           <p:cNvSpPr txBox="1"/>
           <p:nvPr/>
         </p:nvSpPr>
         <p:spPr>
           <a:xfrm>
-            <a:off x="685800" y="3485693"/>
-            <a:ext cx="1828800" cy="512064"/>
+            <a:off x="685800" y="3573841"/>
+            <a:ext cx="1828800" cy="541325"/>
           </a:xfrm>
           <a:prstGeom prst="rect">
             <a:avLst/>
@@ -11450,31 +11450,31 @@
               <a:buNone/>
             </a:pPr>
             <a:r>
-              <a:rPr lang="en-US" sz="950" dirty="0">
+              <a:rPr lang="en-US" sz="900" dirty="0">
                 <a:solidFill>
                   <a:srgbClr val="5C6B63"/>
                 </a:solidFill>
               </a:rPr>
-              <a:t>receipt OCR — total exact on 60 camera-augmented photos; INN 100%, date 97%</a:t>
-            </a:r>
-            <a:endParaRPr lang="en-US" sz="950" dirty="0"/>
-          </a:p>
-        </p:txBody>
-      </p:sp>
-      <p:sp>
-        <p:nvSpPr>
-          <p:cNvPr id="16" name="tile risk model ROC-AUC, synthetic holdout n=500; logistic 0.963, ratio alone 0.948"/>
+              <a:t>receipt OCR total exact, 60 camera-augmented photos; INN 100%, date 97%</a:t>
+            </a:r>
+            <a:endParaRPr lang="en-US" sz="900" dirty="0"/>
+          </a:p>
+        </p:txBody>
+      </p:sp>
+      <p:sp>
+        <p:nvSpPr>
+          <p:cNvPr id="16" name="tile ROC-AUC, synthetic holdout n=500; logistic 0.963, ratio alone 0.948"/>
           <p:cNvSpPr/>
           <p:nvPr/>
         </p:nvSpPr>
         <p:spPr>
           <a:xfrm>
-            <a:off x="2788920" y="2743200"/>
-            <a:ext cx="2103120" cy="1280160"/>
+            <a:off x="2788920" y="2788920"/>
+            <a:ext cx="2103120" cy="1353312"/>
           </a:xfrm>
           <a:prstGeom prst="roundRect">
             <a:avLst>
-              <a:gd name="adj" fmla="val 5714"/>
+              <a:gd name="adj" fmla="val 5405"/>
             </a:avLst>
           </a:prstGeom>
           <a:solidFill>
@@ -11490,14 +11490,14 @@
       </p:sp>
       <p:sp>
         <p:nvSpPr>
-          <p:cNvPr id="17" name="tile value risk model ROC-AUC, synthetic holdout n=500; logistic 0.963, ratio alone 0.948"/>
+          <p:cNvPr id="17" name="tile value ROC-AUC, synthetic holdout n=500; logistic 0.963, ratio alone 0.948"/>
           <p:cNvSpPr txBox="1"/>
           <p:nvPr/>
         </p:nvSpPr>
         <p:spPr>
           <a:xfrm>
-            <a:off x="2926080" y="2816352"/>
-            <a:ext cx="1828800" cy="704088"/>
+            <a:off x="2926080" y="2862072"/>
+            <a:ext cx="1828800" cy="744322"/>
           </a:xfrm>
           <a:prstGeom prst="rect">
             <a:avLst/>
@@ -11513,27 +11513,27 @@
               <a:buNone/>
             </a:pPr>
             <a:r>
-              <a:rPr lang="en-US" sz="2600" b="1" dirty="0">
+              <a:rPr lang="en-US" sz="2400" b="1" dirty="0">
                 <a:solidFill>
                   <a:srgbClr val="FFFFFF"/>
                 </a:solidFill>
               </a:rPr>
               <a:t>0.965</a:t>
             </a:r>
-            <a:endParaRPr lang="en-US" sz="2600" dirty="0"/>
-          </a:p>
-        </p:txBody>
-      </p:sp>
-      <p:sp>
-        <p:nvSpPr>
-          <p:cNvPr id="18" name="tile label risk model ROC-AUC, synthetic holdout n=500; logistic 0.963, ratio alone 0.948"/>
+            <a:endParaRPr lang="en-US" sz="2400" dirty="0"/>
+          </a:p>
+        </p:txBody>
+      </p:sp>
+      <p:sp>
+        <p:nvSpPr>
+          <p:cNvPr id="18" name="tile label ROC-AUC, synthetic holdout n=500; logistic 0.963, ratio alone 0.948"/>
           <p:cNvSpPr txBox="1"/>
           <p:nvPr/>
         </p:nvSpPr>
         <p:spPr>
           <a:xfrm>
-            <a:off x="2926080" y="3485693"/>
-            <a:ext cx="1828800" cy="512064"/>
+            <a:off x="2926080" y="3573841"/>
+            <a:ext cx="1828800" cy="541325"/>
           </a:xfrm>
           <a:prstGeom prst="rect">
             <a:avLst/>
@@ -11549,31 +11549,31 @@
               <a:buNone/>
             </a:pPr>
             <a:r>
-              <a:rPr lang="en-US" sz="950" dirty="0">
+              <a:rPr lang="en-US" sz="900" dirty="0">
                 <a:solidFill>
                   <a:srgbClr val="8FB8A5"/>
                 </a:solidFill>
               </a:rPr>
-              <a:t>risk model ROC-AUC, synthetic holdout n=500; logistic 0.963, ratio alone 0.948</a:t>
-            </a:r>
-            <a:endParaRPr lang="en-US" sz="950" dirty="0"/>
-          </a:p>
-        </p:txBody>
-      </p:sp>
-      <p:sp>
-        <p:nvSpPr>
-          <p:cNvPr id="19" name="tile ROC-AUC on real bank data (Berka, 443 loans, 44 bad, 5-fold; 95% CI ≈ 0.86–0.94) vs 0.735 for the ratio alone"/>
+              <a:t>ROC-AUC, synthetic holdout n=500; logistic 0.963, ratio alone 0.948</a:t>
+            </a:r>
+            <a:endParaRPr lang="en-US" sz="900" dirty="0"/>
+          </a:p>
+        </p:txBody>
+      </p:sp>
+      <p:sp>
+        <p:nvSpPr>
+          <p:cNvPr id="19" name="tile ROC-AUC, real bank data (Berka, 443 loans, 44 bad; 95% CI ≈ 0.86–0.94); ratio alone 0.735"/>
           <p:cNvSpPr/>
           <p:nvPr/>
         </p:nvSpPr>
         <p:spPr>
           <a:xfrm>
-            <a:off x="5029200" y="2743200"/>
-            <a:ext cx="2103120" cy="1280160"/>
+            <a:off x="5029200" y="2788920"/>
+            <a:ext cx="2103120" cy="1353312"/>
           </a:xfrm>
           <a:prstGeom prst="roundRect">
             <a:avLst>
-              <a:gd name="adj" fmla="val 5714"/>
+              <a:gd name="adj" fmla="val 5405"/>
             </a:avLst>
           </a:prstGeom>
           <a:solidFill>
@@ -11589,14 +11589,14 @@
       </p:sp>
       <p:sp>
         <p:nvSpPr>
-          <p:cNvPr id="20" name="tile value ROC-AUC on real bank data (Berka, 443 loans, 44 bad, 5-fold; 95% CI ≈ 0.86–0.94) vs 0.735 for the ratio alone"/>
+          <p:cNvPr id="20" name="tile value ROC-AUC, real bank data (Berka, 443 loans, 44 bad; 95% CI ≈ 0.86–0.94); ratio alone 0.735"/>
           <p:cNvSpPr txBox="1"/>
           <p:nvPr/>
         </p:nvSpPr>
         <p:spPr>
           <a:xfrm>
-            <a:off x="5166360" y="2816352"/>
-            <a:ext cx="1828800" cy="704088"/>
+            <a:off x="5166360" y="2862072"/>
+            <a:ext cx="1828800" cy="744322"/>
           </a:xfrm>
           <a:prstGeom prst="rect">
             <a:avLst/>
@@ -11612,27 +11612,27 @@
               <a:buNone/>
             </a:pPr>
             <a:r>
-              <a:rPr lang="en-US" sz="2600" b="1" dirty="0">
+              <a:rPr lang="en-US" sz="2400" b="1" dirty="0">
                 <a:solidFill>
                   <a:srgbClr val="FFFFFF"/>
                 </a:solidFill>
               </a:rPr>
               <a:t>0.902</a:t>
             </a:r>
-            <a:endParaRPr lang="en-US" sz="2600" dirty="0"/>
-          </a:p>
-        </p:txBody>
-      </p:sp>
-      <p:sp>
-        <p:nvSpPr>
-          <p:cNvPr id="21" name="tile label ROC-AUC on real bank data (Berka, 443 loans, 44 bad, 5-fold; 95% CI ≈ 0.86–0.94) vs 0.735 for the ratio alone"/>
+            <a:endParaRPr lang="en-US" sz="2400" dirty="0"/>
+          </a:p>
+        </p:txBody>
+      </p:sp>
+      <p:sp>
+        <p:nvSpPr>
+          <p:cNvPr id="21" name="tile label ROC-AUC, real bank data (Berka, 443 loans, 44 bad; 95% CI ≈ 0.86–0.94); ratio alone 0.735"/>
           <p:cNvSpPr txBox="1"/>
           <p:nvPr/>
         </p:nvSpPr>
         <p:spPr>
           <a:xfrm>
-            <a:off x="5166360" y="3485693"/>
-            <a:ext cx="1828800" cy="512064"/>
+            <a:off x="5166360" y="3573841"/>
+            <a:ext cx="1828800" cy="541325"/>
           </a:xfrm>
           <a:prstGeom prst="rect">
             <a:avLst/>
@@ -11648,14 +11648,14 @@
               <a:buNone/>
             </a:pPr>
             <a:r>
-              <a:rPr lang="en-US" sz="950" dirty="0">
+              <a:rPr lang="en-US" sz="900" dirty="0">
                 <a:solidFill>
                   <a:srgbClr val="8FB8A5"/>
                 </a:solidFill>
               </a:rPr>
-              <a:t>ROC-AUC on real bank data (Berka, 443 loans, 44 bad, 5-fold; 95% CI ≈ 0.86–0.94) vs 0.735 for the ratio alone</a:t>
-            </a:r>
-            <a:endParaRPr lang="en-US" sz="950" dirty="0"/>
+              <a:t>ROC-AUC, real bank data (Berka, 443 loans, 44 bad; 95% CI ≈ 0.86–0.94); ratio alone 0.735</a:t>
+            </a:r>
+            <a:endParaRPr lang="en-US" sz="900" dirty="0"/>
           </a:p>
         </p:txBody>
       </p:sp>
@@ -14410,7 +14410,7 @@
       </p:sp>
       <p:sp>
         <p:nvSpPr>
-          <p:cNvPr id="12" name="tile addressable applications: 30% of MKBANK's 140,000 micro-projects (bank's own 2026 target) — those outside the family programme and above 50 BRV (assumption 2)"/>
+          <p:cNvPr id="12" name="tile addressable applications: 30% of MKBANK's 140,000 micro-projects (bank's own 2026 target) — those outside the ПДН-exempt family programme (assumption 2)"/>
           <p:cNvSpPr/>
           <p:nvPr/>
         </p:nvSpPr>
@@ -14437,7 +14437,7 @@
       </p:sp>
       <p:sp>
         <p:nvSpPr>
-          <p:cNvPr id="13" name="tile value addressable applications: 30% of MKBANK&amp;apos;s 140,000 micro-projects (bank&amp;apos;s own 2026 target) — those outside the family programme and above 50 BRV (assumption 2)"/>
+          <p:cNvPr id="13" name="tile value addressable applications: 30% of MKBANK&amp;apos;s 140,000 micro-projects (bank&amp;apos;s own 2026 target) — those outside the ПДН-exempt family programme (assumption 2)"/>
           <p:cNvSpPr txBox="1"/>
           <p:nvPr/>
         </p:nvSpPr>
@@ -14473,7 +14473,7 @@
       </p:sp>
       <p:sp>
         <p:nvSpPr>
-          <p:cNvPr id="14" name="tile label addressable applications: 30% of MKBANK&amp;apos;s 140,000 micro-projects (bank&amp;apos;s own 2026 target) — those outside the family programme and above 50 BRV (assumption 2)"/>
+          <p:cNvPr id="14" name="tile label addressable applications: 30% of MKBANK&amp;apos;s 140,000 micro-projects (bank&amp;apos;s own 2026 target) — those outside the ПДН-exempt family programme (assumption 2)"/>
           <p:cNvSpPr txBox="1"/>
           <p:nvPr/>
         </p:nvSpPr>
@@ -14501,7 +14501,7 @@
                   <a:srgbClr val="5C6B63"/>
                 </a:solidFill>
               </a:rPr>
-              <a:t>addressable applications: 30% of MKBANK's 140,000 micro-projects (bank's own 2026 target) — those outside the family programme and above 50 BRV (assumption 2)</a:t>
+              <a:t>addressable applications: 30% of MKBANK's 140,000 micro-projects (bank's own 2026 target) — those outside the ПДН-exempt family programme (assumption 2)</a:t>
             </a:r>
             <a:endParaRPr lang="en-US" sz="850" dirty="0"/>
           </a:p>

</xml_diff>

<commit_message>
Docs/deck: 8/8 unseen layouts and the two-date PDF fixture in README, script and slide 6; SheetJS 0.20.3 note; engine-version note; plain-language project explainer (docs/Daromad_project_explained.docx + builder)
Co-Authored-By: Claude Fable 5.1 <noreply@anthropic.com>
Claude-Session: https://claude.ai/code/session_01Xf5A9DfRgzoaeNELy2iEQH
</commit_message>
<xml_diff>
--- a/deck/Daromad_TYS_deck.pptx
+++ b/deck/Daromad_TYS_deck.pptx
@@ -119,41 +119,41 @@
   <p:extLst>
     <p:ext uri="{521415D9-36F7-43E2-AB2F-B90AF26B5E84}">
       <p14:sectionLst xmlns:p14="http://schemas.microsoft.com/office/powerpoint/2010/main">
-        <p14:section name="Opening" id="{7043f6e1-5069-579b-6fb1-a9274fd6b9fd}">
+        <p14:section name="Opening" id="{ae7b5482-a90c-fde1-bb7f-32a7e2e6b25a}">
           <p14:sldIdLst>
             <p14:sldId id="256"/>
           </p14:sldIdLst>
         </p14:section>
-        <p14:section name="Problem" id="{951a0779-f0a0-7c2d-674d-1e77427ce038}">
+        <p14:section name="Problem" id="{cc8b05c3-9a31-7406-229d-db5b3b7e46c6}">
           <p14:sldIdLst>
             <p14:sldId id="257"/>
           </p14:sldIdLst>
         </p14:section>
-        <p14:section name="Product" id="{20937490-f892-7737-63b2-8b85633888ed}">
+        <p14:section name="Product" id="{61d8c802-f0f5-8fda-460a-4222ad2dee6b}">
           <p14:sldIdLst>
             <p14:sldId id="258"/>
             <p14:sldId id="259"/>
           </p14:sldIdLst>
         </p14:section>
-        <p14:section name="Technology" id="{a518607e-06d8-a3de-0149-97c66fe6d774}">
+        <p14:section name="Technology" id="{1343aa65-7633-4e88-9234-3857541f1b1b}">
           <p14:sldIdLst>
             <p14:sldId id="260"/>
             <p14:sldId id="261"/>
             <p14:sldId id="262"/>
           </p14:sldIdLst>
         </p14:section>
-        <p14:section name="Business" id="{f620084c-fd95-1947-c80c-7fb8ea0814e9}">
+        <p14:section name="Business" id="{2c6f8039-aacf-d3a8-a1d6-98230b44b1eb}">
           <p14:sldIdLst>
             <p14:sldId id="263"/>
             <p14:sldId id="264"/>
           </p14:sldIdLst>
         </p14:section>
-        <p14:section name="Closing" id="{477f4e6d-ee63-ecf9-39e5-cd5eced515ad}">
+        <p14:section name="Closing" id="{228116d2-63c2-2646-ae7e-a5e39aa28002}">
           <p14:sldIdLst>
             <p14:sldId id="265"/>
           </p14:sldIdLst>
         </p14:section>
-        <p14:section name="Appendix" id="{c7813272-489e-17e3-ea66-1dc1ae41d8fb}">
+        <p14:section name="Appendix" id="{d87116b3-b5e7-5b5e-5f45-47abaabedd18}">
           <p14:sldIdLst>
             <p14:sldId id="266"/>
             <p14:sldId id="267"/>
@@ -1730,7 +1730,7 @@
           <a:p>
             <a:r>
               <a:rPr lang="en-US" dirty="0"/>
-              <a:t>Measured through the real app: statement parsing exact on 60 of 60 generator PDFs — and, more importantly, exact on 7 of 7 layouts the parser had never seen: signed-amount CSV, Kirim/Chiqim Excel, quoted English CSV with a type column, Unicode minus, headerless, Приход/Расход TSV, and a Payme-style wallet export with a plus/minus type column and no balance. Tamper recall 40 of 40 with no false alarms on clean statements; receipt OCR 95% on totals, 100% on INN. Risk model: AUC 0.965 on our declared synthetic population — proves the pipeline, not the world. So we ran the same 18 features on real anonymised bank data, 443 loans from PKDD'99, 44 of them bad: AUC 0.90 out-of-fold, confidence interval roughly 0.86 to 0.94, versus 0.74 for the ratio alone. Logistic regression is close — we keep the trees for monotone constraints and thresholds, not for the last hundredth. [0:45]</a:t>
+              <a:t>Measured through the real app: statement parsing exact on 60 of 60 generator PDFs — and, more importantly, exact on 8 of 8 layouts the parser had never seen: signed-amount CSV, Kirim/Chiqim Excel, quoted English CSV with a type column, Unicode minus, headerless, Приход/Расход TSV, and a Payme-style wallet export with a plus/minus type column and no balance. Tamper recall 40 of 40 with no false alarms on clean statements; receipt OCR 95% on totals, 100% on INN. Risk model: AUC 0.965 on our declared synthetic population — proves the pipeline, not the world. So we ran the same 18 features on real anonymised bank data, 443 loans from PKDD'99, 44 of them bad: AUC 0.90 out-of-fold, confidence interval roughly 0.86 to 0.94, versus 0.74 for the ratio alone. Logistic regression is close — we keep the trees for monotone constraints and thresholds, not for the last hundredth. [0:45]</a:t>
             </a:r>
             <a:endParaRPr lang="en-US" dirty="0"/>
           </a:p>
@@ -11221,7 +11221,7 @@
                   <a:srgbClr val="1F4E3D"/>
                 </a:solidFill>
               </a:rPr>
-              <a:t>7/7</a:t>
+              <a:t>8/8</a:t>
             </a:r>
             <a:endParaRPr lang="en-US" sz="2400" dirty="0"/>
           </a:p>

</xml_diff>

<commit_message>
Deck and docs: speaker script and notes removed from the repository and from the public deck (notes are rehearsal material kept locally, git-ignored); README/explainer references updated
Co-Authored-By: Claude Fable 5.1 <noreply@anthropic.com>
Claude-Session: https://claude.ai/code/session_01Xf5A9DfRgzoaeNELy2iEQH
</commit_message>
<xml_diff>
--- a/deck/Daromad_TYS_deck.pptx
+++ b/deck/Daromad_TYS_deck.pptx
@@ -119,41 +119,41 @@
   <p:extLst>
     <p:ext uri="{521415D9-36F7-43E2-AB2F-B90AF26B5E84}">
       <p14:sectionLst xmlns:p14="http://schemas.microsoft.com/office/powerpoint/2010/main">
-        <p14:section name="Opening" id="{ae7b5482-a90c-fde1-bb7f-32a7e2e6b25a}">
+        <p14:section name="Opening" id="{2ef7c5dc-1b20-777c-3361-76c501ab0764}">
           <p14:sldIdLst>
             <p14:sldId id="256"/>
           </p14:sldIdLst>
         </p14:section>
-        <p14:section name="Problem" id="{cc8b05c3-9a31-7406-229d-db5b3b7e46c6}">
+        <p14:section name="Problem" id="{38faace6-e5a1-2b58-da4c-bb08b1d08bdc}">
           <p14:sldIdLst>
             <p14:sldId id="257"/>
           </p14:sldIdLst>
         </p14:section>
-        <p14:section name="Product" id="{61d8c802-f0f5-8fda-460a-4222ad2dee6b}">
+        <p14:section name="Product" id="{95fd892f-f192-725f-2899-04189a4d2c58}">
           <p14:sldIdLst>
             <p14:sldId id="258"/>
             <p14:sldId id="259"/>
           </p14:sldIdLst>
         </p14:section>
-        <p14:section name="Technology" id="{1343aa65-7633-4e88-9234-3857541f1b1b}">
+        <p14:section name="Technology" id="{e0481e38-72c0-b852-1b8f-c064c7704edb}">
           <p14:sldIdLst>
             <p14:sldId id="260"/>
             <p14:sldId id="261"/>
             <p14:sldId id="262"/>
           </p14:sldIdLst>
         </p14:section>
-        <p14:section name="Business" id="{2c6f8039-aacf-d3a8-a1d6-98230b44b1eb}">
+        <p14:section name="Business" id="{f99bf22f-4f3f-c219-9b01-6debca81cf48}">
           <p14:sldIdLst>
             <p14:sldId id="263"/>
             <p14:sldId id="264"/>
           </p14:sldIdLst>
         </p14:section>
-        <p14:section name="Closing" id="{228116d2-63c2-2646-ae7e-a5e39aa28002}">
+        <p14:section name="Closing" id="{b1de8647-c932-763d-1d74-746b718224ec}">
           <p14:sldIdLst>
             <p14:sldId id="265"/>
           </p14:sldIdLst>
         </p14:section>
-        <p14:section name="Appendix" id="{d87116b3-b5e7-5b5e-5f45-47abaabedd18}">
+        <p14:section name="Appendix" id="{6951bb94-a65b-0796-9b2f-11afe6bb49c2}">
           <p14:sldIdLst>
             <p14:sldId id="266"/>
             <p14:sldId id="267"/>
@@ -938,7 +938,7 @@
           <a:p>
             <a:r>
               <a:rPr lang="en-US" dirty="0"/>
-              <a:t>Daromad, team TYS. Partner product for MKBANK's micro and family-business credit department. We remove the hour an officer spends turning a self-employed borrower's statements into an income figure the regulator accepts. [0:15]</a:t>
+              <a:t/>
             </a:r>
             <a:endParaRPr lang="en-US" dirty="0"/>
           </a:p>
@@ -1026,7 +1026,7 @@
           <a:p>
             <a:r>
               <a:rPr lang="en-US" dirty="0"/>
-              <a:t>Thank you. Questions.</a:t>
+              <a:t/>
             </a:r>
             <a:endParaRPr lang="en-US" dirty="0"/>
           </a:p>
@@ -1378,7 +1378,7 @@
           <a:p>
             <a:r>
               <a:rPr lang="en-US" dirty="0"/>
-              <a:t>Show the regulation's list of acceptable income evidence. For a self-employed borrower only one line exists: income credited to bank accounts — no employer, no pension, income untaxed and unfiled. MKBANK targets about 140,000 micro-projects this year, by its own figures. Every one of them needs a documented income assessment, and every one outside the family programme needs a ПДН under 50 percent — for a bank there is no small-loan exclusion — computed from documents like these. Fiscal receipts exist only where the business uses an online cash register; we read them as corroboration, not as the income figure. [0:45]</a:t>
+              <a:t/>
             </a:r>
             <a:endParaRPr lang="en-US" dirty="0"/>
           </a:p>
@@ -1466,7 +1466,7 @@
           <a:p>
             <a:r>
               <a:rPr lang="en-US" dirty="0"/>
-              <a:t>This is the screen after Load sample A. Statement parsed in the browser, twelve months of regulatory income with business revenue separated, ПДН with each line citing its clause, maximum affordable amount, and a what-if slider. [part of demo narration]</a:t>
+              <a:t/>
             </a:r>
             <a:endParaRPr lang="en-US" dirty="0"/>
           </a:p>
@@ -1554,7 +1554,7 @@
           <a:p>
             <a:r>
               <a:rPr lang="en-US" dirty="0"/>
-              <a:t>Open the public URL. Load sample A. Narrate: statement parsed, certificate read, receipt OCR'd in Uzbek; twelve months of income; ПДН just above 50 percent, so the engine computes the maximum affordable amount; drag the slider under it; integrity checks; the memo badge shows how many numbers were checked and that none is unsourced; click a citation to open the statement lines behind a figure; record the decision; export. If a judge hands you a receipt photo or a statement, upload it. Finish with Load tampered statement (it starts a fresh case): the balance-chain check fails and names the edited line. Keep the backup video open in a second tab. [2:00]</a:t>
+              <a:t/>
             </a:r>
             <a:endParaRPr lang="en-US" dirty="0"/>
           </a:p>
@@ -1642,7 +1642,7 @@
           <a:p>
             <a:r>
               <a:rPr lang="en-US" dirty="0"/>
-              <a:t>This is a system, not a prompt: parsing with coordinates, a multilingual categoriser, cash-flow reconstruction, a rule engine mapped clause by clause, boosted trees with monotone constraints, integrity checks, and a template memo with a verifier. No API key exists in this product. Production is the same bundle on the bank's server — the perimeter is literal. [0:45]</a:t>
+              <a:t/>
             </a:r>
             <a:endParaRPr lang="en-US" dirty="0"/>
           </a:p>
@@ -1730,7 +1730,7 @@
           <a:p>
             <a:r>
               <a:rPr lang="en-US" dirty="0"/>
-              <a:t>Measured through the real app: statement parsing exact on 60 of 60 generator PDFs — and, more importantly, exact on 8 of 8 layouts the parser had never seen: signed-amount CSV, Kirim/Chiqim Excel, quoted English CSV with a type column, Unicode minus, headerless, Приход/Расход TSV, and a Payme-style wallet export with a plus/minus type column and no balance. Tamper recall 40 of 40 with no false alarms on clean statements; receipt OCR 95% on totals, 100% on INN. Risk model: AUC 0.965 on our declared synthetic population — proves the pipeline, not the world. So we ran the same 18 features on real anonymised bank data, 443 loans from PKDD'99, 44 of them bad: AUC 0.90 out-of-fold, confidence interval roughly 0.86 to 0.94, versus 0.74 for the ratio alone. Logistic regression is close — we keep the trees for monotone constraints and thresholds, not for the last hundredth. [0:45]</a:t>
+              <a:t/>
             </a:r>
             <a:endParaRPr lang="en-US" dirty="0"/>
           </a:p>
@@ -1818,7 +1818,7 @@
           <a:p>
             <a:r>
               <a:rPr lang="en-US" dirty="0"/>
-              <a:t>Ten archetypes anchored to stat.uz wages, 24 months of daily transactions, rendered to PDFs with a text layer in two layouts, receipts photographed through a camera model, four tamper types. Every parameter is in the repo. The jury can regenerate everything with one command. [0:30]</a:t>
+              <a:t/>
             </a:r>
             <a:endParaRPr lang="en-US" dirty="0"/>
           </a:p>
@@ -1906,7 +1906,7 @@
           <a:p>
             <a:r>
               <a:rPr lang="en-US" dirty="0"/>
-              <a:t>Cost: our three people plus one bank analyst, one small VM — no GPU, no licences, no API spend; marginal cost per application is zero; about 190 million for three months. Value, with two assumptions the pilot exists to measure: document handling falls from about 90 to 25 minutes, and about 30 percent of MKBANK's 140,000 micro-project applications are addressable — those outside the ПДН-exempt family programme; for a bank there is no small-loan threshold. That is 42,000 applications, 45,000 officer-hours, 23 full-time officers, about 4 billion sum a year at a 15-million loaded monthly cost. The pilot does not pay for itself in five branches; the roll-out does, within its first month. Even at a 10 percent addressable share it pays back within two months. Every term is a slider. [1:30]</a:t>
+              <a:t/>
             </a:r>
             <a:endParaRPr lang="en-US" dirty="0"/>
           </a:p>
@@ -1994,7 +1994,7 @@
           <a:p>
             <a:r>
               <a:rPr lang="en-US" dirty="0"/>
-              <a:t>What another team cannot rebuild in a weekend: the Uzbek layout corpus and parsers, the categoriser lexicon, the clause-mapped rule engine with its exemptions, the verifier that makes unsourced numbers impossible, and the calibrated synthetic population. Next: scanned-statement OCR, core-banking pull for MKBANK's own account holders, retraining inside the perimeter. Thank you. [0:30]</a:t>
+              <a:t/>
             </a:r>
             <a:endParaRPr lang="en-US" dirty="0"/>
           </a:p>
@@ -2707,7 +2707,7 @@
       </p:grpSpPr>
       <p:sp>
         <p:nvSpPr>
-          <p:cNvPr id="3" name="brand"/>
+          <p:cNvPr id="2" name="brand"/>
           <p:cNvSpPr txBox="1"/>
           <p:nvPr/>
         </p:nvSpPr>
@@ -2743,7 +2743,7 @@
       </p:sp>
       <p:sp>
         <p:nvSpPr>
-          <p:cNvPr id="4" name="tagline"/>
+          <p:cNvPr id="3" name="tagline"/>
           <p:cNvSpPr txBox="1"/>
           <p:nvPr/>
         </p:nvSpPr>
@@ -2779,7 +2779,7 @@
       </p:sp>
       <p:sp>
         <p:nvSpPr>
-          <p:cNvPr id="5" name="mode pill"/>
+          <p:cNvPr id="4" name="mode pill"/>
           <p:cNvSpPr/>
           <p:nvPr/>
         </p:nvSpPr>
@@ -2806,7 +2806,7 @@
       </p:sp>
       <p:sp>
         <p:nvSpPr>
-          <p:cNvPr id="6" name="mode"/>
+          <p:cNvPr id="5" name="mode"/>
           <p:cNvSpPr txBox="1"/>
           <p:nvPr/>
         </p:nvSpPr>
@@ -2842,7 +2842,7 @@
       </p:sp>
       <p:sp>
         <p:nvSpPr>
-          <p:cNvPr id="7" name="team"/>
+          <p:cNvPr id="6" name="team"/>
           <p:cNvSpPr txBox="1"/>
           <p:nvPr/>
         </p:nvSpPr>
@@ -2889,7 +2889,7 @@
       </p:sp>
       <p:sp>
         <p:nvSpPr>
-          <p:cNvPr id="8" name="links"/>
+          <p:cNvPr id="7" name="links"/>
           <p:cNvSpPr txBox="1"/>
           <p:nvPr/>
         </p:nvSpPr>
@@ -2958,7 +2958,7 @@
       </p:sp>
       <p:sp>
         <p:nvSpPr>
-          <p:cNvPr id="9" name="event"/>
+          <p:cNvPr id="8" name="event"/>
           <p:cNvSpPr txBox="1"/>
           <p:nvPr/>
         </p:nvSpPr>
@@ -2994,7 +2994,7 @@
       </p:sp>
       <p:sp>
         <p:nvSpPr>
-          <p:cNvPr id="10" name="Text 0"/>
+          <p:cNvPr id="9" name="Text 0"/>
           <p:cNvSpPr/>
           <p:nvPr>
             <p:ph idx="100" type="title" hasCustomPrompt="1"/>
@@ -3024,7 +3024,7 @@
       </p:sp>
       <p:sp>
         <p:nvSpPr>
-          <p:cNvPr id="11" name="Text 0"/>
+          <p:cNvPr id="10" name="Text 0"/>
           <p:cNvSpPr/>
           <p:nvPr>
             <p:ph idx="101" type="body" hasCustomPrompt="1"/>
@@ -3117,7 +3117,7 @@
       </p:sp>
       <p:sp>
         <p:nvSpPr>
-          <p:cNvPr id="4" name="Text 0"/>
+          <p:cNvPr id="3" name="Text 0"/>
           <p:cNvSpPr/>
           <p:nvPr>
             <p:ph idx="101" type="body" hasCustomPrompt="1"/>
@@ -3155,7 +3155,7 @@
       </p:sp>
       <p:sp>
         <p:nvSpPr>
-          <p:cNvPr id="5" name="closing links"/>
+          <p:cNvPr id="4" name="closing links"/>
           <p:cNvSpPr txBox="1"/>
           <p:nvPr/>
         </p:nvSpPr>
@@ -7485,7 +7485,7 @@
       </p:sp>
       <p:sp>
         <p:nvSpPr>
-          <p:cNvPr id="4" name="list caption"/>
+          <p:cNvPr id="3" name="list caption"/>
           <p:cNvSpPr txBox="1"/>
           <p:nvPr/>
         </p:nvSpPr>
@@ -7521,7 +7521,7 @@
       </p:sp>
       <p:sp>
         <p:nvSpPr>
-          <p:cNvPr id="5" name="evidence 0"/>
+          <p:cNvPr id="4" name="evidence 0"/>
           <p:cNvSpPr/>
           <p:nvPr/>
         </p:nvSpPr>
@@ -7548,7 +7548,7 @@
       </p:sp>
       <p:pic>
         <p:nvPicPr>
-          <p:cNvPr id="6" name="evidence icon 0" descr="preencoded.png">    </p:cNvPr>
+          <p:cNvPr id="5" name="evidence icon 0" descr="preencoded.png">    </p:cNvPr>
           <p:cNvPicPr>
             <a:picLocks noChangeAspect="1"/>
           </p:cNvPicPr>
@@ -7572,7 +7572,7 @@
       </p:pic>
       <p:sp>
         <p:nvSpPr>
-          <p:cNvPr id="7" name="evidence text 0"/>
+          <p:cNvPr id="6" name="evidence text 0"/>
           <p:cNvSpPr txBox="1"/>
           <p:nvPr/>
         </p:nvSpPr>
@@ -7619,7 +7619,7 @@
       </p:sp>
       <p:sp>
         <p:nvSpPr>
-          <p:cNvPr id="8" name="evidence 1"/>
+          <p:cNvPr id="7" name="evidence 1"/>
           <p:cNvSpPr/>
           <p:nvPr/>
         </p:nvSpPr>
@@ -7646,7 +7646,7 @@
       </p:sp>
       <p:pic>
         <p:nvPicPr>
-          <p:cNvPr id="9" name="evidence icon 1" descr="preencoded.png">    </p:cNvPr>
+          <p:cNvPr id="8" name="evidence icon 1" descr="preencoded.png">    </p:cNvPr>
           <p:cNvPicPr>
             <a:picLocks noChangeAspect="1"/>
           </p:cNvPicPr>
@@ -7670,7 +7670,7 @@
       </p:pic>
       <p:sp>
         <p:nvSpPr>
-          <p:cNvPr id="10" name="evidence text 1"/>
+          <p:cNvPr id="9" name="evidence text 1"/>
           <p:cNvSpPr txBox="1"/>
           <p:nvPr/>
         </p:nvSpPr>
@@ -7717,7 +7717,7 @@
       </p:sp>
       <p:sp>
         <p:nvSpPr>
-          <p:cNvPr id="11" name="evidence 2"/>
+          <p:cNvPr id="10" name="evidence 2"/>
           <p:cNvSpPr/>
           <p:nvPr/>
         </p:nvSpPr>
@@ -7744,7 +7744,7 @@
       </p:sp>
       <p:pic>
         <p:nvPicPr>
-          <p:cNvPr id="12" name="evidence icon 2" descr="preencoded.png">    </p:cNvPr>
+          <p:cNvPr id="11" name="evidence icon 2" descr="preencoded.png">    </p:cNvPr>
           <p:cNvPicPr>
             <a:picLocks noChangeAspect="1"/>
           </p:cNvPicPr>
@@ -7768,7 +7768,7 @@
       </p:pic>
       <p:sp>
         <p:nvSpPr>
-          <p:cNvPr id="13" name="evidence text 2"/>
+          <p:cNvPr id="12" name="evidence text 2"/>
           <p:cNvSpPr txBox="1"/>
           <p:nvPr/>
         </p:nvSpPr>
@@ -7815,7 +7815,7 @@
       </p:sp>
       <p:sp>
         <p:nvSpPr>
-          <p:cNvPr id="14" name="evidence 3"/>
+          <p:cNvPr id="13" name="evidence 3"/>
           <p:cNvSpPr/>
           <p:nvPr/>
         </p:nvSpPr>
@@ -7842,7 +7842,7 @@
       </p:sp>
       <p:pic>
         <p:nvPicPr>
-          <p:cNvPr id="15" name="evidence icon 3" descr="preencoded.png">    </p:cNvPr>
+          <p:cNvPr id="14" name="evidence icon 3" descr="preencoded.png">    </p:cNvPr>
           <p:cNvPicPr>
             <a:picLocks noChangeAspect="1"/>
           </p:cNvPicPr>
@@ -7866,7 +7866,7 @@
       </p:pic>
       <p:sp>
         <p:nvSpPr>
-          <p:cNvPr id="16" name="evidence text 3"/>
+          <p:cNvPr id="15" name="evidence text 3"/>
           <p:cNvSpPr txBox="1"/>
           <p:nvPr/>
         </p:nvSpPr>
@@ -7913,7 +7913,7 @@
       </p:sp>
       <p:sp>
         <p:nvSpPr>
-          <p:cNvPr id="17" name="evidence 4"/>
+          <p:cNvPr id="16" name="evidence 4"/>
           <p:cNvSpPr/>
           <p:nvPr/>
         </p:nvSpPr>
@@ -7940,7 +7940,7 @@
       </p:sp>
       <p:pic>
         <p:nvPicPr>
-          <p:cNvPr id="18" name="evidence icon 4" descr="preencoded.png">    </p:cNvPr>
+          <p:cNvPr id="17" name="evidence icon 4" descr="preencoded.png">    </p:cNvPr>
           <p:cNvPicPr>
             <a:picLocks noChangeAspect="1"/>
           </p:cNvPicPr>
@@ -7964,7 +7964,7 @@
       </p:pic>
       <p:sp>
         <p:nvSpPr>
-          <p:cNvPr id="19" name="evidence text 4"/>
+          <p:cNvPr id="18" name="evidence text 4"/>
           <p:cNvSpPr txBox="1"/>
           <p:nvPr/>
         </p:nvSpPr>
@@ -8011,7 +8011,7 @@
       </p:sp>
       <p:sp>
         <p:nvSpPr>
-          <p:cNvPr id="20" name="evidence 5"/>
+          <p:cNvPr id="19" name="evidence 5"/>
           <p:cNvSpPr/>
           <p:nvPr/>
         </p:nvSpPr>
@@ -8038,7 +8038,7 @@
       </p:sp>
       <p:pic>
         <p:nvPicPr>
-          <p:cNvPr id="21" name="evidence icon 5" descr="preencoded.png">    </p:cNvPr>
+          <p:cNvPr id="20" name="evidence icon 5" descr="preencoded.png">    </p:cNvPr>
           <p:cNvPicPr>
             <a:picLocks noChangeAspect="1"/>
           </p:cNvPicPr>
@@ -8062,7 +8062,7 @@
       </p:pic>
       <p:sp>
         <p:nvSpPr>
-          <p:cNvPr id="22" name="evidence text 5"/>
+          <p:cNvPr id="21" name="evidence text 5"/>
           <p:cNvSpPr txBox="1"/>
           <p:nvPr/>
         </p:nvSpPr>
@@ -8109,7 +8109,7 @@
       </p:sp>
       <p:sp>
         <p:nvSpPr>
-          <p:cNvPr id="23" name="tile ПДН limit for all loans since 1 Jan 2025 (cl.10); 12-month arithmetic mean of income (cl.7)"/>
+          <p:cNvPr id="22" name="tile ПДН limit for all loans since 1 Jan 2025 (cl.10); 12-month arithmetic mean of income (cl.7)"/>
           <p:cNvSpPr/>
           <p:nvPr/>
         </p:nvSpPr>
@@ -8136,7 +8136,7 @@
       </p:sp>
       <p:sp>
         <p:nvSpPr>
-          <p:cNvPr id="24" name="tile value ПДН limit for all loans since 1 Jan 2025 (cl.10); 12-month arithmetic mean of income (cl.7)"/>
+          <p:cNvPr id="23" name="tile value ПДН limit for all loans since 1 Jan 2025 (cl.10); 12-month arithmetic mean of income (cl.7)"/>
           <p:cNvSpPr txBox="1"/>
           <p:nvPr/>
         </p:nvSpPr>
@@ -8172,7 +8172,7 @@
       </p:sp>
       <p:sp>
         <p:nvSpPr>
-          <p:cNvPr id="25" name="tile label ПДН limit for all loans since 1 Jan 2025 (cl.10); 12-month arithmetic mean of income (cl.7)"/>
+          <p:cNvPr id="24" name="tile label ПДН limit for all loans since 1 Jan 2025 (cl.10); 12-month arithmetic mean of income (cl.7)"/>
           <p:cNvSpPr txBox="1"/>
           <p:nvPr/>
         </p:nvSpPr>
@@ -8208,7 +8208,7 @@
       </p:sp>
       <p:sp>
         <p:nvSpPr>
-          <p:cNvPr id="26" name="tile micro-projects MKBANK targets in 2026 (47,975 in 2025); 1,062 mahalla agents"/>
+          <p:cNvPr id="25" name="tile micro-projects MKBANK targets in 2026 (47,975 in 2025); 1,062 mahalla agents"/>
           <p:cNvSpPr/>
           <p:nvPr/>
         </p:nvSpPr>
@@ -8235,7 +8235,7 @@
       </p:sp>
       <p:sp>
         <p:nvSpPr>
-          <p:cNvPr id="27" name="tile value micro-projects MKBANK targets in 2026 (47,975 in 2025); 1,062 mahalla agents"/>
+          <p:cNvPr id="26" name="tile value micro-projects MKBANK targets in 2026 (47,975 in 2025); 1,062 mahalla agents"/>
           <p:cNvSpPr txBox="1"/>
           <p:nvPr/>
         </p:nvSpPr>
@@ -8271,7 +8271,7 @@
       </p:sp>
       <p:sp>
         <p:nvSpPr>
-          <p:cNvPr id="28" name="tile label micro-projects MKBANK targets in 2026 (47,975 in 2025); 1,062 mahalla agents"/>
+          <p:cNvPr id="27" name="tile label micro-projects MKBANK targets in 2026 (47,975 in 2025); 1,062 mahalla agents"/>
           <p:cNvSpPr txBox="1"/>
           <p:nvPr/>
         </p:nvSpPr>
@@ -8307,7 +8307,7 @@
       </p:sp>
       <p:sp>
         <p:nvSpPr>
-          <p:cNvPr id="29" name="tile an officer's manual reading of 12 months of statements per application (our estimate; pilot measures it)"/>
+          <p:cNvPr id="28" name="tile an officer's manual reading of 12 months of statements per application (our estimate; pilot measures it)"/>
           <p:cNvSpPr/>
           <p:nvPr/>
         </p:nvSpPr>
@@ -8334,7 +8334,7 @@
       </p:sp>
       <p:sp>
         <p:nvSpPr>
-          <p:cNvPr id="30" name="tile value an officer&amp;apos;s manual reading of 12 months of statements per application (our estimate; pilot measures it)"/>
+          <p:cNvPr id="29" name="tile value an officer&amp;apos;s manual reading of 12 months of statements per application (our estimate; pilot measures it)"/>
           <p:cNvSpPr txBox="1"/>
           <p:nvPr/>
         </p:nvSpPr>
@@ -8370,7 +8370,7 @@
       </p:sp>
       <p:sp>
         <p:nvSpPr>
-          <p:cNvPr id="31" name="tile label an officer&amp;apos;s manual reading of 12 months of statements per application (our estimate; pilot measures it)"/>
+          <p:cNvPr id="30" name="tile label an officer&amp;apos;s manual reading of 12 months of statements per application (our estimate; pilot measures it)"/>
           <p:cNvSpPr txBox="1"/>
           <p:nvPr/>
         </p:nvSpPr>
@@ -8406,7 +8406,7 @@
       </p:sp>
       <p:sp>
         <p:nvSpPr>
-          <p:cNvPr id="32" name="tile of official income records for ~790k registered self-employed (untaxed, unfiled, no cash register required)"/>
+          <p:cNvPr id="31" name="tile of official income records for ~790k registered self-employed (untaxed, unfiled, no cash register required)"/>
           <p:cNvSpPr/>
           <p:nvPr/>
         </p:nvSpPr>
@@ -8433,7 +8433,7 @@
       </p:sp>
       <p:sp>
         <p:nvSpPr>
-          <p:cNvPr id="33" name="tile value of official income records for ~790k registered self-employed (untaxed, unfiled, no cash register required)"/>
+          <p:cNvPr id="32" name="tile value of official income records for ~790k registered self-employed (untaxed, unfiled, no cash register required)"/>
           <p:cNvSpPr txBox="1"/>
           <p:nvPr/>
         </p:nvSpPr>
@@ -8469,7 +8469,7 @@
       </p:sp>
       <p:sp>
         <p:nvSpPr>
-          <p:cNvPr id="34" name="tile label of official income records for ~790k registered self-employed (untaxed, unfiled, no cash register required)"/>
+          <p:cNvPr id="33" name="tile label of official income records for ~790k registered self-employed (untaxed, unfiled, no cash register required)"/>
           <p:cNvSpPr txBox="1"/>
           <p:nvPr/>
         </p:nvSpPr>
@@ -8505,7 +8505,7 @@
       </p:sp>
       <p:sp>
         <p:nvSpPr>
-          <p:cNvPr id="35" name="sources"/>
+          <p:cNvPr id="34" name="sources"/>
           <p:cNvSpPr txBox="1"/>
           <p:nvPr/>
         </p:nvSpPr>
@@ -8649,7 +8649,7 @@
       </p:sp>
       <p:pic>
         <p:nvPicPr>
-          <p:cNvPr id="4" name="screenshot income and pdn" descr="/home/claude/daromad/deck/img/income_pdn.png">    </p:cNvPr>
+          <p:cNvPr id="3" name="screenshot income and pdn" descr="/home/claude/daromad/deck/img/income_pdn.png">    </p:cNvPr>
           <p:cNvPicPr>
             <a:picLocks noChangeAspect="1"/>
           </p:cNvPicPr>
@@ -8673,7 +8673,7 @@
       </p:pic>
       <p:pic>
         <p:nvPicPr>
-          <p:cNvPr id="5" name="screenshot memo" descr="/home/claude/daromad/deck/img/memo.png">    </p:cNvPr>
+          <p:cNvPr id="4" name="screenshot memo" descr="/home/claude/daromad/deck/img/memo.png">    </p:cNvPr>
           <p:cNvPicPr>
             <a:picLocks noChangeAspect="1"/>
           </p:cNvPicPr>
@@ -8697,7 +8697,7 @@
       </p:pic>
       <p:sp>
         <p:nvSpPr>
-          <p:cNvPr id="6" name="got circle 0"/>
+          <p:cNvPr id="5" name="got circle 0"/>
           <p:cNvSpPr/>
           <p:nvPr/>
         </p:nvSpPr>
@@ -8722,7 +8722,7 @@
       </p:sp>
       <p:pic>
         <p:nvPicPr>
-          <p:cNvPr id="7" name="got icon 0" descr="preencoded.png">    </p:cNvPr>
+          <p:cNvPr id="6" name="got icon 0" descr="preencoded.png">    </p:cNvPr>
           <p:cNvPicPr>
             <a:picLocks noChangeAspect="1"/>
           </p:cNvPicPr>
@@ -8746,7 +8746,7 @@
       </p:pic>
       <p:sp>
         <p:nvSpPr>
-          <p:cNvPr id="8" name="got head 0"/>
+          <p:cNvPr id="7" name="got head 0"/>
           <p:cNvSpPr txBox="1"/>
           <p:nvPr/>
         </p:nvSpPr>
@@ -8782,7 +8782,7 @@
       </p:sp>
       <p:sp>
         <p:nvSpPr>
-          <p:cNvPr id="9" name="got text 0"/>
+          <p:cNvPr id="8" name="got text 0"/>
           <p:cNvSpPr txBox="1"/>
           <p:nvPr/>
         </p:nvSpPr>
@@ -8818,7 +8818,7 @@
       </p:sp>
       <p:sp>
         <p:nvSpPr>
-          <p:cNvPr id="10" name="got circle 1"/>
+          <p:cNvPr id="9" name="got circle 1"/>
           <p:cNvSpPr/>
           <p:nvPr/>
         </p:nvSpPr>
@@ -8843,7 +8843,7 @@
       </p:sp>
       <p:pic>
         <p:nvPicPr>
-          <p:cNvPr id="11" name="got icon 1" descr="preencoded.png">    </p:cNvPr>
+          <p:cNvPr id="10" name="got icon 1" descr="preencoded.png">    </p:cNvPr>
           <p:cNvPicPr>
             <a:picLocks noChangeAspect="1"/>
           </p:cNvPicPr>
@@ -8867,7 +8867,7 @@
       </p:pic>
       <p:sp>
         <p:nvSpPr>
-          <p:cNvPr id="12" name="got head 1"/>
+          <p:cNvPr id="11" name="got head 1"/>
           <p:cNvSpPr txBox="1"/>
           <p:nvPr/>
         </p:nvSpPr>
@@ -8903,7 +8903,7 @@
       </p:sp>
       <p:sp>
         <p:nvSpPr>
-          <p:cNvPr id="13" name="got text 1"/>
+          <p:cNvPr id="12" name="got text 1"/>
           <p:cNvSpPr txBox="1"/>
           <p:nvPr/>
         </p:nvSpPr>
@@ -8939,7 +8939,7 @@
       </p:sp>
       <p:sp>
         <p:nvSpPr>
-          <p:cNvPr id="14" name="got circle 2"/>
+          <p:cNvPr id="13" name="got circle 2"/>
           <p:cNvSpPr/>
           <p:nvPr/>
         </p:nvSpPr>
@@ -8964,7 +8964,7 @@
       </p:sp>
       <p:pic>
         <p:nvPicPr>
-          <p:cNvPr id="15" name="got icon 2" descr="preencoded.png">    </p:cNvPr>
+          <p:cNvPr id="14" name="got icon 2" descr="preencoded.png">    </p:cNvPr>
           <p:cNvPicPr>
             <a:picLocks noChangeAspect="1"/>
           </p:cNvPicPr>
@@ -8988,7 +8988,7 @@
       </p:pic>
       <p:sp>
         <p:nvSpPr>
-          <p:cNvPr id="16" name="got head 2"/>
+          <p:cNvPr id="15" name="got head 2"/>
           <p:cNvSpPr txBox="1"/>
           <p:nvPr/>
         </p:nvSpPr>
@@ -9024,7 +9024,7 @@
       </p:sp>
       <p:sp>
         <p:nvSpPr>
-          <p:cNvPr id="17" name="got text 2"/>
+          <p:cNvPr id="16" name="got text 2"/>
           <p:cNvSpPr txBox="1"/>
           <p:nvPr/>
         </p:nvSpPr>
@@ -9060,7 +9060,7 @@
       </p:sp>
       <p:sp>
         <p:nvSpPr>
-          <p:cNvPr id="18" name="got circle 3"/>
+          <p:cNvPr id="17" name="got circle 3"/>
           <p:cNvSpPr/>
           <p:nvPr/>
         </p:nvSpPr>
@@ -9085,7 +9085,7 @@
       </p:sp>
       <p:pic>
         <p:nvPicPr>
-          <p:cNvPr id="19" name="got icon 3" descr="preencoded.png">    </p:cNvPr>
+          <p:cNvPr id="18" name="got icon 3" descr="preencoded.png">    </p:cNvPr>
           <p:cNvPicPr>
             <a:picLocks noChangeAspect="1"/>
           </p:cNvPicPr>
@@ -9109,7 +9109,7 @@
       </p:pic>
       <p:sp>
         <p:nvSpPr>
-          <p:cNvPr id="20" name="got head 3"/>
+          <p:cNvPr id="19" name="got head 3"/>
           <p:cNvSpPr txBox="1"/>
           <p:nvPr/>
         </p:nvSpPr>
@@ -9145,7 +9145,7 @@
       </p:sp>
       <p:sp>
         <p:nvSpPr>
-          <p:cNvPr id="21" name="got text 3"/>
+          <p:cNvPr id="20" name="got text 3"/>
           <p:cNvSpPr txBox="1"/>
           <p:nvPr/>
         </p:nvSpPr>
@@ -9289,7 +9289,7 @@
       </p:sp>
       <p:sp>
         <p:nvSpPr>
-          <p:cNvPr id="4" name="url box"/>
+          <p:cNvPr id="3" name="url box"/>
           <p:cNvSpPr/>
           <p:nvPr/>
         </p:nvSpPr>
@@ -9316,7 +9316,7 @@
       </p:sp>
       <p:pic>
         <p:nvPicPr>
-          <p:cNvPr id="5" name="globe" descr="preencoded.png">    </p:cNvPr>
+          <p:cNvPr id="4" name="globe" descr="preencoded.png">    </p:cNvPr>
           <p:cNvPicPr>
             <a:picLocks noChangeAspect="1"/>
           </p:cNvPicPr>
@@ -9340,7 +9340,7 @@
       </p:pic>
       <p:sp>
         <p:nvSpPr>
-          <p:cNvPr id="6" name="url"/>
+          <p:cNvPr id="5" name="url"/>
           <p:cNvSpPr txBox="1"/>
           <p:nvPr/>
         </p:nvSpPr>
@@ -9388,7 +9388,7 @@
       </p:sp>
       <p:sp>
         <p:nvSpPr>
-          <p:cNvPr id="7" name="demo steps"/>
+          <p:cNvPr id="6" name="demo steps"/>
           <p:cNvSpPr txBox="1"/>
           <p:nvPr/>
         </p:nvSpPr>
@@ -9512,7 +9512,7 @@
       </p:sp>
       <p:pic>
         <p:nvPicPr>
-          <p:cNvPr id="8" name="screenshot integrity" descr="/home/claude/daromad/deck/img/integrity_risk.png">    </p:cNvPr>
+          <p:cNvPr id="7" name="screenshot integrity" descr="/home/claude/daromad/deck/img/integrity_risk.png">    </p:cNvPr>
           <p:cNvPicPr>
             <a:picLocks noChangeAspect="1"/>
           </p:cNvPicPr>
@@ -9536,7 +9536,7 @@
       </p:pic>
       <p:pic>
         <p:nvPicPr>
-          <p:cNvPr id="9" name="screenshot tamper" descr="/home/claude/daromad/deck/img/tamper.png">    </p:cNvPr>
+          <p:cNvPr id="8" name="screenshot tamper" descr="/home/claude/daromad/deck/img/tamper.png">    </p:cNvPr>
           <p:cNvPicPr>
             <a:picLocks noChangeAspect="1"/>
           </p:cNvPicPr>
@@ -9560,7 +9560,7 @@
       </p:pic>
       <p:pic>
         <p:nvPicPr>
-          <p:cNvPr id="10" name="qr site" descr="/home/claude/daromad/deck/img/qr_site.png">    </p:cNvPr>
+          <p:cNvPr id="9" name="qr site" descr="/home/claude/daromad/deck/img/qr_site.png">    </p:cNvPr>
           <p:cNvPicPr>
             <a:picLocks noChangeAspect="1"/>
           </p:cNvPicPr>
@@ -9584,7 +9584,7 @@
       </p:pic>
       <p:sp>
         <p:nvSpPr>
-          <p:cNvPr id="11" name="qr caption"/>
+          <p:cNvPr id="10" name="qr caption"/>
           <p:cNvSpPr txBox="1"/>
           <p:nvPr/>
         </p:nvSpPr>
@@ -9728,7 +9728,7 @@
       </p:sp>
       <p:sp>
         <p:nvSpPr>
-          <p:cNvPr id="4" name="component 0"/>
+          <p:cNvPr id="3" name="component 0"/>
           <p:cNvSpPr/>
           <p:nvPr/>
         </p:nvSpPr>
@@ -9755,7 +9755,7 @@
       </p:sp>
       <p:sp>
         <p:nvSpPr>
-          <p:cNvPr id="5" name="comp circle 0"/>
+          <p:cNvPr id="4" name="comp circle 0"/>
           <p:cNvSpPr/>
           <p:nvPr/>
         </p:nvSpPr>
@@ -9780,7 +9780,7 @@
       </p:sp>
       <p:pic>
         <p:nvPicPr>
-          <p:cNvPr id="6" name="comp icon 0" descr="preencoded.png">    </p:cNvPr>
+          <p:cNvPr id="5" name="comp icon 0" descr="preencoded.png">    </p:cNvPr>
           <p:cNvPicPr>
             <a:picLocks noChangeAspect="1"/>
           </p:cNvPicPr>
@@ -9804,7 +9804,7 @@
       </p:pic>
       <p:sp>
         <p:nvSpPr>
-          <p:cNvPr id="7" name="comp head 0"/>
+          <p:cNvPr id="6" name="comp head 0"/>
           <p:cNvSpPr txBox="1"/>
           <p:nvPr/>
         </p:nvSpPr>
@@ -9840,7 +9840,7 @@
       </p:sp>
       <p:sp>
         <p:nvSpPr>
-          <p:cNvPr id="8" name="comp text 0"/>
+          <p:cNvPr id="7" name="comp text 0"/>
           <p:cNvSpPr txBox="1"/>
           <p:nvPr/>
         </p:nvSpPr>
@@ -9876,7 +9876,7 @@
       </p:sp>
       <p:sp>
         <p:nvSpPr>
-          <p:cNvPr id="9" name="component 1"/>
+          <p:cNvPr id="8" name="component 1"/>
           <p:cNvSpPr/>
           <p:nvPr/>
         </p:nvSpPr>
@@ -9903,7 +9903,7 @@
       </p:sp>
       <p:sp>
         <p:nvSpPr>
-          <p:cNvPr id="10" name="comp circle 1"/>
+          <p:cNvPr id="9" name="comp circle 1"/>
           <p:cNvSpPr/>
           <p:nvPr/>
         </p:nvSpPr>
@@ -9928,7 +9928,7 @@
       </p:sp>
       <p:pic>
         <p:nvPicPr>
-          <p:cNvPr id="11" name="comp icon 1" descr="preencoded.png">    </p:cNvPr>
+          <p:cNvPr id="10" name="comp icon 1" descr="preencoded.png">    </p:cNvPr>
           <p:cNvPicPr>
             <a:picLocks noChangeAspect="1"/>
           </p:cNvPicPr>
@@ -9952,7 +9952,7 @@
       </p:pic>
       <p:sp>
         <p:nvSpPr>
-          <p:cNvPr id="12" name="comp head 1"/>
+          <p:cNvPr id="11" name="comp head 1"/>
           <p:cNvSpPr txBox="1"/>
           <p:nvPr/>
         </p:nvSpPr>
@@ -9988,7 +9988,7 @@
       </p:sp>
       <p:sp>
         <p:nvSpPr>
-          <p:cNvPr id="13" name="comp text 1"/>
+          <p:cNvPr id="12" name="comp text 1"/>
           <p:cNvSpPr txBox="1"/>
           <p:nvPr/>
         </p:nvSpPr>
@@ -10024,7 +10024,7 @@
       </p:sp>
       <p:sp>
         <p:nvSpPr>
-          <p:cNvPr id="14" name="component 2"/>
+          <p:cNvPr id="13" name="component 2"/>
           <p:cNvSpPr/>
           <p:nvPr/>
         </p:nvSpPr>
@@ -10051,7 +10051,7 @@
       </p:sp>
       <p:sp>
         <p:nvSpPr>
-          <p:cNvPr id="15" name="comp circle 2"/>
+          <p:cNvPr id="14" name="comp circle 2"/>
           <p:cNvSpPr/>
           <p:nvPr/>
         </p:nvSpPr>
@@ -10076,7 +10076,7 @@
       </p:sp>
       <p:pic>
         <p:nvPicPr>
-          <p:cNvPr id="16" name="comp icon 2" descr="preencoded.png">    </p:cNvPr>
+          <p:cNvPr id="15" name="comp icon 2" descr="preencoded.png">    </p:cNvPr>
           <p:cNvPicPr>
             <a:picLocks noChangeAspect="1"/>
           </p:cNvPicPr>
@@ -10100,7 +10100,7 @@
       </p:pic>
       <p:sp>
         <p:nvSpPr>
-          <p:cNvPr id="17" name="comp head 2"/>
+          <p:cNvPr id="16" name="comp head 2"/>
           <p:cNvSpPr txBox="1"/>
           <p:nvPr/>
         </p:nvSpPr>
@@ -10136,7 +10136,7 @@
       </p:sp>
       <p:sp>
         <p:nvSpPr>
-          <p:cNvPr id="18" name="comp text 2"/>
+          <p:cNvPr id="17" name="comp text 2"/>
           <p:cNvSpPr txBox="1"/>
           <p:nvPr/>
         </p:nvSpPr>
@@ -10172,7 +10172,7 @@
       </p:sp>
       <p:sp>
         <p:nvSpPr>
-          <p:cNvPr id="19" name="component 3"/>
+          <p:cNvPr id="18" name="component 3"/>
           <p:cNvSpPr/>
           <p:nvPr/>
         </p:nvSpPr>
@@ -10199,7 +10199,7 @@
       </p:sp>
       <p:sp>
         <p:nvSpPr>
-          <p:cNvPr id="20" name="comp circle 3"/>
+          <p:cNvPr id="19" name="comp circle 3"/>
           <p:cNvSpPr/>
           <p:nvPr/>
         </p:nvSpPr>
@@ -10224,7 +10224,7 @@
       </p:sp>
       <p:pic>
         <p:nvPicPr>
-          <p:cNvPr id="21" name="comp icon 3" descr="preencoded.png">    </p:cNvPr>
+          <p:cNvPr id="20" name="comp icon 3" descr="preencoded.png">    </p:cNvPr>
           <p:cNvPicPr>
             <a:picLocks noChangeAspect="1"/>
           </p:cNvPicPr>
@@ -10248,7 +10248,7 @@
       </p:pic>
       <p:sp>
         <p:nvSpPr>
-          <p:cNvPr id="22" name="comp head 3"/>
+          <p:cNvPr id="21" name="comp head 3"/>
           <p:cNvSpPr txBox="1"/>
           <p:nvPr/>
         </p:nvSpPr>
@@ -10284,7 +10284,7 @@
       </p:sp>
       <p:sp>
         <p:nvSpPr>
-          <p:cNvPr id="23" name="comp text 3"/>
+          <p:cNvPr id="22" name="comp text 3"/>
           <p:cNvSpPr txBox="1"/>
           <p:nvPr/>
         </p:nvSpPr>
@@ -10320,7 +10320,7 @@
       </p:sp>
       <p:sp>
         <p:nvSpPr>
-          <p:cNvPr id="24" name="component 4"/>
+          <p:cNvPr id="23" name="component 4"/>
           <p:cNvSpPr/>
           <p:nvPr/>
         </p:nvSpPr>
@@ -10347,7 +10347,7 @@
       </p:sp>
       <p:sp>
         <p:nvSpPr>
-          <p:cNvPr id="25" name="comp circle 4"/>
+          <p:cNvPr id="24" name="comp circle 4"/>
           <p:cNvSpPr/>
           <p:nvPr/>
         </p:nvSpPr>
@@ -10372,7 +10372,7 @@
       </p:sp>
       <p:pic>
         <p:nvPicPr>
-          <p:cNvPr id="26" name="comp icon 4" descr="preencoded.png">    </p:cNvPr>
+          <p:cNvPr id="25" name="comp icon 4" descr="preencoded.png">    </p:cNvPr>
           <p:cNvPicPr>
             <a:picLocks noChangeAspect="1"/>
           </p:cNvPicPr>
@@ -10396,7 +10396,7 @@
       </p:pic>
       <p:sp>
         <p:nvSpPr>
-          <p:cNvPr id="27" name="comp head 4"/>
+          <p:cNvPr id="26" name="comp head 4"/>
           <p:cNvSpPr txBox="1"/>
           <p:nvPr/>
         </p:nvSpPr>
@@ -10432,7 +10432,7 @@
       </p:sp>
       <p:sp>
         <p:nvSpPr>
-          <p:cNvPr id="28" name="comp text 4"/>
+          <p:cNvPr id="27" name="comp text 4"/>
           <p:cNvSpPr txBox="1"/>
           <p:nvPr/>
         </p:nvSpPr>
@@ -10468,7 +10468,7 @@
       </p:sp>
       <p:sp>
         <p:nvSpPr>
-          <p:cNvPr id="29" name="component 5"/>
+          <p:cNvPr id="28" name="component 5"/>
           <p:cNvSpPr/>
           <p:nvPr/>
         </p:nvSpPr>
@@ -10495,7 +10495,7 @@
       </p:sp>
       <p:sp>
         <p:nvSpPr>
-          <p:cNvPr id="30" name="comp circle 5"/>
+          <p:cNvPr id="29" name="comp circle 5"/>
           <p:cNvSpPr/>
           <p:nvPr/>
         </p:nvSpPr>
@@ -10520,7 +10520,7 @@
       </p:sp>
       <p:pic>
         <p:nvPicPr>
-          <p:cNvPr id="31" name="comp icon 5" descr="preencoded.png">    </p:cNvPr>
+          <p:cNvPr id="30" name="comp icon 5" descr="preencoded.png">    </p:cNvPr>
           <p:cNvPicPr>
             <a:picLocks noChangeAspect="1"/>
           </p:cNvPicPr>
@@ -10544,7 +10544,7 @@
       </p:pic>
       <p:sp>
         <p:nvSpPr>
-          <p:cNvPr id="32" name="comp head 5"/>
+          <p:cNvPr id="31" name="comp head 5"/>
           <p:cNvSpPr txBox="1"/>
           <p:nvPr/>
         </p:nvSpPr>
@@ -10580,7 +10580,7 @@
       </p:sp>
       <p:sp>
         <p:nvSpPr>
-          <p:cNvPr id="33" name="comp text 5"/>
+          <p:cNvPr id="32" name="comp text 5"/>
           <p:cNvSpPr txBox="1"/>
           <p:nvPr/>
         </p:nvSpPr>
@@ -10616,7 +10616,7 @@
       </p:sp>
       <p:sp>
         <p:nvSpPr>
-          <p:cNvPr id="34" name="component 6"/>
+          <p:cNvPr id="33" name="component 6"/>
           <p:cNvSpPr/>
           <p:nvPr/>
         </p:nvSpPr>
@@ -10643,7 +10643,7 @@
       </p:sp>
       <p:sp>
         <p:nvSpPr>
-          <p:cNvPr id="35" name="comp circle 6"/>
+          <p:cNvPr id="34" name="comp circle 6"/>
           <p:cNvSpPr/>
           <p:nvPr/>
         </p:nvSpPr>
@@ -10668,7 +10668,7 @@
       </p:sp>
       <p:pic>
         <p:nvPicPr>
-          <p:cNvPr id="36" name="comp icon 6" descr="preencoded.png">    </p:cNvPr>
+          <p:cNvPr id="35" name="comp icon 6" descr="preencoded.png">    </p:cNvPr>
           <p:cNvPicPr>
             <a:picLocks noChangeAspect="1"/>
           </p:cNvPicPr>
@@ -10692,7 +10692,7 @@
       </p:pic>
       <p:sp>
         <p:nvSpPr>
-          <p:cNvPr id="37" name="comp head 6"/>
+          <p:cNvPr id="36" name="comp head 6"/>
           <p:cNvSpPr txBox="1"/>
           <p:nvPr/>
         </p:nvSpPr>
@@ -10728,7 +10728,7 @@
       </p:sp>
       <p:sp>
         <p:nvSpPr>
-          <p:cNvPr id="38" name="comp text 6"/>
+          <p:cNvPr id="37" name="comp text 6"/>
           <p:cNvSpPr txBox="1"/>
           <p:nvPr/>
         </p:nvSpPr>
@@ -10764,7 +10764,7 @@
       </p:sp>
       <p:sp>
         <p:nvSpPr>
-          <p:cNvPr id="39" name="perimeter card"/>
+          <p:cNvPr id="38" name="perimeter card"/>
           <p:cNvSpPr/>
           <p:nvPr/>
         </p:nvSpPr>
@@ -10791,7 +10791,7 @@
       </p:sp>
       <p:pic>
         <p:nvPicPr>
-          <p:cNvPr id="40" name="perimeter icon" descr="preencoded.png">    </p:cNvPr>
+          <p:cNvPr id="39" name="perimeter icon" descr="preencoded.png">    </p:cNvPr>
           <p:cNvPicPr>
             <a:picLocks noChangeAspect="1"/>
           </p:cNvPicPr>
@@ -10815,7 +10815,7 @@
       </p:pic>
       <p:sp>
         <p:nvSpPr>
-          <p:cNvPr id="41" name="perimeter head"/>
+          <p:cNvPr id="40" name="perimeter head"/>
           <p:cNvSpPr txBox="1"/>
           <p:nvPr/>
         </p:nvSpPr>
@@ -10851,7 +10851,7 @@
       </p:sp>
       <p:sp>
         <p:nvSpPr>
-          <p:cNvPr id="42" name="perimeter text"/>
+          <p:cNvPr id="41" name="perimeter text"/>
           <p:cNvSpPr txBox="1"/>
           <p:nvPr/>
         </p:nvSpPr>
@@ -10887,7 +10887,7 @@
       </p:sp>
       <p:sp>
         <p:nvSpPr>
-          <p:cNvPr id="43" name="speed"/>
+          <p:cNvPr id="42" name="speed"/>
           <p:cNvSpPr txBox="1"/>
           <p:nvPr/>
         </p:nvSpPr>
@@ -10923,7 +10923,7 @@
       </p:sp>
       <p:sp>
         <p:nvSpPr>
-          <p:cNvPr id="44" name="hitl"/>
+          <p:cNvPr id="43" name="hitl"/>
           <p:cNvSpPr txBox="1"/>
           <p:nvPr/>
         </p:nvSpPr>
@@ -11067,7 +11067,7 @@
       </p:sp>
       <p:sp>
         <p:nvSpPr>
-          <p:cNvPr id="4" name="tile generator PDFs: exact rows, balance chain reconciled (2 layouts, RU/UZ)"/>
+          <p:cNvPr id="3" name="tile generator PDFs: exact rows, balance chain reconciled (2 layouts, RU/UZ)"/>
           <p:cNvSpPr/>
           <p:nvPr/>
         </p:nvSpPr>
@@ -11094,7 +11094,7 @@
       </p:sp>
       <p:sp>
         <p:nvSpPr>
-          <p:cNvPr id="5" name="tile value generator PDFs: exact rows, balance chain reconciled (2 layouts, RU/UZ)"/>
+          <p:cNvPr id="4" name="tile value generator PDFs: exact rows, balance chain reconciled (2 layouts, RU/UZ)"/>
           <p:cNvSpPr txBox="1"/>
           <p:nvPr/>
         </p:nvSpPr>
@@ -11130,7 +11130,7 @@
       </p:sp>
       <p:sp>
         <p:nvSpPr>
-          <p:cNvPr id="6" name="tile label generator PDFs: exact rows, balance chain reconciled (2 layouts, RU/UZ)"/>
+          <p:cNvPr id="5" name="tile label generator PDFs: exact rows, balance chain reconciled (2 layouts, RU/UZ)"/>
           <p:cNvSpPr txBox="1"/>
           <p:nvPr/>
         </p:nvSpPr>
@@ -11166,7 +11166,7 @@
       </p:sp>
       <p:sp>
         <p:nvSpPr>
-          <p:cNvPr id="7" name="tile unseen layouts exact — CSV/XLSX/TSV variants incl. a wallet export (list on the model card)"/>
+          <p:cNvPr id="6" name="tile unseen layouts exact — CSV/XLSX/TSV variants incl. a wallet export (list on the model card)"/>
           <p:cNvSpPr/>
           <p:nvPr/>
         </p:nvSpPr>
@@ -11193,7 +11193,7 @@
       </p:sp>
       <p:sp>
         <p:nvSpPr>
-          <p:cNvPr id="8" name="tile value unseen layouts exact — CSV/XLSX/TSV variants incl. a wallet export (list on the model card)"/>
+          <p:cNvPr id="7" name="tile value unseen layouts exact — CSV/XLSX/TSV variants incl. a wallet export (list on the model card)"/>
           <p:cNvSpPr txBox="1"/>
           <p:nvPr/>
         </p:nvSpPr>
@@ -11229,7 +11229,7 @@
       </p:sp>
       <p:sp>
         <p:nvSpPr>
-          <p:cNvPr id="9" name="tile label unseen layouts exact — CSV/XLSX/TSV variants incl. a wallet export (list on the model card)"/>
+          <p:cNvPr id="8" name="tile label unseen layouts exact — CSV/XLSX/TSV variants incl. a wallet export (list on the model card)"/>
           <p:cNvSpPr txBox="1"/>
           <p:nvPr/>
         </p:nvSpPr>
@@ -11265,7 +11265,7 @@
       </p:sp>
       <p:sp>
         <p:nvSpPr>
-          <p:cNvPr id="10" name="tile tampered statements caught, 4 tamper types; 0 false alarms on clean ones"/>
+          <p:cNvPr id="9" name="tile tampered statements caught, 4 tamper types; 0 false alarms on clean ones"/>
           <p:cNvSpPr/>
           <p:nvPr/>
         </p:nvSpPr>
@@ -11292,7 +11292,7 @@
       </p:sp>
       <p:sp>
         <p:nvSpPr>
-          <p:cNvPr id="11" name="tile value tampered statements caught, 4 tamper types; 0 false alarms on clean ones"/>
+          <p:cNvPr id="10" name="tile value tampered statements caught, 4 tamper types; 0 false alarms on clean ones"/>
           <p:cNvSpPr txBox="1"/>
           <p:nvPr/>
         </p:nvSpPr>
@@ -11328,7 +11328,7 @@
       </p:sp>
       <p:sp>
         <p:nvSpPr>
-          <p:cNvPr id="12" name="tile label tampered statements caught, 4 tamper types; 0 false alarms on clean ones"/>
+          <p:cNvPr id="11" name="tile label tampered statements caught, 4 tamper types; 0 false alarms on clean ones"/>
           <p:cNvSpPr txBox="1"/>
           <p:nvPr/>
         </p:nvSpPr>
@@ -11364,7 +11364,7 @@
       </p:sp>
       <p:sp>
         <p:nvSpPr>
-          <p:cNvPr id="13" name="tile receipt OCR total exact, 60 camera-augmented photos; INN 100%, date 97%"/>
+          <p:cNvPr id="12" name="tile receipt OCR total exact, 60 camera-augmented photos; INN 100%, date 97%"/>
           <p:cNvSpPr/>
           <p:nvPr/>
         </p:nvSpPr>
@@ -11391,7 +11391,7 @@
       </p:sp>
       <p:sp>
         <p:nvSpPr>
-          <p:cNvPr id="14" name="tile value receipt OCR total exact, 60 camera-augmented photos; INN 100%, date 97%"/>
+          <p:cNvPr id="13" name="tile value receipt OCR total exact, 60 camera-augmented photos; INN 100%, date 97%"/>
           <p:cNvSpPr txBox="1"/>
           <p:nvPr/>
         </p:nvSpPr>
@@ -11427,7 +11427,7 @@
       </p:sp>
       <p:sp>
         <p:nvSpPr>
-          <p:cNvPr id="15" name="tile label receipt OCR total exact, 60 camera-augmented photos; INN 100%, date 97%"/>
+          <p:cNvPr id="14" name="tile label receipt OCR total exact, 60 camera-augmented photos; INN 100%, date 97%"/>
           <p:cNvSpPr txBox="1"/>
           <p:nvPr/>
         </p:nvSpPr>
@@ -11463,7 +11463,7 @@
       </p:sp>
       <p:sp>
         <p:nvSpPr>
-          <p:cNvPr id="16" name="tile ROC-AUC, synthetic holdout n=500; logistic 0.963, ratio alone 0.948"/>
+          <p:cNvPr id="15" name="tile ROC-AUC, synthetic holdout n=500; logistic 0.963, ratio alone 0.948"/>
           <p:cNvSpPr/>
           <p:nvPr/>
         </p:nvSpPr>
@@ -11490,7 +11490,7 @@
       </p:sp>
       <p:sp>
         <p:nvSpPr>
-          <p:cNvPr id="17" name="tile value ROC-AUC, synthetic holdout n=500; logistic 0.963, ratio alone 0.948"/>
+          <p:cNvPr id="16" name="tile value ROC-AUC, synthetic holdout n=500; logistic 0.963, ratio alone 0.948"/>
           <p:cNvSpPr txBox="1"/>
           <p:nvPr/>
         </p:nvSpPr>
@@ -11526,7 +11526,7 @@
       </p:sp>
       <p:sp>
         <p:nvSpPr>
-          <p:cNvPr id="18" name="tile label ROC-AUC, synthetic holdout n=500; logistic 0.963, ratio alone 0.948"/>
+          <p:cNvPr id="17" name="tile label ROC-AUC, synthetic holdout n=500; logistic 0.963, ratio alone 0.948"/>
           <p:cNvSpPr txBox="1"/>
           <p:nvPr/>
         </p:nvSpPr>
@@ -11562,7 +11562,7 @@
       </p:sp>
       <p:sp>
         <p:nvSpPr>
-          <p:cNvPr id="19" name="tile ROC-AUC, real bank data (Berka, 443 loans, 44 bad; 95% CI ≈ 0.86–0.94); ratio alone 0.735"/>
+          <p:cNvPr id="18" name="tile ROC-AUC, real bank data (Berka, 443 loans, 44 bad; 95% CI ≈ 0.86–0.94); ratio alone 0.735"/>
           <p:cNvSpPr/>
           <p:nvPr/>
         </p:nvSpPr>
@@ -11589,7 +11589,7 @@
       </p:sp>
       <p:sp>
         <p:nvSpPr>
-          <p:cNvPr id="20" name="tile value ROC-AUC, real bank data (Berka, 443 loans, 44 bad; 95% CI ≈ 0.86–0.94); ratio alone 0.735"/>
+          <p:cNvPr id="19" name="tile value ROC-AUC, real bank data (Berka, 443 loans, 44 bad; 95% CI ≈ 0.86–0.94); ratio alone 0.735"/>
           <p:cNvSpPr txBox="1"/>
           <p:nvPr/>
         </p:nvSpPr>
@@ -11625,7 +11625,7 @@
       </p:sp>
       <p:sp>
         <p:nvSpPr>
-          <p:cNvPr id="21" name="tile label ROC-AUC, real bank data (Berka, 443 loans, 44 bad; 95% CI ≈ 0.86–0.94); ratio alone 0.735"/>
+          <p:cNvPr id="20" name="tile label ROC-AUC, real bank data (Berka, 443 loans, 44 bad; 95% CI ≈ 0.86–0.94); ratio alone 0.735"/>
           <p:cNvSpPr txBox="1"/>
           <p:nvPr/>
         </p:nvSpPr>
@@ -11661,7 +11661,7 @@
       </p:sp>
       <p:graphicFrame>
         <p:nvGraphicFramePr>
-          <p:cNvPr id="22" name="Chart 0" descr=""/>
+          <p:cNvPr id="21" name="Chart 0" descr=""/>
           <p:cNvGraphicFramePr/>
           <p:nvPr/>
         </p:nvGraphicFramePr>
@@ -11677,7 +11677,7 @@
       </p:graphicFrame>
       <p:sp>
         <p:nvSpPr>
-          <p:cNvPr id="23" name="reading"/>
+          <p:cNvPr id="22" name="reading"/>
           <p:cNvSpPr txBox="1"/>
           <p:nvPr/>
         </p:nvSpPr>
@@ -11713,7 +11713,7 @@
       </p:sp>
       <p:pic>
         <p:nvPicPr>
-          <p:cNvPr id="24" name="screenshot eval" descr="/home/claude/daromad/deck/img/eval_kpis.png">    </p:cNvPr>
+          <p:cNvPr id="23" name="screenshot eval" descr="/home/claude/daromad/deck/img/eval_kpis.png">    </p:cNvPr>
           <p:cNvPicPr>
             <a:picLocks noChangeAspect="1"/>
           </p:cNvPicPr>
@@ -11737,7 +11737,7 @@
       </p:pic>
       <p:sp>
         <p:nvSpPr>
-          <p:cNvPr id="25" name="provenance"/>
+          <p:cNvPr id="24" name="provenance"/>
           <p:cNvSpPr txBox="1"/>
           <p:nvPr/>
         </p:nvSpPr>
@@ -11773,7 +11773,7 @@
       </p:sp>
       <p:sp>
         <p:nvSpPr>
-          <p:cNvPr id="26" name="caveat"/>
+          <p:cNvPr id="25" name="caveat"/>
           <p:cNvSpPr txBox="1"/>
           <p:nvPr/>
         </p:nvSpPr>
@@ -11917,7 +11917,7 @@
       </p:sp>
       <p:sp>
         <p:nvSpPr>
-          <p:cNvPr id="4" name="gen num bg 0"/>
+          <p:cNvPr id="3" name="gen num bg 0"/>
           <p:cNvSpPr/>
           <p:nvPr/>
         </p:nvSpPr>
@@ -11942,7 +11942,7 @@
       </p:sp>
       <p:sp>
         <p:nvSpPr>
-          <p:cNvPr id="5" name="gen num 0"/>
+          <p:cNvPr id="4" name="gen num 0"/>
           <p:cNvSpPr txBox="1"/>
           <p:nvPr/>
         </p:nvSpPr>
@@ -11978,7 +11978,7 @@
       </p:sp>
       <p:sp>
         <p:nvSpPr>
-          <p:cNvPr id="6" name="gen head 0"/>
+          <p:cNvPr id="5" name="gen head 0"/>
           <p:cNvSpPr txBox="1"/>
           <p:nvPr/>
         </p:nvSpPr>
@@ -12014,7 +12014,7 @@
       </p:sp>
       <p:sp>
         <p:nvSpPr>
-          <p:cNvPr id="7" name="gen text 0"/>
+          <p:cNvPr id="6" name="gen text 0"/>
           <p:cNvSpPr txBox="1"/>
           <p:nvPr/>
         </p:nvSpPr>
@@ -12050,7 +12050,7 @@
       </p:sp>
       <p:sp>
         <p:nvSpPr>
-          <p:cNvPr id="8" name="gen num bg 1"/>
+          <p:cNvPr id="7" name="gen num bg 1"/>
           <p:cNvSpPr/>
           <p:nvPr/>
         </p:nvSpPr>
@@ -12075,7 +12075,7 @@
       </p:sp>
       <p:sp>
         <p:nvSpPr>
-          <p:cNvPr id="9" name="gen num 1"/>
+          <p:cNvPr id="8" name="gen num 1"/>
           <p:cNvSpPr txBox="1"/>
           <p:nvPr/>
         </p:nvSpPr>
@@ -12111,7 +12111,7 @@
       </p:sp>
       <p:sp>
         <p:nvSpPr>
-          <p:cNvPr id="10" name="gen head 1"/>
+          <p:cNvPr id="9" name="gen head 1"/>
           <p:cNvSpPr txBox="1"/>
           <p:nvPr/>
         </p:nvSpPr>
@@ -12147,7 +12147,7 @@
       </p:sp>
       <p:sp>
         <p:nvSpPr>
-          <p:cNvPr id="11" name="gen text 1"/>
+          <p:cNvPr id="10" name="gen text 1"/>
           <p:cNvSpPr txBox="1"/>
           <p:nvPr/>
         </p:nvSpPr>
@@ -12183,7 +12183,7 @@
       </p:sp>
       <p:sp>
         <p:nvSpPr>
-          <p:cNvPr id="12" name="gen num bg 2"/>
+          <p:cNvPr id="11" name="gen num bg 2"/>
           <p:cNvSpPr/>
           <p:nvPr/>
         </p:nvSpPr>
@@ -12208,7 +12208,7 @@
       </p:sp>
       <p:sp>
         <p:nvSpPr>
-          <p:cNvPr id="13" name="gen num 2"/>
+          <p:cNvPr id="12" name="gen num 2"/>
           <p:cNvSpPr txBox="1"/>
           <p:nvPr/>
         </p:nvSpPr>
@@ -12244,7 +12244,7 @@
       </p:sp>
       <p:sp>
         <p:nvSpPr>
-          <p:cNvPr id="14" name="gen head 2"/>
+          <p:cNvPr id="13" name="gen head 2"/>
           <p:cNvSpPr txBox="1"/>
           <p:nvPr/>
         </p:nvSpPr>
@@ -12280,7 +12280,7 @@
       </p:sp>
       <p:sp>
         <p:nvSpPr>
-          <p:cNvPr id="15" name="gen text 2"/>
+          <p:cNvPr id="14" name="gen text 2"/>
           <p:cNvSpPr txBox="1"/>
           <p:nvPr/>
         </p:nvSpPr>
@@ -12316,7 +12316,7 @@
       </p:sp>
       <p:sp>
         <p:nvSpPr>
-          <p:cNvPr id="16" name="gen num bg 3"/>
+          <p:cNvPr id="15" name="gen num bg 3"/>
           <p:cNvSpPr/>
           <p:nvPr/>
         </p:nvSpPr>
@@ -12341,7 +12341,7 @@
       </p:sp>
       <p:sp>
         <p:nvSpPr>
-          <p:cNvPr id="17" name="gen num 3"/>
+          <p:cNvPr id="16" name="gen num 3"/>
           <p:cNvSpPr txBox="1"/>
           <p:nvPr/>
         </p:nvSpPr>
@@ -12377,7 +12377,7 @@
       </p:sp>
       <p:sp>
         <p:nvSpPr>
-          <p:cNvPr id="18" name="gen head 3"/>
+          <p:cNvPr id="17" name="gen head 3"/>
           <p:cNvSpPr txBox="1"/>
           <p:nvPr/>
         </p:nvSpPr>
@@ -12413,7 +12413,7 @@
       </p:sp>
       <p:sp>
         <p:nvSpPr>
-          <p:cNvPr id="19" name="gen text 3"/>
+          <p:cNvPr id="18" name="gen text 3"/>
           <p:cNvSpPr txBox="1"/>
           <p:nvPr/>
         </p:nvSpPr>
@@ -12449,7 +12449,7 @@
       </p:sp>
       <p:sp>
         <p:nvSpPr>
-          <p:cNvPr id="20" name="gen num bg 4"/>
+          <p:cNvPr id="19" name="gen num bg 4"/>
           <p:cNvSpPr/>
           <p:nvPr/>
         </p:nvSpPr>
@@ -12474,7 +12474,7 @@
       </p:sp>
       <p:sp>
         <p:nvSpPr>
-          <p:cNvPr id="21" name="gen num 4"/>
+          <p:cNvPr id="20" name="gen num 4"/>
           <p:cNvSpPr txBox="1"/>
           <p:nvPr/>
         </p:nvSpPr>
@@ -12510,7 +12510,7 @@
       </p:sp>
       <p:sp>
         <p:nvSpPr>
-          <p:cNvPr id="22" name="gen head 4"/>
+          <p:cNvPr id="21" name="gen head 4"/>
           <p:cNvSpPr txBox="1"/>
           <p:nvPr/>
         </p:nvSpPr>
@@ -12546,7 +12546,7 @@
       </p:sp>
       <p:sp>
         <p:nvSpPr>
-          <p:cNvPr id="23" name="gen text 4"/>
+          <p:cNvPr id="22" name="gen text 4"/>
           <p:cNvSpPr txBox="1"/>
           <p:nvPr/>
         </p:nvSpPr>
@@ -12582,7 +12582,7 @@
       </p:sp>
       <p:pic>
         <p:nvPicPr>
-          <p:cNvPr id="24" name="statement thumbnail" descr="/home/claude/daromad/deck/img/stmt-01.jpg">    </p:cNvPr>
+          <p:cNvPr id="23" name="statement thumbnail" descr="/home/claude/daromad/deck/img/stmt-01.jpg">    </p:cNvPr>
           <p:cNvPicPr>
             <a:picLocks noChangeAspect="1"/>
           </p:cNvPicPr>
@@ -12606,7 +12606,7 @@
       </p:pic>
       <p:pic>
         <p:nvPicPr>
-          <p:cNvPr id="25" name="receipt photo" descr="/home/claude/daromad/deck/img/receipt.jpg">    </p:cNvPr>
+          <p:cNvPr id="24" name="receipt photo" descr="/home/claude/daromad/deck/img/receipt.jpg">    </p:cNvPr>
           <p:cNvPicPr>
             <a:picLocks noChangeAspect="1"/>
           </p:cNvPicPr>
@@ -12630,7 +12630,7 @@
       </p:pic>
       <p:sp>
         <p:nvSpPr>
-          <p:cNvPr id="26" name="image caption"/>
+          <p:cNvPr id="25" name="image caption"/>
           <p:cNvSpPr txBox="1"/>
           <p:nvPr/>
         </p:nvSpPr>
@@ -12666,7 +12666,7 @@
       </p:sp>
       <p:sp>
         <p:nvSpPr>
-          <p:cNvPr id="27" name="regen cmd"/>
+          <p:cNvPr id="26" name="regen cmd"/>
           <p:cNvSpPr txBox="1"/>
           <p:nvPr/>
         </p:nvSpPr>
@@ -12705,7 +12705,7 @@
       </p:sp>
       <p:sp>
         <p:nvSpPr>
-          <p:cNvPr id="28" name="berka note"/>
+          <p:cNvPr id="27" name="berka note"/>
           <p:cNvSpPr txBox="1"/>
           <p:nvPr/>
         </p:nvSpPr>
@@ -12849,7 +12849,7 @@
       </p:sp>
       <p:sp>
         <p:nvSpPr>
-          <p:cNvPr id="4" name="cost caption"/>
+          <p:cNvPr id="3" name="cost caption"/>
           <p:cNvSpPr txBox="1"/>
           <p:nvPr/>
         </p:nvSpPr>
@@ -14203,7 +14203,7 @@
       </p:graphicFrame>
       <p:sp>
         <p:nvSpPr>
-          <p:cNvPr id="6" name="run cost"/>
+          <p:cNvPr id="5" name="run cost"/>
           <p:cNvSpPr txBox="1"/>
           <p:nvPr/>
         </p:nvSpPr>
@@ -14239,7 +14239,7 @@
       </p:sp>
       <p:sp>
         <p:nvSpPr>
-          <p:cNvPr id="7" name="timeline"/>
+          <p:cNvPr id="6" name="timeline"/>
           <p:cNvSpPr txBox="1"/>
           <p:nvPr/>
         </p:nvSpPr>
@@ -14275,7 +14275,7 @@
       </p:sp>
       <p:sp>
         <p:nvSpPr>
-          <p:cNvPr id="8" name="value caption"/>
+          <p:cNvPr id="7" name="value caption"/>
           <p:cNvSpPr txBox="1"/>
           <p:nvPr/>
         </p:nvSpPr>
@@ -14311,7 +14311,7 @@
       </p:sp>
       <p:sp>
         <p:nvSpPr>
-          <p:cNvPr id="9" name="tile document handling per application, before → with Daromad (assumption 1; the pilot measures it)"/>
+          <p:cNvPr id="8" name="tile document handling per application, before → with Daromad (assumption 1; the pilot measures it)"/>
           <p:cNvSpPr/>
           <p:nvPr/>
         </p:nvSpPr>
@@ -14338,7 +14338,7 @@
       </p:sp>
       <p:sp>
         <p:nvSpPr>
-          <p:cNvPr id="10" name="tile value document handling per application, before → with Daromad (assumption 1; the pilot measures it)"/>
+          <p:cNvPr id="9" name="tile value document handling per application, before → with Daromad (assumption 1; the pilot measures it)"/>
           <p:cNvSpPr txBox="1"/>
           <p:nvPr/>
         </p:nvSpPr>
@@ -14374,7 +14374,7 @@
       </p:sp>
       <p:sp>
         <p:nvSpPr>
-          <p:cNvPr id="11" name="tile label document handling per application, before → with Daromad (assumption 1; the pilot measures it)"/>
+          <p:cNvPr id="10" name="tile label document handling per application, before → with Daromad (assumption 1; the pilot measures it)"/>
           <p:cNvSpPr txBox="1"/>
           <p:nvPr/>
         </p:nvSpPr>
@@ -14410,7 +14410,7 @@
       </p:sp>
       <p:sp>
         <p:nvSpPr>
-          <p:cNvPr id="12" name="tile addressable applications: 30% of MKBANK's 140,000 micro-projects (bank's own 2026 target) — those outside the ПДН-exempt family programme (assumption 2)"/>
+          <p:cNvPr id="11" name="tile addressable applications: 30% of MKBANK's 140,000 micro-projects (bank's own 2026 target) — those outside the ПДН-exempt family programme (assumption 2)"/>
           <p:cNvSpPr/>
           <p:nvPr/>
         </p:nvSpPr>
@@ -14437,7 +14437,7 @@
       </p:sp>
       <p:sp>
         <p:nvSpPr>
-          <p:cNvPr id="13" name="tile value addressable applications: 30% of MKBANK&amp;apos;s 140,000 micro-projects (bank&amp;apos;s own 2026 target) — those outside the ПДН-exempt family programme (assumption 2)"/>
+          <p:cNvPr id="12" name="tile value addressable applications: 30% of MKBANK&amp;apos;s 140,000 micro-projects (bank&amp;apos;s own 2026 target) — those outside the ПДН-exempt family programme (assumption 2)"/>
           <p:cNvSpPr txBox="1"/>
           <p:nvPr/>
         </p:nvSpPr>
@@ -14473,7 +14473,7 @@
       </p:sp>
       <p:sp>
         <p:nvSpPr>
-          <p:cNvPr id="14" name="tile label addressable applications: 30% of MKBANK&amp;apos;s 140,000 micro-projects (bank&amp;apos;s own 2026 target) — those outside the ПДН-exempt family programme (assumption 2)"/>
+          <p:cNvPr id="13" name="tile label addressable applications: 30% of MKBANK&amp;apos;s 140,000 micro-projects (bank&amp;apos;s own 2026 target) — those outside the ПДН-exempt family programme (assumption 2)"/>
           <p:cNvSpPr txBox="1"/>
           <p:nvPr/>
         </p:nvSpPr>
@@ -14509,7 +14509,7 @@
       </p:sp>
       <p:sp>
         <p:nvSpPr>
-          <p:cNvPr id="15" name="tile officer-hours saved per year = 42,000 × 65 min ≈ 23 FTE-years at 2,000 h"/>
+          <p:cNvPr id="14" name="tile officer-hours saved per year = 42,000 × 65 min ≈ 23 FTE-years at 2,000 h"/>
           <p:cNvSpPr/>
           <p:nvPr/>
         </p:nvSpPr>
@@ -14536,7 +14536,7 @@
       </p:sp>
       <p:sp>
         <p:nvSpPr>
-          <p:cNvPr id="16" name="tile value officer-hours saved per year = 42,000 × 65 min ≈ 23 FTE-years at 2,000 h"/>
+          <p:cNvPr id="15" name="tile value officer-hours saved per year = 42,000 × 65 min ≈ 23 FTE-years at 2,000 h"/>
           <p:cNvSpPr txBox="1"/>
           <p:nvPr/>
         </p:nvSpPr>
@@ -14572,7 +14572,7 @@
       </p:sp>
       <p:sp>
         <p:nvSpPr>
-          <p:cNvPr id="17" name="tile label officer-hours saved per year = 42,000 × 65 min ≈ 23 FTE-years at 2,000 h"/>
+          <p:cNvPr id="16" name="tile label officer-hours saved per year = 42,000 × 65 min ≈ 23 FTE-years at 2,000 h"/>
           <p:cNvSpPr txBox="1"/>
           <p:nvPr/>
         </p:nvSpPr>
@@ -14608,7 +14608,7 @@
       </p:sp>
       <p:sp>
         <p:nvSpPr>
-          <p:cNvPr id="18" name="tile 23 FTE × 15M/month × 12 — officer time only; at a 10% addressable share ≈ 1.4 bn"/>
+          <p:cNvPr id="17" name="tile 23 FTE × 15M/month × 12 — officer time only; at a 10% addressable share ≈ 1.4 bn"/>
           <p:cNvSpPr/>
           <p:nvPr/>
         </p:nvSpPr>
@@ -14635,7 +14635,7 @@
       </p:sp>
       <p:sp>
         <p:nvSpPr>
-          <p:cNvPr id="19" name="tile value 23 FTE × 15M/month × 12 — officer time only; at a 10% addressable share ≈ 1.4 bn"/>
+          <p:cNvPr id="18" name="tile value 23 FTE × 15M/month × 12 — officer time only; at a 10% addressable share ≈ 1.4 bn"/>
           <p:cNvSpPr txBox="1"/>
           <p:nvPr/>
         </p:nvSpPr>
@@ -14671,7 +14671,7 @@
       </p:sp>
       <p:sp>
         <p:nvSpPr>
-          <p:cNvPr id="20" name="tile label 23 FTE × 15M/month × 12 — officer time only; at a 10% addressable share ≈ 1.4 bn"/>
+          <p:cNvPr id="19" name="tile label 23 FTE × 15M/month × 12 — officer time only; at a 10% addressable share ≈ 1.4 bn"/>
           <p:cNvSpPr txBox="1"/>
           <p:nvPr/>
         </p:nvSpPr>
@@ -14707,7 +14707,7 @@
       </p:sp>
       <p:sp>
         <p:nvSpPr>
-          <p:cNvPr id="21" name="payback"/>
+          <p:cNvPr id="20" name="payback"/>
           <p:cNvSpPr txBox="1"/>
           <p:nvPr/>
         </p:nvSpPr>
@@ -14754,7 +14754,7 @@
       </p:sp>
       <p:sp>
         <p:nvSpPr>
-          <p:cNvPr id="22" name="owner"/>
+          <p:cNvPr id="21" name="owner"/>
           <p:cNvSpPr txBox="1"/>
           <p:nvPr/>
         </p:nvSpPr>
@@ -14898,7 +14898,7 @@
       </p:sp>
       <p:sp>
         <p:nvSpPr>
-          <p:cNvPr id="4" name="replication card"/>
+          <p:cNvPr id="3" name="replication card"/>
           <p:cNvSpPr/>
           <p:nvPr/>
         </p:nvSpPr>
@@ -14925,7 +14925,7 @@
       </p:sp>
       <p:pic>
         <p:nvPicPr>
-          <p:cNvPr id="5" name="lock icon" descr="preencoded.png">    </p:cNvPr>
+          <p:cNvPr id="4" name="lock icon" descr="preencoded.png">    </p:cNvPr>
           <p:cNvPicPr>
             <a:picLocks noChangeAspect="1"/>
           </p:cNvPicPr>
@@ -14949,7 +14949,7 @@
       </p:pic>
       <p:sp>
         <p:nvSpPr>
-          <p:cNvPr id="6" name="replication head"/>
+          <p:cNvPr id="5" name="replication head"/>
           <p:cNvSpPr txBox="1"/>
           <p:nvPr/>
         </p:nvSpPr>
@@ -14985,7 +14985,7 @@
       </p:sp>
       <p:sp>
         <p:nvSpPr>
-          <p:cNvPr id="7" name="bullets"/>
+          <p:cNvPr id="6" name="bullets"/>
           <p:cNvSpPr txBox="1"/>
           <p:nvPr/>
         </p:nvSpPr>
@@ -15115,7 +15115,7 @@
       </p:sp>
       <p:sp>
         <p:nvSpPr>
-          <p:cNvPr id="8" name="next card"/>
+          <p:cNvPr id="7" name="next card"/>
           <p:cNvSpPr/>
           <p:nvPr/>
         </p:nvSpPr>
@@ -15142,7 +15142,7 @@
       </p:sp>
       <p:pic>
         <p:nvPicPr>
-          <p:cNvPr id="9" name="layers icon" descr="preencoded.png">    </p:cNvPr>
+          <p:cNvPr id="8" name="layers icon" descr="preencoded.png">    </p:cNvPr>
           <p:cNvPicPr>
             <a:picLocks noChangeAspect="1"/>
           </p:cNvPicPr>
@@ -15166,7 +15166,7 @@
       </p:pic>
       <p:sp>
         <p:nvSpPr>
-          <p:cNvPr id="10" name="next head"/>
+          <p:cNvPr id="9" name="next head"/>
           <p:cNvSpPr txBox="1"/>
           <p:nvPr/>
         </p:nvSpPr>
@@ -15202,7 +15202,7 @@
       </p:sp>
       <p:sp>
         <p:nvSpPr>
-          <p:cNvPr id="11" name="bullets"/>
+          <p:cNvPr id="10" name="bullets"/>
           <p:cNvSpPr txBox="1"/>
           <p:nvPr/>
         </p:nvSpPr>

</xml_diff>

<commit_message>
Team member names removed from the deck, README, About page and explainer (roles kept, team name only)
Co-Authored-By: Claude Fable 5.1 <noreply@anthropic.com>
Claude-Session: https://claude.ai/code/session_01Xf5A9DfRgzoaeNELy2iEQH
</commit_message>
<xml_diff>
--- a/deck/Daromad_TYS_deck.pptx
+++ b/deck/Daromad_TYS_deck.pptx
@@ -119,41 +119,41 @@
   <p:extLst>
     <p:ext uri="{521415D9-36F7-43E2-AB2F-B90AF26B5E84}">
       <p14:sectionLst xmlns:p14="http://schemas.microsoft.com/office/powerpoint/2010/main">
-        <p14:section name="Opening" id="{2ef7c5dc-1b20-777c-3361-76c501ab0764}">
+        <p14:section name="Opening" id="{f3bd124d-1b49-8b76-fb78-a161188864c1}">
           <p14:sldIdLst>
             <p14:sldId id="256"/>
           </p14:sldIdLst>
         </p14:section>
-        <p14:section name="Problem" id="{38faace6-e5a1-2b58-da4c-bb08b1d08bdc}">
+        <p14:section name="Problem" id="{ca8e37c9-0b22-933b-569f-32ce8f8f2672}">
           <p14:sldIdLst>
             <p14:sldId id="257"/>
           </p14:sldIdLst>
         </p14:section>
-        <p14:section name="Product" id="{95fd892f-f192-725f-2899-04189a4d2c58}">
+        <p14:section name="Product" id="{ac463876-0f77-3ed9-771d-38016bef3bc5}">
           <p14:sldIdLst>
             <p14:sldId id="258"/>
             <p14:sldId id="259"/>
           </p14:sldIdLst>
         </p14:section>
-        <p14:section name="Technology" id="{e0481e38-72c0-b852-1b8f-c064c7704edb}">
+        <p14:section name="Technology" id="{d155d059-84f8-3978-3394-803e4ee176a5}">
           <p14:sldIdLst>
             <p14:sldId id="260"/>
             <p14:sldId id="261"/>
             <p14:sldId id="262"/>
           </p14:sldIdLst>
         </p14:section>
-        <p14:section name="Business" id="{f99bf22f-4f3f-c219-9b01-6debca81cf48}">
+        <p14:section name="Business" id="{2b1269ee-ce9d-ee61-993c-095dab69efa1}">
           <p14:sldIdLst>
             <p14:sldId id="263"/>
             <p14:sldId id="264"/>
           </p14:sldIdLst>
         </p14:section>
-        <p14:section name="Closing" id="{b1de8647-c932-763d-1d74-746b718224ec}">
+        <p14:section name="Closing" id="{da016894-d388-24e1-884c-eefa20ab6f52}">
           <p14:sldIdLst>
             <p14:sldId id="265"/>
           </p14:sldIdLst>
         </p14:section>
-        <p14:section name="Appendix" id="{6951bb94-a65b-0796-9b2f-11afe6bb49c2}">
+        <p14:section name="Appendix" id="{23f3084f-c015-3c32-e505-c3e55e68edf4}">
           <p14:sldIdLst>
             <p14:sldId id="266"/>
             <p14:sldId id="267"/>
@@ -2881,7 +2881,7 @@
                   <a:srgbClr val="E9F1EC"/>
                 </a:solidFill>
               </a:rPr>
-              <a:t>Munisbek (technical lead) · Jahongir (research &amp; data) · Umida (compliance &amp; business case)</a:t>
+              <a:t>three members — technical lead · research &amp; data · compliance &amp; business case</a:t>
             </a:r>
             <a:endParaRPr lang="en-US" sz="1500" dirty="0"/>
           </a:p>
@@ -3229,18 +3229,7 @@
                   <a:srgbClr val="8FB8A5"/>
                 </a:solidFill>
               </a:rPr>
-              <a:t>Team TYS:  </a:t>
-            </a:r>
-            <a:pPr indent="0" marL="0">
-              <a:buNone/>
-            </a:pPr>
-            <a:r>
-              <a:rPr lang="en-US" sz="1500" dirty="0">
-                <a:solidFill>
-                  <a:srgbClr val="8FB8A5"/>
-                </a:solidFill>
-              </a:rPr>
-              <a:t>Munisbek · Jahongir · Umida</a:t>
+              <a:t>Team TYS</a:t>
             </a:r>
             <a:endParaRPr lang="en-US" sz="1500" dirty="0"/>
           </a:p>

</xml_diff>

<commit_message>
Roles removed everywhere; title slide shows the team name, mode and partners only (product introduced later in the deck)
Co-Authored-By: Claude Fable 5.1 <noreply@anthropic.com>
Claude-Session: https://claude.ai/code/session_01Xf5A9DfRgzoaeNELy2iEQH
</commit_message>
<xml_diff>
--- a/deck/Daromad_TYS_deck.pptx
+++ b/deck/Daromad_TYS_deck.pptx
@@ -119,41 +119,41 @@
   <p:extLst>
     <p:ext uri="{521415D9-36F7-43E2-AB2F-B90AF26B5E84}">
       <p14:sectionLst xmlns:p14="http://schemas.microsoft.com/office/powerpoint/2010/main">
-        <p14:section name="Opening" id="{f3bd124d-1b49-8b76-fb78-a161188864c1}">
+        <p14:section name="Opening" id="{938d0e5d-99cb-1d2e-0d56-4418114c45e1}">
           <p14:sldIdLst>
             <p14:sldId id="256"/>
           </p14:sldIdLst>
         </p14:section>
-        <p14:section name="Problem" id="{ca8e37c9-0b22-933b-569f-32ce8f8f2672}">
+        <p14:section name="Problem" id="{3728b9c6-5a60-a867-0ea7-1772d78d4a8b}">
           <p14:sldIdLst>
             <p14:sldId id="257"/>
           </p14:sldIdLst>
         </p14:section>
-        <p14:section name="Product" id="{ac463876-0f77-3ed9-771d-38016bef3bc5}">
+        <p14:section name="Product" id="{fede45dc-353f-1879-ed7c-db04f64f801a}">
           <p14:sldIdLst>
             <p14:sldId id="258"/>
             <p14:sldId id="259"/>
           </p14:sldIdLst>
         </p14:section>
-        <p14:section name="Technology" id="{d155d059-84f8-3978-3394-803e4ee176a5}">
+        <p14:section name="Technology" id="{8008f07e-2422-8e59-c479-3d8a005651fa}">
           <p14:sldIdLst>
             <p14:sldId id="260"/>
             <p14:sldId id="261"/>
             <p14:sldId id="262"/>
           </p14:sldIdLst>
         </p14:section>
-        <p14:section name="Business" id="{2b1269ee-ce9d-ee61-993c-095dab69efa1}">
+        <p14:section name="Business" id="{782ceecd-ea5e-0ab6-c56f-382cb85b1fd4}">
           <p14:sldIdLst>
             <p14:sldId id="263"/>
             <p14:sldId id="264"/>
           </p14:sldIdLst>
         </p14:section>
-        <p14:section name="Closing" id="{da016894-d388-24e1-884c-eefa20ab6f52}">
+        <p14:section name="Closing" id="{f33e43d9-a711-4a58-72b4-133c960f186d}">
           <p14:sldIdLst>
             <p14:sldId id="265"/>
           </p14:sldIdLst>
         </p14:section>
-        <p14:section name="Appendix" id="{23f3084f-c015-3c32-e505-c3e55e68edf4}">
+        <p14:section name="Appendix" id="{d10f310e-6a25-9d88-c45e-77320167e443}">
           <p14:sldIdLst>
             <p14:sldId id="266"/>
             <p14:sldId id="267"/>
@@ -2198,7 +2198,7 @@
                   <a:srgbClr val="8FB8A5"/>
                 </a:solidFill>
               </a:rPr>
-              <a:t>Daromad · team TYS · FinTech / AI in Finance</a:t>
+              <a:t>team TYS · FinTech / AI in Finance</a:t>
             </a:r>
             <a:endParaRPr lang="en-US" sz="1000" dirty="0"/>
           </a:p>
@@ -2707,14 +2707,14 @@
       </p:grpSpPr>
       <p:sp>
         <p:nvSpPr>
-          <p:cNvPr id="2" name="brand"/>
+          <p:cNvPr id="2" name="team name"/>
           <p:cNvSpPr txBox="1"/>
           <p:nvPr/>
         </p:nvSpPr>
         <p:spPr>
           <a:xfrm>
-            <a:off x="640080" y="1371600"/>
-            <a:ext cx="7315200" cy="1097280"/>
+            <a:off x="640080" y="1463040"/>
+            <a:ext cx="10058400" cy="1097280"/>
           </a:xfrm>
           <a:prstGeom prst="rect">
             <a:avLst/>
@@ -2735,7 +2735,7 @@
                   <a:srgbClr val="FFFFFF"/>
                 </a:solidFill>
               </a:rPr>
-              <a:t>Daromad</a:t>
+              <a:t>Team TYS</a:t>
             </a:r>
             <a:endParaRPr lang="en-US" sz="6000" dirty="0"/>
           </a:p>
@@ -2743,14 +2743,14 @@
       </p:sp>
       <p:sp>
         <p:nvSpPr>
-          <p:cNvPr id="3" name="tagline"/>
+          <p:cNvPr id="3" name="event"/>
           <p:cNvSpPr txBox="1"/>
           <p:nvPr/>
         </p:nvSpPr>
         <p:spPr>
           <a:xfrm>
-            <a:off x="640080" y="2468880"/>
-            <a:ext cx="10058400" cy="731520"/>
+            <a:off x="640080" y="2560320"/>
+            <a:ext cx="10058400" cy="640080"/>
           </a:xfrm>
           <a:prstGeom prst="rect">
             <a:avLst/>
@@ -2766,14 +2766,14 @@
               <a:buNone/>
             </a:pPr>
             <a:r>
-              <a:rPr lang="en-US" sz="2800" dirty="0">
+              <a:rPr lang="en-US" sz="2600" dirty="0">
                 <a:solidFill>
                   <a:srgbClr val="E9F1EC"/>
                 </a:solidFill>
               </a:rPr>
-              <a:t>Income evidence for borrowers who have no payslip</a:t>
-            </a:r>
-            <a:endParaRPr lang="en-US" sz="2800" dirty="0"/>
+              <a:t>FinTech / AI in Finance · final defence</a:t>
+            </a:r>
+            <a:endParaRPr lang="en-US" sz="2600" dirty="0"/>
           </a:p>
         </p:txBody>
       </p:sp>
@@ -2785,7 +2785,7 @@
         </p:nvSpPr>
         <p:spPr>
           <a:xfrm>
-            <a:off x="640080" y="3474720"/>
+            <a:off x="640080" y="3566160"/>
             <a:ext cx="6949440" cy="548640"/>
           </a:xfrm>
           <a:prstGeom prst="roundRect">
@@ -2812,7 +2812,7 @@
         </p:nvSpPr>
         <p:spPr>
           <a:xfrm>
-            <a:off x="777240" y="3474720"/>
+            <a:off x="777240" y="3566160"/>
             <a:ext cx="6766560" cy="548640"/>
           </a:xfrm>
           <a:prstGeom prst="rect">
@@ -2842,14 +2842,14 @@
       </p:sp>
       <p:sp>
         <p:nvSpPr>
-          <p:cNvPr id="6" name="team"/>
+          <p:cNvPr id="6" name="partners"/>
           <p:cNvSpPr txBox="1"/>
           <p:nvPr/>
         </p:nvSpPr>
         <p:spPr>
           <a:xfrm>
-            <a:off x="640080" y="4297680"/>
-            <a:ext cx="10515600" cy="457200"/>
+            <a:off x="640080" y="4480560"/>
+            <a:ext cx="10515600" cy="365760"/>
           </a:xfrm>
           <a:prstGeom prst="rect">
             <a:avLst/>
@@ -2865,91 +2865,80 @@
               <a:buNone/>
             </a:pPr>
             <a:r>
-              <a:rPr lang="en-US" sz="1500" b="1" dirty="0">
+              <a:rPr lang="en-US" sz="1400" dirty="0">
                 <a:solidFill>
                   <a:srgbClr val="E9F1EC"/>
                 </a:solidFill>
               </a:rPr>
-              <a:t>Team TYS  </a:t>
-            </a:r>
+              <a:t>Partners: MKBANK and the Central Bank of Uzbekistan · October 2026</a:t>
+            </a:r>
+            <a:endParaRPr lang="en-US" sz="1400" dirty="0"/>
+          </a:p>
+        </p:txBody>
+      </p:sp>
+      <p:sp>
+        <p:nvSpPr>
+          <p:cNvPr id="7" name="links"/>
+          <p:cNvSpPr txBox="1"/>
+          <p:nvPr/>
+        </p:nvSpPr>
+        <p:spPr>
+          <a:xfrm>
+            <a:off x="640080" y="5029200"/>
+            <a:ext cx="10972800" cy="457200"/>
+          </a:xfrm>
+          <a:prstGeom prst="rect">
+            <a:avLst/>
+          </a:prstGeom>
+          <a:noFill/>
+          <a:ln/>
+        </p:spPr>
+        <p:txBody>
+          <a:bodyPr wrap="square" lIns="0" tIns="0" rIns="0" bIns="0" rtlCol="0" anchor="ctr"/>
+          <a:lstStyle/>
+          <a:p>
             <a:pPr indent="0" marL="0">
               <a:buNone/>
             </a:pPr>
             <a:r>
-              <a:rPr lang="en-US" sz="1500" dirty="0">
-                <a:solidFill>
-                  <a:srgbClr val="E9F1EC"/>
-                </a:solidFill>
-              </a:rPr>
-              <a:t>three members — technical lead · research &amp; data · compliance &amp; business case</a:t>
-            </a:r>
-            <a:endParaRPr lang="en-US" sz="1500" dirty="0"/>
-          </a:p>
-        </p:txBody>
-      </p:sp>
-      <p:sp>
-        <p:nvSpPr>
-          <p:cNvPr id="7" name="links"/>
-          <p:cNvSpPr txBox="1"/>
-          <p:nvPr/>
-        </p:nvSpPr>
-        <p:spPr>
-          <a:xfrm>
-            <a:off x="640080" y="4846320"/>
-            <a:ext cx="10972800" cy="457200"/>
-          </a:xfrm>
-          <a:prstGeom prst="rect">
-            <a:avLst/>
-          </a:prstGeom>
-          <a:noFill/>
-          <a:ln/>
-        </p:spPr>
-        <p:txBody>
-          <a:bodyPr wrap="square" lIns="0" tIns="0" rIns="0" bIns="0" rtlCol="0" anchor="ctr"/>
-          <a:lstStyle/>
-          <a:p>
+              <a:rPr lang="en-US" sz="1300" b="1" dirty="0">
+                <a:solidFill>
+                  <a:srgbClr val="8FB8A5"/>
+                </a:solidFill>
+              </a:rPr>
+              <a:t>Live prototype  </a:t>
+            </a:r>
             <a:pPr indent="0" marL="0">
               <a:buNone/>
             </a:pPr>
             <a:r>
-              <a:rPr lang="en-US" sz="1300" b="1" dirty="0">
+              <a:rPr lang="en-US" sz="1300" dirty="0">
                 <a:solidFill>
                   <a:srgbClr val="8FB8A5"/>
                 </a:solidFill>
               </a:rPr>
-              <a:t>Live prototype  </a:t>
+              <a:t>https://tys-fintech.vercel.app    </a:t>
             </a:r>
             <a:pPr indent="0" marL="0">
               <a:buNone/>
             </a:pPr>
             <a:r>
-              <a:rPr lang="en-US" sz="1300" dirty="0">
+              <a:rPr lang="en-US" sz="1300" b="1" dirty="0">
                 <a:solidFill>
                   <a:srgbClr val="8FB8A5"/>
                 </a:solidFill>
               </a:rPr>
-              <a:t>https://tys-fintech.vercel.app    </a:t>
+              <a:t>Repository  </a:t>
             </a:r>
             <a:pPr indent="0" marL="0">
               <a:buNone/>
             </a:pPr>
             <a:r>
-              <a:rPr lang="en-US" sz="1300" b="1" dirty="0">
+              <a:rPr lang="en-US" sz="1300" dirty="0">
                 <a:solidFill>
                   <a:srgbClr val="8FB8A5"/>
                 </a:solidFill>
               </a:rPr>
-              <a:t>Repository  </a:t>
-            </a:r>
-            <a:pPr indent="0" marL="0">
-              <a:buNone/>
-            </a:pPr>
-            <a:r>
-              <a:rPr lang="en-US" sz="1300" dirty="0">
-                <a:solidFill>
-                  <a:srgbClr val="8FB8A5"/>
-                </a:solidFill>
-              </a:rPr>
               <a:t>https://github.com/hmunisbekk-droid/TYS-fintech</a:t>
             </a:r>
             <a:endParaRPr lang="en-US" sz="1300" dirty="0"/>
@@ -2958,43 +2947,7 @@
       </p:sp>
       <p:sp>
         <p:nvSpPr>
-          <p:cNvPr id="8" name="event"/>
-          <p:cNvSpPr txBox="1"/>
-          <p:nvPr/>
-        </p:nvSpPr>
-        <p:spPr>
-          <a:xfrm>
-            <a:off x="640080" y="5760720"/>
-            <a:ext cx="10515600" cy="365760"/>
-          </a:xfrm>
-          <a:prstGeom prst="rect">
-            <a:avLst/>
-          </a:prstGeom>
-          <a:noFill/>
-          <a:ln/>
-        </p:spPr>
-        <p:txBody>
-          <a:bodyPr wrap="square" lIns="0" tIns="0" rIns="0" bIns="0" rtlCol="0" anchor="ctr"/>
-          <a:lstStyle/>
-          <a:p>
-            <a:pPr indent="0" marL="0">
-              <a:buNone/>
-            </a:pPr>
-            <a:r>
-              <a:rPr lang="en-US" sz="1200" dirty="0">
-                <a:solidFill>
-                  <a:srgbClr val="8FB8A5"/>
-                </a:solidFill>
-              </a:rPr>
-              <a:t>FinTech / AI in Finance · partners MKBANK and the Central Bank of Uzbekistan · final defence, October 2026</a:t>
-            </a:r>
-            <a:endParaRPr lang="en-US" sz="1200" dirty="0"/>
-          </a:p>
-        </p:txBody>
-      </p:sp>
-      <p:sp>
-        <p:nvSpPr>
-          <p:cNvPr id="9" name="Text 0"/>
+          <p:cNvPr id="8" name="Text 0"/>
           <p:cNvSpPr/>
           <p:nvPr>
             <p:ph idx="100" type="title" hasCustomPrompt="1"/>
@@ -3024,7 +2977,7 @@
       </p:sp>
       <p:sp>
         <p:nvSpPr>
-          <p:cNvPr id="10" name="Text 0"/>
+          <p:cNvPr id="9" name="Text 0"/>
           <p:cNvSpPr/>
           <p:nvPr>
             <p:ph idx="101" type="body" hasCustomPrompt="1"/>

</xml_diff>

<commit_message>
Docs and deck on Regulation 3618; Westminster Harvard reference list (docs/REFERENCES.md, Appendix D, Word explainer with in-text citations); MKBANK 2026 figure worded as programme projects
Co-Authored-By: Claude Fable 5.1 <noreply@anthropic.com>
Claude-Session: https://claude.ai/code/session_01Xf5A9DfRgzoaeNELy2iEQH
</commit_message>
<xml_diff>
--- a/deck/Daromad_TYS_deck.pptx
+++ b/deck/Daromad_TYS_deck.pptx
@@ -18,9 +18,11 @@
     <p:sldId id="266" r:id="rId12"/>
     <p:sldId id="267" r:id="rId13"/>
     <p:sldId id="268" r:id="rId14"/>
+    <p:sldId id="269" r:id="rId15"/>
+    <p:sldId id="270" r:id="rId16"/>
   </p:sldIdLst>
   <p:notesMasterIdLst>
-    <p:notesMasterId r:id="rId15"/>
+    <p:notesMasterId r:id="rId17"/>
   </p:notesMasterIdLst>
   <p:sldSz cx="12192000" cy="6858000"/>
   <p:notesSz cx="6858000" cy="12192000"/>
@@ -119,45 +121,47 @@
   <p:extLst>
     <p:ext uri="{521415D9-36F7-43E2-AB2F-B90AF26B5E84}">
       <p14:sectionLst xmlns:p14="http://schemas.microsoft.com/office/powerpoint/2010/main">
-        <p14:section name="Opening" id="{938d0e5d-99cb-1d2e-0d56-4418114c45e1}">
+        <p14:section name="Opening" id="{73a72464-cffd-f2d0-5f82-6f91b86ff507}">
           <p14:sldIdLst>
             <p14:sldId id="256"/>
           </p14:sldIdLst>
         </p14:section>
-        <p14:section name="Problem" id="{3728b9c6-5a60-a867-0ea7-1772d78d4a8b}">
+        <p14:section name="Problem" id="{9f910ee0-c355-923d-5899-70d8fb4aa5fc}">
           <p14:sldIdLst>
             <p14:sldId id="257"/>
           </p14:sldIdLst>
         </p14:section>
-        <p14:section name="Product" id="{fede45dc-353f-1879-ed7c-db04f64f801a}">
+        <p14:section name="Product" id="{3ccf97e0-c764-cb6e-8750-dca8d249e21b}">
           <p14:sldIdLst>
             <p14:sldId id="258"/>
             <p14:sldId id="259"/>
           </p14:sldIdLst>
         </p14:section>
-        <p14:section name="Technology" id="{8008f07e-2422-8e59-c479-3d8a005651fa}">
+        <p14:section name="Technology" id="{a8c08eea-f8c6-6a96-ca23-797117af12d4}">
           <p14:sldIdLst>
             <p14:sldId id="260"/>
             <p14:sldId id="261"/>
             <p14:sldId id="262"/>
           </p14:sldIdLst>
         </p14:section>
-        <p14:section name="Business" id="{782ceecd-ea5e-0ab6-c56f-382cb85b1fd4}">
+        <p14:section name="Business" id="{e6857768-a65f-c9b6-76de-8e7733ff7e9b}">
           <p14:sldIdLst>
             <p14:sldId id="263"/>
             <p14:sldId id="264"/>
           </p14:sldIdLst>
         </p14:section>
-        <p14:section name="Closing" id="{f33e43d9-a711-4a58-72b4-133c960f186d}">
+        <p14:section name="Closing" id="{97ba455c-33e2-be27-614e-0326440e6272}">
           <p14:sldIdLst>
             <p14:sldId id="265"/>
           </p14:sldIdLst>
         </p14:section>
-        <p14:section name="Appendix" id="{d10f310e-6a25-9d88-c45e-77320167e443}">
+        <p14:section name="Appendix" id="{100a785f-3589-9e6a-a741-f10bba8718c3}">
           <p14:sldIdLst>
             <p14:sldId id="266"/>
             <p14:sldId id="267"/>
             <p14:sldId id="268"/>
+            <p14:sldId id="269"/>
+            <p14:sldId id="270"/>
           </p14:sldIdLst>
         </p14:section>
       </p14:sectionLst>
@@ -1314,6 +1318,182 @@
             <a:fld id="{F7021451-1387-4CA6-816F-3879F97B5CBC}" type="slidenum">
               <a:rPr lang="en-US"/>
               <a:t>13</a:t>
+            </a:fld>
+            <a:endParaRPr lang="en-US"/>
+          </a:p>
+        </p:txBody>
+      </p:sp>
+    </p:spTree>
+    <p:extLst>
+      <p:ext uri="{BB962C8B-B14F-4D97-AF65-F5344CB8AC3E}">
+        <p14:creationId xmlns:p14="http://schemas.microsoft.com/office/powerpoint/2010/main" val="1024086991"/>
+      </p:ext>
+    </p:extLst>
+  </p:cSld>
+  <p:clrMapOvr>
+    <a:masterClrMapping/>
+  </p:clrMapOvr>
+</p:notes>
+</file>
+
+<file path=ppt/notesSlides/notesSlide14.xml><?xml version="1.0" encoding="utf-8"?>
+<p:notes xmlns:a="http://schemas.openxmlformats.org/drawingml/2006/main" xmlns:r="http://schemas.openxmlformats.org/officeDocument/2006/relationships" xmlns:p="http://schemas.openxmlformats.org/presentationml/2006/main">
+  <p:cSld>
+    <p:spTree>
+      <p:nvGrpSpPr>
+        <p:cNvPr id="1" name=""/>
+        <p:cNvGrpSpPr/>
+        <p:nvPr/>
+      </p:nvGrpSpPr>
+      <p:grpSpPr>
+        <a:xfrm>
+          <a:off x="0" y="0"/>
+          <a:ext cx="0" cy="0"/>
+          <a:chOff x="0" y="0"/>
+          <a:chExt cx="0" cy="0"/>
+        </a:xfrm>
+      </p:grpSpPr>
+      <p:sp>
+        <p:nvSpPr>
+          <p:cNvPr id="2" name="Slide Image Placeholder 1"/>
+          <p:cNvSpPr>
+            <a:spLocks noGrp="1" noRot="1" noChangeAspect="1"/>
+          </p:cNvSpPr>
+          <p:nvPr>
+            <p:ph type="sldImg"/>
+          </p:nvPr>
+        </p:nvSpPr>
+        <p:spPr/>
+      </p:sp>
+      <p:sp>
+        <p:nvSpPr>
+          <p:cNvPr id="3" name="Notes Placeholder 2"/>
+          <p:cNvSpPr>
+            <a:spLocks noGrp="1"/>
+          </p:cNvSpPr>
+          <p:nvPr>
+            <p:ph type="body" idx="1"/>
+          </p:nvPr>
+        </p:nvSpPr>
+        <p:spPr/>
+        <p:txBody>
+          <a:bodyPr/>
+          <a:lstStyle/>
+          <a:p>
+            <a:r>
+              <a:rPr lang="en-US" dirty="0"/>
+              <a:t/>
+            </a:r>
+            <a:endParaRPr lang="en-US" dirty="0"/>
+          </a:p>
+        </p:txBody>
+      </p:sp>
+      <p:sp>
+        <p:nvSpPr>
+          <p:cNvPr id="4" name="Slide Number Placeholder 3"/>
+          <p:cNvSpPr>
+            <a:spLocks noGrp="1"/>
+          </p:cNvSpPr>
+          <p:nvPr>
+            <p:ph type="sldNum" sz="quarter" idx="10"/>
+          </p:nvPr>
+        </p:nvSpPr>
+        <p:spPr/>
+        <p:txBody>
+          <a:bodyPr/>
+          <a:lstStyle/>
+          <a:p>
+            <a:fld id="{F7021451-1387-4CA6-816F-3879F97B5CBC}" type="slidenum">
+              <a:rPr lang="en-US"/>
+              <a:t>14</a:t>
+            </a:fld>
+            <a:endParaRPr lang="en-US"/>
+          </a:p>
+        </p:txBody>
+      </p:sp>
+    </p:spTree>
+    <p:extLst>
+      <p:ext uri="{BB962C8B-B14F-4D97-AF65-F5344CB8AC3E}">
+        <p14:creationId xmlns:p14="http://schemas.microsoft.com/office/powerpoint/2010/main" val="1024086991"/>
+      </p:ext>
+    </p:extLst>
+  </p:cSld>
+  <p:clrMapOvr>
+    <a:masterClrMapping/>
+  </p:clrMapOvr>
+</p:notes>
+</file>
+
+<file path=ppt/notesSlides/notesSlide15.xml><?xml version="1.0" encoding="utf-8"?>
+<p:notes xmlns:a="http://schemas.openxmlformats.org/drawingml/2006/main" xmlns:r="http://schemas.openxmlformats.org/officeDocument/2006/relationships" xmlns:p="http://schemas.openxmlformats.org/presentationml/2006/main">
+  <p:cSld>
+    <p:spTree>
+      <p:nvGrpSpPr>
+        <p:cNvPr id="1" name=""/>
+        <p:cNvGrpSpPr/>
+        <p:nvPr/>
+      </p:nvGrpSpPr>
+      <p:grpSpPr>
+        <a:xfrm>
+          <a:off x="0" y="0"/>
+          <a:ext cx="0" cy="0"/>
+          <a:chOff x="0" y="0"/>
+          <a:chExt cx="0" cy="0"/>
+        </a:xfrm>
+      </p:grpSpPr>
+      <p:sp>
+        <p:nvSpPr>
+          <p:cNvPr id="2" name="Slide Image Placeholder 1"/>
+          <p:cNvSpPr>
+            <a:spLocks noGrp="1" noRot="1" noChangeAspect="1"/>
+          </p:cNvSpPr>
+          <p:nvPr>
+            <p:ph type="sldImg"/>
+          </p:nvPr>
+        </p:nvSpPr>
+        <p:spPr/>
+      </p:sp>
+      <p:sp>
+        <p:nvSpPr>
+          <p:cNvPr id="3" name="Notes Placeholder 2"/>
+          <p:cNvSpPr>
+            <a:spLocks noGrp="1"/>
+          </p:cNvSpPr>
+          <p:nvPr>
+            <p:ph type="body" idx="1"/>
+          </p:nvPr>
+        </p:nvSpPr>
+        <p:spPr/>
+        <p:txBody>
+          <a:bodyPr/>
+          <a:lstStyle/>
+          <a:p>
+            <a:r>
+              <a:rPr lang="en-US" dirty="0"/>
+              <a:t/>
+            </a:r>
+            <a:endParaRPr lang="en-US" dirty="0"/>
+          </a:p>
+        </p:txBody>
+      </p:sp>
+      <p:sp>
+        <p:nvSpPr>
+          <p:cNvPr id="4" name="Slide Number Placeholder 3"/>
+          <p:cNvSpPr>
+            <a:spLocks noGrp="1"/>
+          </p:cNvSpPr>
+          <p:nvPr>
+            <p:ph type="sldNum" sz="quarter" idx="10"/>
+          </p:nvPr>
+        </p:nvSpPr>
+        <p:spPr/>
+        <p:txBody>
+          <a:bodyPr/>
+          <a:lstStyle/>
+          <a:p>
+            <a:fld id="{F7021451-1387-4CA6-816F-3879F97B5CBC}" type="slidenum">
+              <a:rPr lang="en-US"/>
+              <a:t>15</a:t>
             </a:fld>
             <a:endParaRPr lang="en-US"/>
           </a:p>
@@ -3478,7 +3658,7 @@
                             <a:srgbClr val="17201B"/>
                           </a:solidFill>
                         </a:rPr>
-                        <a:t>cl.1</a:t>
+                        <a:t>cl.2</a:t>
                       </a:r>
                       <a:endParaRPr lang="en-US" sz="900" dirty="0"/>
                     </a:p>
@@ -3539,7 +3719,7 @@
                             <a:srgbClr val="17201B"/>
                           </a:solidFill>
                         </a:rPr>
-                        <a:t>ПДН = average monthly payments on loans/microloans ÷ average monthly income (borrower + co-borrower)</a:t>
+                        <a:t>ПДН = average monthly payments on loans (microloans) ÷ average monthly income («ўртача ойлик тўловлари миқдорининг … ўртача ойлик даромадига нисбати»)</a:t>
                       </a:r>
                       <a:endParaRPr lang="en-US" sz="900" dirty="0"/>
                     </a:p>
@@ -3663,7 +3843,7 @@
                             <a:srgbClr val="17201B"/>
                           </a:solidFill>
                         </a:rPr>
-                        <a:t>cl.2</a:t>
+                        <a:t>cl.3</a:t>
                       </a:r>
                       <a:endParaRPr lang="en-US" sz="900" dirty="0"/>
                     </a:p>
@@ -3724,7 +3904,7 @@
                             <a:srgbClr val="17201B"/>
                           </a:solidFill>
                         </a:rPr>
-                        <a:t>Includes the application under review and all loan agreements with all lenders; co-borrower loans counted. Lender-type reliefs (2024): banks («банк томонидан…») — only a portfolio quota, up to 15% of the number of loans to individuals outside the requirement; MFOs and pawnshops («микромолия ташкилоти ва ломбард томонидан…») — excluded when amount + outstanding principal ≤ 50 BRV; MFOs lending to the self-employed — 75 BRV. Daromad defaults to bank: ratio always computed, quota shown as a note</a:t>
+                        <a:t>Ratio ≤ 50% («50 фоиздан ошмаслиги лозим»). Up to 15% of outstanding loans may carry up to 100% (amendment 31/9, 2025) — bank-level quota → committee. Self-employed registered &lt; 6 months: income-generating loans within 15% without the ratio</a:t>
                       </a:r>
                       <a:endParaRPr lang="en-US" sz="900" dirty="0"/>
                     </a:p>
@@ -3785,7 +3965,7 @@
                             <a:srgbClr val="17201B"/>
                           </a:solidFill>
                         </a:rPr>
-                        <a:t>lender-type selector, ПДН panel note</a:t>
+                        <a:t>status: pass / quota / fail; cl.3 ¶4 badge</a:t>
                       </a:r>
                       <a:endParaRPr lang="en-US" sz="900" dirty="0"/>
                     </a:p>
@@ -3909,7 +4089,7 @@
                             <a:srgbClr val="17201B"/>
                           </a:solidFill>
                         </a:rPr>
-                        <a:t>Guarantor loans count only when payments are more than 30 days overdue («30 кундан ортиқ муддати ўтган тўловлари мавжуд бўлса»)</a:t>
+                        <a:t>Not applicable to loans to individual entrepreneurs, family-entrepreneurship programmes and education loans («татбиқ этилмайди»)</a:t>
                       </a:r>
                       <a:endParaRPr lang="en-US" sz="900" dirty="0"/>
                     </a:p>
@@ -3970,377 +4150,7 @@
                             <a:srgbClr val="17201B"/>
                           </a:solidFill>
                         </a:rPr>
-                        <a:t>obligations table, DPD column</a:t>
-                      </a:r>
-                      <a:endParaRPr lang="en-US" sz="900" dirty="0"/>
-                    </a:p>
-                  </a:txBody>
-                  <a:tcPr marL="91440" marR="91440" marT="45720" marB="45720">
-                    <a:lnL w="6350" cap="flat" cmpd="sng" algn="ctr">
-                      <a:solidFill>
-                        <a:srgbClr val="E9F1EC"/>
-                      </a:solidFill>
-                      <a:prstDash val="solid"/>
-                      <a:round/>
-                      <a:headEnd type="none" w="med" len="med"/>
-                      <a:tailEnd type="none" w="med" len="med"/>
-                    </a:lnL>
-                    <a:lnR w="6350" cap="flat" cmpd="sng" algn="ctr">
-                      <a:solidFill>
-                        <a:srgbClr val="E9F1EC"/>
-                      </a:solidFill>
-                      <a:prstDash val="solid"/>
-                      <a:round/>
-                      <a:headEnd type="none" w="med" len="med"/>
-                      <a:tailEnd type="none" w="med" len="med"/>
-                    </a:lnR>
-                    <a:lnT w="6350" cap="flat" cmpd="sng" algn="ctr">
-                      <a:solidFill>
-                        <a:srgbClr val="E9F1EC"/>
-                      </a:solidFill>
-                      <a:prstDash val="solid"/>
-                      <a:round/>
-                      <a:headEnd type="none" w="med" len="med"/>
-                      <a:tailEnd type="none" w="med" len="med"/>
-                    </a:lnT>
-                    <a:lnB w="6350" cap="flat" cmpd="sng" algn="ctr">
-                      <a:solidFill>
-                        <a:srgbClr val="E9F1EC"/>
-                      </a:solidFill>
-                      <a:prstDash val="solid"/>
-                      <a:round/>
-                      <a:headEnd type="none" w="med" len="med"/>
-                      <a:tailEnd type="none" w="med" len="med"/>
-                    </a:lnB>
-                    <a:solidFill>
-                      <a:srgbClr val="FFFFFF"/>
-                    </a:solidFill>
-                  </a:tcPr>
-                </a:tc>
-              </a:tr>
-              <a:tr h="384048">
-                <a:tc>
-                  <a:txBody>
-                    <a:bodyPr/>
-                    <a:lstStyle/>
-                    <a:p>
-                      <a:pPr indent="0" marL="0">
-                        <a:buNone/>
-                      </a:pPr>
-                      <a:r>
-                        <a:rPr lang="en-US" sz="900" b="1" dirty="0">
-                          <a:solidFill>
-                            <a:srgbClr val="17201B"/>
-                          </a:solidFill>
-                        </a:rPr>
-                        <a:t>cl.4¹</a:t>
-                      </a:r>
-                      <a:endParaRPr lang="en-US" sz="900" dirty="0"/>
-                    </a:p>
-                  </a:txBody>
-                  <a:tcPr marL="91440" marR="91440" marT="45720" marB="45720">
-                    <a:lnL w="6350" cap="flat" cmpd="sng" algn="ctr">
-                      <a:solidFill>
-                        <a:srgbClr val="E9F1EC"/>
-                      </a:solidFill>
-                      <a:prstDash val="solid"/>
-                      <a:round/>
-                      <a:headEnd type="none" w="med" len="med"/>
-                      <a:tailEnd type="none" w="med" len="med"/>
-                    </a:lnL>
-                    <a:lnR w="6350" cap="flat" cmpd="sng" algn="ctr">
-                      <a:solidFill>
-                        <a:srgbClr val="E9F1EC"/>
-                      </a:solidFill>
-                      <a:prstDash val="solid"/>
-                      <a:round/>
-                      <a:headEnd type="none" w="med" len="med"/>
-                      <a:tailEnd type="none" w="med" len="med"/>
-                    </a:lnR>
-                    <a:lnT w="6350" cap="flat" cmpd="sng" algn="ctr">
-                      <a:solidFill>
-                        <a:srgbClr val="E9F1EC"/>
-                      </a:solidFill>
-                      <a:prstDash val="solid"/>
-                      <a:round/>
-                      <a:headEnd type="none" w="med" len="med"/>
-                      <a:tailEnd type="none" w="med" len="med"/>
-                    </a:lnT>
-                    <a:lnB w="6350" cap="flat" cmpd="sng" algn="ctr">
-                      <a:solidFill>
-                        <a:srgbClr val="E9F1EC"/>
-                      </a:solidFill>
-                      <a:prstDash val="solid"/>
-                      <a:round/>
-                      <a:headEnd type="none" w="med" len="med"/>
-                      <a:tailEnd type="none" w="med" len="med"/>
-                    </a:lnB>
-                    <a:solidFill>
-                      <a:srgbClr val="E9F1EC"/>
-                    </a:solidFill>
-                  </a:tcPr>
-                </a:tc>
-                <a:tc>
-                  <a:txBody>
-                    <a:bodyPr/>
-                    <a:lstStyle/>
-                    <a:p>
-                      <a:pPr indent="0" marL="0">
-                        <a:buNone/>
-                      </a:pPr>
-                      <a:r>
-                        <a:rPr lang="en-US" sz="900" dirty="0">
-                          <a:solidFill>
-                            <a:srgbClr val="17201B"/>
-                          </a:solidFill>
-                        </a:rPr>
-                        <a:t>Terms over 36 months: total payments spread over 36 («барча тўловлар 36 ойга тенг миқдорда тақсимланади»); mortgages over 180 months spread over 180</a:t>
-                      </a:r>
-                      <a:endParaRPr lang="en-US" sz="900" dirty="0"/>
-                    </a:p>
-                  </a:txBody>
-                  <a:tcPr marL="91440" marR="91440" marT="45720" marB="45720">
-                    <a:lnL w="6350" cap="flat" cmpd="sng" algn="ctr">
-                      <a:solidFill>
-                        <a:srgbClr val="E9F1EC"/>
-                      </a:solidFill>
-                      <a:prstDash val="solid"/>
-                      <a:round/>
-                      <a:headEnd type="none" w="med" len="med"/>
-                      <a:tailEnd type="none" w="med" len="med"/>
-                    </a:lnL>
-                    <a:lnR w="6350" cap="flat" cmpd="sng" algn="ctr">
-                      <a:solidFill>
-                        <a:srgbClr val="E9F1EC"/>
-                      </a:solidFill>
-                      <a:prstDash val="solid"/>
-                      <a:round/>
-                      <a:headEnd type="none" w="med" len="med"/>
-                      <a:tailEnd type="none" w="med" len="med"/>
-                    </a:lnR>
-                    <a:lnT w="6350" cap="flat" cmpd="sng" algn="ctr">
-                      <a:solidFill>
-                        <a:srgbClr val="E9F1EC"/>
-                      </a:solidFill>
-                      <a:prstDash val="solid"/>
-                      <a:round/>
-                      <a:headEnd type="none" w="med" len="med"/>
-                      <a:tailEnd type="none" w="med" len="med"/>
-                    </a:lnT>
-                    <a:lnB w="6350" cap="flat" cmpd="sng" algn="ctr">
-                      <a:solidFill>
-                        <a:srgbClr val="E9F1EC"/>
-                      </a:solidFill>
-                      <a:prstDash val="solid"/>
-                      <a:round/>
-                      <a:headEnd type="none" w="med" len="med"/>
-                      <a:tailEnd type="none" w="med" len="med"/>
-                    </a:lnB>
-                    <a:solidFill>
-                      <a:srgbClr val="E9F1EC"/>
-                    </a:solidFill>
-                  </a:tcPr>
-                </a:tc>
-                <a:tc>
-                  <a:txBody>
-                    <a:bodyPr/>
-                    <a:lstStyle/>
-                    <a:p>
-                      <a:pPr indent="0" marL="0">
-                        <a:buNone/>
-                      </a:pPr>
-                      <a:r>
-                        <a:rPr lang="en-US" sz="900" dirty="0">
-                          <a:solidFill>
-                            <a:srgbClr val="17201B"/>
-                          </a:solidFill>
-                        </a:rPr>
-                        <a:t>per-line note</a:t>
-                      </a:r>
-                      <a:endParaRPr lang="en-US" sz="900" dirty="0"/>
-                    </a:p>
-                  </a:txBody>
-                  <a:tcPr marL="91440" marR="91440" marT="45720" marB="45720">
-                    <a:lnL w="6350" cap="flat" cmpd="sng" algn="ctr">
-                      <a:solidFill>
-                        <a:srgbClr val="E9F1EC"/>
-                      </a:solidFill>
-                      <a:prstDash val="solid"/>
-                      <a:round/>
-                      <a:headEnd type="none" w="med" len="med"/>
-                      <a:tailEnd type="none" w="med" len="med"/>
-                    </a:lnL>
-                    <a:lnR w="6350" cap="flat" cmpd="sng" algn="ctr">
-                      <a:solidFill>
-                        <a:srgbClr val="E9F1EC"/>
-                      </a:solidFill>
-                      <a:prstDash val="solid"/>
-                      <a:round/>
-                      <a:headEnd type="none" w="med" len="med"/>
-                      <a:tailEnd type="none" w="med" len="med"/>
-                    </a:lnR>
-                    <a:lnT w="6350" cap="flat" cmpd="sng" algn="ctr">
-                      <a:solidFill>
-                        <a:srgbClr val="E9F1EC"/>
-                      </a:solidFill>
-                      <a:prstDash val="solid"/>
-                      <a:round/>
-                      <a:headEnd type="none" w="med" len="med"/>
-                      <a:tailEnd type="none" w="med" len="med"/>
-                    </a:lnT>
-                    <a:lnB w="6350" cap="flat" cmpd="sng" algn="ctr">
-                      <a:solidFill>
-                        <a:srgbClr val="E9F1EC"/>
-                      </a:solidFill>
-                      <a:prstDash val="solid"/>
-                      <a:round/>
-                      <a:headEnd type="none" w="med" len="med"/>
-                      <a:tailEnd type="none" w="med" len="med"/>
-                    </a:lnB>
-                    <a:solidFill>
-                      <a:srgbClr val="E9F1EC"/>
-                    </a:solidFill>
-                  </a:tcPr>
-                </a:tc>
-              </a:tr>
-              <a:tr h="384048">
-                <a:tc>
-                  <a:txBody>
-                    <a:bodyPr/>
-                    <a:lstStyle/>
-                    <a:p>
-                      <a:pPr indent="0" marL="0">
-                        <a:buNone/>
-                      </a:pPr>
-                      <a:r>
-                        <a:rPr lang="en-US" sz="900" b="1" dirty="0">
-                          <a:solidFill>
-                            <a:srgbClr val="17201B"/>
-                          </a:solidFill>
-                        </a:rPr>
-                        <a:t>cl.6</a:t>
-                      </a:r>
-                      <a:endParaRPr lang="en-US" sz="900" dirty="0"/>
-                    </a:p>
-                  </a:txBody>
-                  <a:tcPr marL="91440" marR="91440" marT="45720" marB="45720">
-                    <a:lnL w="6350" cap="flat" cmpd="sng" algn="ctr">
-                      <a:solidFill>
-                        <a:srgbClr val="E9F1EC"/>
-                      </a:solidFill>
-                      <a:prstDash val="solid"/>
-                      <a:round/>
-                      <a:headEnd type="none" w="med" len="med"/>
-                      <a:tailEnd type="none" w="med" len="med"/>
-                    </a:lnL>
-                    <a:lnR w="6350" cap="flat" cmpd="sng" algn="ctr">
-                      <a:solidFill>
-                        <a:srgbClr val="E9F1EC"/>
-                      </a:solidFill>
-                      <a:prstDash val="solid"/>
-                      <a:round/>
-                      <a:headEnd type="none" w="med" len="med"/>
-                      <a:tailEnd type="none" w="med" len="med"/>
-                    </a:lnR>
-                    <a:lnT w="6350" cap="flat" cmpd="sng" algn="ctr">
-                      <a:solidFill>
-                        <a:srgbClr val="E9F1EC"/>
-                      </a:solidFill>
-                      <a:prstDash val="solid"/>
-                      <a:round/>
-                      <a:headEnd type="none" w="med" len="med"/>
-                      <a:tailEnd type="none" w="med" len="med"/>
-                    </a:lnT>
-                    <a:lnB w="6350" cap="flat" cmpd="sng" algn="ctr">
-                      <a:solidFill>
-                        <a:srgbClr val="E9F1EC"/>
-                      </a:solidFill>
-                      <a:prstDash val="solid"/>
-                      <a:round/>
-                      <a:headEnd type="none" w="med" len="med"/>
-                      <a:tailEnd type="none" w="med" len="med"/>
-                    </a:lnB>
-                    <a:solidFill>
-                      <a:srgbClr val="FFFFFF"/>
-                    </a:solidFill>
-                  </a:tcPr>
-                </a:tc>
-                <a:tc>
-                  <a:txBody>
-                    <a:bodyPr/>
-                    <a:lstStyle/>
-                    <a:p>
-                      <a:pPr indent="0" marL="0">
-                        <a:buNone/>
-                      </a:pPr>
-                      <a:r>
-                        <a:rPr lang="en-US" sz="900" dirty="0">
-                          <a:solidFill>
-                            <a:srgbClr val="17201B"/>
-                          </a:solidFill>
-                        </a:rPr>
-                        <a:t>Calculation date within 10 calendar days of the loan date</a:t>
-                      </a:r>
-                      <a:endParaRPr lang="en-US" sz="900" dirty="0"/>
-                    </a:p>
-                  </a:txBody>
-                  <a:tcPr marL="91440" marR="91440" marT="45720" marB="45720">
-                    <a:lnL w="6350" cap="flat" cmpd="sng" algn="ctr">
-                      <a:solidFill>
-                        <a:srgbClr val="E9F1EC"/>
-                      </a:solidFill>
-                      <a:prstDash val="solid"/>
-                      <a:round/>
-                      <a:headEnd type="none" w="med" len="med"/>
-                      <a:tailEnd type="none" w="med" len="med"/>
-                    </a:lnL>
-                    <a:lnR w="6350" cap="flat" cmpd="sng" algn="ctr">
-                      <a:solidFill>
-                        <a:srgbClr val="E9F1EC"/>
-                      </a:solidFill>
-                      <a:prstDash val="solid"/>
-                      <a:round/>
-                      <a:headEnd type="none" w="med" len="med"/>
-                      <a:tailEnd type="none" w="med" len="med"/>
-                    </a:lnR>
-                    <a:lnT w="6350" cap="flat" cmpd="sng" algn="ctr">
-                      <a:solidFill>
-                        <a:srgbClr val="E9F1EC"/>
-                      </a:solidFill>
-                      <a:prstDash val="solid"/>
-                      <a:round/>
-                      <a:headEnd type="none" w="med" len="med"/>
-                      <a:tailEnd type="none" w="med" len="med"/>
-                    </a:lnT>
-                    <a:lnB w="6350" cap="flat" cmpd="sng" algn="ctr">
-                      <a:solidFill>
-                        <a:srgbClr val="E9F1EC"/>
-                      </a:solidFill>
-                      <a:prstDash val="solid"/>
-                      <a:round/>
-                      <a:headEnd type="none" w="med" len="med"/>
-                      <a:tailEnd type="none" w="med" len="med"/>
-                    </a:lnB>
-                    <a:solidFill>
-                      <a:srgbClr val="FFFFFF"/>
-                    </a:solidFill>
-                  </a:tcPr>
-                </a:tc>
-                <a:tc>
-                  <a:txBody>
-                    <a:bodyPr/>
-                    <a:lstStyle/>
-                    <a:p>
-                      <a:pPr indent="0" marL="0">
-                        <a:buNone/>
-                      </a:pPr>
-                      <a:r>
-                        <a:rPr lang="en-US" sz="900" dirty="0">
-                          <a:solidFill>
-                            <a:srgbClr val="17201B"/>
-                          </a:solidFill>
-                        </a:rPr>
-                        <a:t>case date</a:t>
+                        <a:t>exemption badge</a:t>
                       </a:r>
                       <a:endParaRPr lang="en-US" sz="900" dirty="0"/>
                     </a:p>
@@ -4464,7 +4274,7 @@
                             <a:srgbClr val="17201B"/>
                           </a:solidFill>
                         </a:rPr>
-                        <a:t>Average monthly income = arithmetic mean of the last 12 months; co-borrower income added</a:t>
+                        <a:t>All agreements with all lenders incl. the application under review; co-borrower loans counted; guarantor loans only when &gt; 30 days overdue («30 кундан ортиқ муддати ўтган»)</a:t>
                       </a:r>
                       <a:endParaRPr lang="en-US" sz="900" dirty="0"/>
                     </a:p>
@@ -4525,7 +4335,7 @@
                             <a:srgbClr val="17201B"/>
                           </a:solidFill>
                         </a:rPr>
-                        <a:t>income base</a:t>
+                        <a:t>obligations table, DPD column</a:t>
                       </a:r>
                       <a:endParaRPr lang="en-US" sz="900" dirty="0"/>
                     </a:p>
@@ -4588,7 +4398,7 @@
                             <a:srgbClr val="17201B"/>
                           </a:solidFill>
                         </a:rPr>
-                        <a:t>cl.9</a:t>
+                        <a:t>cl.8</a:t>
                       </a:r>
                       <a:endParaRPr lang="en-US" sz="900" dirty="0"/>
                     </a:p>
@@ -4649,7 +4459,7 @@
                             <a:srgbClr val="17201B"/>
                           </a:solidFill>
                         </a:rPr>
-                        <a:t>Evidence: employer salary data, pension, funded-pension contributions, income credited to bank accounts, taxes paid, interest/dividends/rent; other data allowed</a:t>
+                        <a:t>Annuity spreading: microloan &gt; 36 months → 36; other loan &gt; 60 → 60; mortgage &gt; 180 → 180</a:t>
                       </a:r>
                       <a:endParaRPr lang="en-US" sz="900" dirty="0"/>
                     </a:p>
@@ -4693,6 +4503,931 @@
                     </a:lnB>
                     <a:solidFill>
                       <a:srgbClr val="FFFFFF"/>
+                    </a:solidFill>
+                  </a:tcPr>
+                </a:tc>
+                <a:tc>
+                  <a:txBody>
+                    <a:bodyPr/>
+                    <a:lstStyle/>
+                    <a:p>
+                      <a:pPr indent="0" marL="0">
+                        <a:buNone/>
+                      </a:pPr>
+                      <a:r>
+                        <a:rPr lang="en-US" sz="900" dirty="0">
+                          <a:solidFill>
+                            <a:srgbClr val="17201B"/>
+                          </a:solidFill>
+                        </a:rPr>
+                        <a:t>per-line note</a:t>
+                      </a:r>
+                      <a:endParaRPr lang="en-US" sz="900" dirty="0"/>
+                    </a:p>
+                  </a:txBody>
+                  <a:tcPr marL="91440" marR="91440" marT="45720" marB="45720">
+                    <a:lnL w="6350" cap="flat" cmpd="sng" algn="ctr">
+                      <a:solidFill>
+                        <a:srgbClr val="E9F1EC"/>
+                      </a:solidFill>
+                      <a:prstDash val="solid"/>
+                      <a:round/>
+                      <a:headEnd type="none" w="med" len="med"/>
+                      <a:tailEnd type="none" w="med" len="med"/>
+                    </a:lnL>
+                    <a:lnR w="6350" cap="flat" cmpd="sng" algn="ctr">
+                      <a:solidFill>
+                        <a:srgbClr val="E9F1EC"/>
+                      </a:solidFill>
+                      <a:prstDash val="solid"/>
+                      <a:round/>
+                      <a:headEnd type="none" w="med" len="med"/>
+                      <a:tailEnd type="none" w="med" len="med"/>
+                    </a:lnR>
+                    <a:lnT w="6350" cap="flat" cmpd="sng" algn="ctr">
+                      <a:solidFill>
+                        <a:srgbClr val="E9F1EC"/>
+                      </a:solidFill>
+                      <a:prstDash val="solid"/>
+                      <a:round/>
+                      <a:headEnd type="none" w="med" len="med"/>
+                      <a:tailEnd type="none" w="med" len="med"/>
+                    </a:lnT>
+                    <a:lnB w="6350" cap="flat" cmpd="sng" algn="ctr">
+                      <a:solidFill>
+                        <a:srgbClr val="E9F1EC"/>
+                      </a:solidFill>
+                      <a:prstDash val="solid"/>
+                      <a:round/>
+                      <a:headEnd type="none" w="med" len="med"/>
+                      <a:tailEnd type="none" w="med" len="med"/>
+                    </a:lnB>
+                    <a:solidFill>
+                      <a:srgbClr val="FFFFFF"/>
+                    </a:solidFill>
+                  </a:tcPr>
+                </a:tc>
+              </a:tr>
+              <a:tr h="384048">
+                <a:tc>
+                  <a:txBody>
+                    <a:bodyPr/>
+                    <a:lstStyle/>
+                    <a:p>
+                      <a:pPr indent="0" marL="0">
+                        <a:buNone/>
+                      </a:pPr>
+                      <a:r>
+                        <a:rPr lang="en-US" sz="900" b="1" dirty="0">
+                          <a:solidFill>
+                            <a:srgbClr val="17201B"/>
+                          </a:solidFill>
+                        </a:rPr>
+                        <a:t>cl.12</a:t>
+                      </a:r>
+                      <a:endParaRPr lang="en-US" sz="900" dirty="0"/>
+                    </a:p>
+                  </a:txBody>
+                  <a:tcPr marL="91440" marR="91440" marT="45720" marB="45720">
+                    <a:lnL w="6350" cap="flat" cmpd="sng" algn="ctr">
+                      <a:solidFill>
+                        <a:srgbClr val="E9F1EC"/>
+                      </a:solidFill>
+                      <a:prstDash val="solid"/>
+                      <a:round/>
+                      <a:headEnd type="none" w="med" len="med"/>
+                      <a:tailEnd type="none" w="med" len="med"/>
+                    </a:lnL>
+                    <a:lnR w="6350" cap="flat" cmpd="sng" algn="ctr">
+                      <a:solidFill>
+                        <a:srgbClr val="E9F1EC"/>
+                      </a:solidFill>
+                      <a:prstDash val="solid"/>
+                      <a:round/>
+                      <a:headEnd type="none" w="med" len="med"/>
+                      <a:tailEnd type="none" w="med" len="med"/>
+                    </a:lnR>
+                    <a:lnT w="6350" cap="flat" cmpd="sng" algn="ctr">
+                      <a:solidFill>
+                        <a:srgbClr val="E9F1EC"/>
+                      </a:solidFill>
+                      <a:prstDash val="solid"/>
+                      <a:round/>
+                      <a:headEnd type="none" w="med" len="med"/>
+                      <a:tailEnd type="none" w="med" len="med"/>
+                    </a:lnT>
+                    <a:lnB w="6350" cap="flat" cmpd="sng" algn="ctr">
+                      <a:solidFill>
+                        <a:srgbClr val="E9F1EC"/>
+                      </a:solidFill>
+                      <a:prstDash val="solid"/>
+                      <a:round/>
+                      <a:headEnd type="none" w="med" len="med"/>
+                      <a:tailEnd type="none" w="med" len="med"/>
+                    </a:lnB>
+                    <a:solidFill>
+                      <a:srgbClr val="E9F1EC"/>
+                    </a:solidFill>
+                  </a:tcPr>
+                </a:tc>
+                <a:tc>
+                  <a:txBody>
+                    <a:bodyPr/>
+                    <a:lstStyle/>
+                    <a:p>
+                      <a:pPr indent="0" marL="0">
+                        <a:buNone/>
+                      </a:pPr>
+                      <a:r>
+                        <a:rPr lang="en-US" sz="900" dirty="0">
+                          <a:solidFill>
+                            <a:srgbClr val="17201B"/>
+                          </a:solidFill>
+                        </a:rPr>
+                        <a:t>No more than 3 working days between the calculation and the issue («3 иш кунидан ошмаслиги керак»)</a:t>
+                      </a:r>
+                      <a:endParaRPr lang="en-US" sz="900" dirty="0"/>
+                    </a:p>
+                  </a:txBody>
+                  <a:tcPr marL="91440" marR="91440" marT="45720" marB="45720">
+                    <a:lnL w="6350" cap="flat" cmpd="sng" algn="ctr">
+                      <a:solidFill>
+                        <a:srgbClr val="E9F1EC"/>
+                      </a:solidFill>
+                      <a:prstDash val="solid"/>
+                      <a:round/>
+                      <a:headEnd type="none" w="med" len="med"/>
+                      <a:tailEnd type="none" w="med" len="med"/>
+                    </a:lnL>
+                    <a:lnR w="6350" cap="flat" cmpd="sng" algn="ctr">
+                      <a:solidFill>
+                        <a:srgbClr val="E9F1EC"/>
+                      </a:solidFill>
+                      <a:prstDash val="solid"/>
+                      <a:round/>
+                      <a:headEnd type="none" w="med" len="med"/>
+                      <a:tailEnd type="none" w="med" len="med"/>
+                    </a:lnR>
+                    <a:lnT w="6350" cap="flat" cmpd="sng" algn="ctr">
+                      <a:solidFill>
+                        <a:srgbClr val="E9F1EC"/>
+                      </a:solidFill>
+                      <a:prstDash val="solid"/>
+                      <a:round/>
+                      <a:headEnd type="none" w="med" len="med"/>
+                      <a:tailEnd type="none" w="med" len="med"/>
+                    </a:lnT>
+                    <a:lnB w="6350" cap="flat" cmpd="sng" algn="ctr">
+                      <a:solidFill>
+                        <a:srgbClr val="E9F1EC"/>
+                      </a:solidFill>
+                      <a:prstDash val="solid"/>
+                      <a:round/>
+                      <a:headEnd type="none" w="med" len="med"/>
+                      <a:tailEnd type="none" w="med" len="med"/>
+                    </a:lnB>
+                    <a:solidFill>
+                      <a:srgbClr val="E9F1EC"/>
+                    </a:solidFill>
+                  </a:tcPr>
+                </a:tc>
+                <a:tc>
+                  <a:txBody>
+                    <a:bodyPr/>
+                    <a:lstStyle/>
+                    <a:p>
+                      <a:pPr indent="0" marL="0">
+                        <a:buNone/>
+                      </a:pPr>
+                      <a:r>
+                        <a:rPr lang="en-US" sz="900" dirty="0">
+                          <a:solidFill>
+                            <a:srgbClr val="17201B"/>
+                          </a:solidFill>
+                        </a:rPr>
+                        <a:t>case date</a:t>
+                      </a:r>
+                      <a:endParaRPr lang="en-US" sz="900" dirty="0"/>
+                    </a:p>
+                  </a:txBody>
+                  <a:tcPr marL="91440" marR="91440" marT="45720" marB="45720">
+                    <a:lnL w="6350" cap="flat" cmpd="sng" algn="ctr">
+                      <a:solidFill>
+                        <a:srgbClr val="E9F1EC"/>
+                      </a:solidFill>
+                      <a:prstDash val="solid"/>
+                      <a:round/>
+                      <a:headEnd type="none" w="med" len="med"/>
+                      <a:tailEnd type="none" w="med" len="med"/>
+                    </a:lnL>
+                    <a:lnR w="6350" cap="flat" cmpd="sng" algn="ctr">
+                      <a:solidFill>
+                        <a:srgbClr val="E9F1EC"/>
+                      </a:solidFill>
+                      <a:prstDash val="solid"/>
+                      <a:round/>
+                      <a:headEnd type="none" w="med" len="med"/>
+                      <a:tailEnd type="none" w="med" len="med"/>
+                    </a:lnR>
+                    <a:lnT w="6350" cap="flat" cmpd="sng" algn="ctr">
+                      <a:solidFill>
+                        <a:srgbClr val="E9F1EC"/>
+                      </a:solidFill>
+                      <a:prstDash val="solid"/>
+                      <a:round/>
+                      <a:headEnd type="none" w="med" len="med"/>
+                      <a:tailEnd type="none" w="med" len="med"/>
+                    </a:lnT>
+                    <a:lnB w="6350" cap="flat" cmpd="sng" algn="ctr">
+                      <a:solidFill>
+                        <a:srgbClr val="E9F1EC"/>
+                      </a:solidFill>
+                      <a:prstDash val="solid"/>
+                      <a:round/>
+                      <a:headEnd type="none" w="med" len="med"/>
+                      <a:tailEnd type="none" w="med" len="med"/>
+                    </a:lnB>
+                    <a:solidFill>
+                      <a:srgbClr val="E9F1EC"/>
+                    </a:solidFill>
+                  </a:tcPr>
+                </a:tc>
+              </a:tr>
+              <a:tr h="384048">
+                <a:tc>
+                  <a:txBody>
+                    <a:bodyPr/>
+                    <a:lstStyle/>
+                    <a:p>
+                      <a:pPr indent="0" marL="0">
+                        <a:buNone/>
+                      </a:pPr>
+                      <a:r>
+                        <a:rPr lang="en-US" sz="900" b="1" dirty="0">
+                          <a:solidFill>
+                            <a:srgbClr val="17201B"/>
+                          </a:solidFill>
+                        </a:rPr>
+                        <a:t>cl.13</a:t>
+                      </a:r>
+                      <a:endParaRPr lang="en-US" sz="900" dirty="0"/>
+                    </a:p>
+                  </a:txBody>
+                  <a:tcPr marL="91440" marR="91440" marT="45720" marB="45720">
+                    <a:lnL w="6350" cap="flat" cmpd="sng" algn="ctr">
+                      <a:solidFill>
+                        <a:srgbClr val="E9F1EC"/>
+                      </a:solidFill>
+                      <a:prstDash val="solid"/>
+                      <a:round/>
+                      <a:headEnd type="none" w="med" len="med"/>
+                      <a:tailEnd type="none" w="med" len="med"/>
+                    </a:lnL>
+                    <a:lnR w="6350" cap="flat" cmpd="sng" algn="ctr">
+                      <a:solidFill>
+                        <a:srgbClr val="E9F1EC"/>
+                      </a:solidFill>
+                      <a:prstDash val="solid"/>
+                      <a:round/>
+                      <a:headEnd type="none" w="med" len="med"/>
+                      <a:tailEnd type="none" w="med" len="med"/>
+                    </a:lnR>
+                    <a:lnT w="6350" cap="flat" cmpd="sng" algn="ctr">
+                      <a:solidFill>
+                        <a:srgbClr val="E9F1EC"/>
+                      </a:solidFill>
+                      <a:prstDash val="solid"/>
+                      <a:round/>
+                      <a:headEnd type="none" w="med" len="med"/>
+                      <a:tailEnd type="none" w="med" len="med"/>
+                    </a:lnT>
+                    <a:lnB w="6350" cap="flat" cmpd="sng" algn="ctr">
+                      <a:solidFill>
+                        <a:srgbClr val="E9F1EC"/>
+                      </a:solidFill>
+                      <a:prstDash val="solid"/>
+                      <a:round/>
+                      <a:headEnd type="none" w="med" len="med"/>
+                      <a:tailEnd type="none" w="med" len="med"/>
+                    </a:lnB>
+                    <a:solidFill>
+                      <a:srgbClr val="FFFFFF"/>
+                    </a:solidFill>
+                  </a:tcPr>
+                </a:tc>
+                <a:tc>
+                  <a:txBody>
+                    <a:bodyPr/>
+                    <a:lstStyle/>
+                    <a:p>
+                      <a:pPr indent="0" marL="0">
+                        <a:buNone/>
+                      </a:pPr>
+                      <a:r>
+                        <a:rPr lang="en-US" sz="900" dirty="0">
+                          <a:solidFill>
+                            <a:srgbClr val="17201B"/>
+                          </a:solidFill>
+                        </a:rPr>
+                        <a:t>Average income over a continuous 6–12-month period («камида 6 ой … 12 ойдан ошмаган»): 1/12 of the last 12 months, or 1/n for 6–11</a:t>
+                      </a:r>
+                      <a:endParaRPr lang="en-US" sz="900" dirty="0"/>
+                    </a:p>
+                  </a:txBody>
+                  <a:tcPr marL="91440" marR="91440" marT="45720" marB="45720">
+                    <a:lnL w="6350" cap="flat" cmpd="sng" algn="ctr">
+                      <a:solidFill>
+                        <a:srgbClr val="E9F1EC"/>
+                      </a:solidFill>
+                      <a:prstDash val="solid"/>
+                      <a:round/>
+                      <a:headEnd type="none" w="med" len="med"/>
+                      <a:tailEnd type="none" w="med" len="med"/>
+                    </a:lnL>
+                    <a:lnR w="6350" cap="flat" cmpd="sng" algn="ctr">
+                      <a:solidFill>
+                        <a:srgbClr val="E9F1EC"/>
+                      </a:solidFill>
+                      <a:prstDash val="solid"/>
+                      <a:round/>
+                      <a:headEnd type="none" w="med" len="med"/>
+                      <a:tailEnd type="none" w="med" len="med"/>
+                    </a:lnR>
+                    <a:lnT w="6350" cap="flat" cmpd="sng" algn="ctr">
+                      <a:solidFill>
+                        <a:srgbClr val="E9F1EC"/>
+                      </a:solidFill>
+                      <a:prstDash val="solid"/>
+                      <a:round/>
+                      <a:headEnd type="none" w="med" len="med"/>
+                      <a:tailEnd type="none" w="med" len="med"/>
+                    </a:lnT>
+                    <a:lnB w="6350" cap="flat" cmpd="sng" algn="ctr">
+                      <a:solidFill>
+                        <a:srgbClr val="E9F1EC"/>
+                      </a:solidFill>
+                      <a:prstDash val="solid"/>
+                      <a:round/>
+                      <a:headEnd type="none" w="med" len="med"/>
+                      <a:tailEnd type="none" w="med" len="med"/>
+                    </a:lnB>
+                    <a:solidFill>
+                      <a:srgbClr val="FFFFFF"/>
+                    </a:solidFill>
+                  </a:tcPr>
+                </a:tc>
+                <a:tc>
+                  <a:txBody>
+                    <a:bodyPr/>
+                    <a:lstStyle/>
+                    <a:p>
+                      <a:pPr indent="0" marL="0">
+                        <a:buNone/>
+                      </a:pPr>
+                      <a:r>
+                        <a:rPr lang="en-US" sz="900" dirty="0">
+                          <a:solidFill>
+                            <a:srgbClr val="17201B"/>
+                          </a:solidFill>
+                        </a:rPr>
+                        <a:t>income base, months used</a:t>
+                      </a:r>
+                      <a:endParaRPr lang="en-US" sz="900" dirty="0"/>
+                    </a:p>
+                  </a:txBody>
+                  <a:tcPr marL="91440" marR="91440" marT="45720" marB="45720">
+                    <a:lnL w="6350" cap="flat" cmpd="sng" algn="ctr">
+                      <a:solidFill>
+                        <a:srgbClr val="E9F1EC"/>
+                      </a:solidFill>
+                      <a:prstDash val="solid"/>
+                      <a:round/>
+                      <a:headEnd type="none" w="med" len="med"/>
+                      <a:tailEnd type="none" w="med" len="med"/>
+                    </a:lnL>
+                    <a:lnR w="6350" cap="flat" cmpd="sng" algn="ctr">
+                      <a:solidFill>
+                        <a:srgbClr val="E9F1EC"/>
+                      </a:solidFill>
+                      <a:prstDash val="solid"/>
+                      <a:round/>
+                      <a:headEnd type="none" w="med" len="med"/>
+                      <a:tailEnd type="none" w="med" len="med"/>
+                    </a:lnR>
+                    <a:lnT w="6350" cap="flat" cmpd="sng" algn="ctr">
+                      <a:solidFill>
+                        <a:srgbClr val="E9F1EC"/>
+                      </a:solidFill>
+                      <a:prstDash val="solid"/>
+                      <a:round/>
+                      <a:headEnd type="none" w="med" len="med"/>
+                      <a:tailEnd type="none" w="med" len="med"/>
+                    </a:lnT>
+                    <a:lnB w="6350" cap="flat" cmpd="sng" algn="ctr">
+                      <a:solidFill>
+                        <a:srgbClr val="E9F1EC"/>
+                      </a:solidFill>
+                      <a:prstDash val="solid"/>
+                      <a:round/>
+                      <a:headEnd type="none" w="med" len="med"/>
+                      <a:tailEnd type="none" w="med" len="med"/>
+                    </a:lnB>
+                    <a:solidFill>
+                      <a:srgbClr val="FFFFFF"/>
+                    </a:solidFill>
+                  </a:tcPr>
+                </a:tc>
+              </a:tr>
+              <a:tr h="384048">
+                <a:tc>
+                  <a:txBody>
+                    <a:bodyPr/>
+                    <a:lstStyle/>
+                    <a:p>
+                      <a:pPr indent="0" marL="0">
+                        <a:buNone/>
+                      </a:pPr>
+                      <a:r>
+                        <a:rPr lang="en-US" sz="900" b="1" dirty="0">
+                          <a:solidFill>
+                            <a:srgbClr val="17201B"/>
+                          </a:solidFill>
+                        </a:rPr>
+                        <a:t>cl.14</a:t>
+                      </a:r>
+                      <a:endParaRPr lang="en-US" sz="900" dirty="0"/>
+                    </a:p>
+                  </a:txBody>
+                  <a:tcPr marL="91440" marR="91440" marT="45720" marB="45720">
+                    <a:lnL w="6350" cap="flat" cmpd="sng" algn="ctr">
+                      <a:solidFill>
+                        <a:srgbClr val="E9F1EC"/>
+                      </a:solidFill>
+                      <a:prstDash val="solid"/>
+                      <a:round/>
+                      <a:headEnd type="none" w="med" len="med"/>
+                      <a:tailEnd type="none" w="med" len="med"/>
+                    </a:lnL>
+                    <a:lnR w="6350" cap="flat" cmpd="sng" algn="ctr">
+                      <a:solidFill>
+                        <a:srgbClr val="E9F1EC"/>
+                      </a:solidFill>
+                      <a:prstDash val="solid"/>
+                      <a:round/>
+                      <a:headEnd type="none" w="med" len="med"/>
+                      <a:tailEnd type="none" w="med" len="med"/>
+                    </a:lnR>
+                    <a:lnT w="6350" cap="flat" cmpd="sng" algn="ctr">
+                      <a:solidFill>
+                        <a:srgbClr val="E9F1EC"/>
+                      </a:solidFill>
+                      <a:prstDash val="solid"/>
+                      <a:round/>
+                      <a:headEnd type="none" w="med" len="med"/>
+                      <a:tailEnd type="none" w="med" len="med"/>
+                    </a:lnT>
+                    <a:lnB w="6350" cap="flat" cmpd="sng" algn="ctr">
+                      <a:solidFill>
+                        <a:srgbClr val="E9F1EC"/>
+                      </a:solidFill>
+                      <a:prstDash val="solid"/>
+                      <a:round/>
+                      <a:headEnd type="none" w="med" len="med"/>
+                      <a:tailEnd type="none" w="med" len="med"/>
+                    </a:lnB>
+                    <a:solidFill>
+                      <a:srgbClr val="E9F1EC"/>
+                    </a:solidFill>
+                  </a:tcPr>
+                </a:tc>
+                <a:tc>
+                  <a:txBody>
+                    <a:bodyPr/>
+                    <a:lstStyle/>
+                    <a:p>
+                      <a:pPr indent="0" marL="0">
+                        <a:buNone/>
+                      </a:pPr>
+                      <a:r>
+                        <a:rPr lang="en-US" sz="900" dirty="0">
+                          <a:solidFill>
+                            <a:srgbClr val="17201B"/>
+                          </a:solidFill>
+                        </a:rPr>
+                        <a:t>The median may replace the mean when it is lower</a:t>
+                      </a:r>
+                      <a:endParaRPr lang="en-US" sz="900" dirty="0"/>
+                    </a:p>
+                  </a:txBody>
+                  <a:tcPr marL="91440" marR="91440" marT="45720" marB="45720">
+                    <a:lnL w="6350" cap="flat" cmpd="sng" algn="ctr">
+                      <a:solidFill>
+                        <a:srgbClr val="E9F1EC"/>
+                      </a:solidFill>
+                      <a:prstDash val="solid"/>
+                      <a:round/>
+                      <a:headEnd type="none" w="med" len="med"/>
+                      <a:tailEnd type="none" w="med" len="med"/>
+                    </a:lnL>
+                    <a:lnR w="6350" cap="flat" cmpd="sng" algn="ctr">
+                      <a:solidFill>
+                        <a:srgbClr val="E9F1EC"/>
+                      </a:solidFill>
+                      <a:prstDash val="solid"/>
+                      <a:round/>
+                      <a:headEnd type="none" w="med" len="med"/>
+                      <a:tailEnd type="none" w="med" len="med"/>
+                    </a:lnR>
+                    <a:lnT w="6350" cap="flat" cmpd="sng" algn="ctr">
+                      <a:solidFill>
+                        <a:srgbClr val="E9F1EC"/>
+                      </a:solidFill>
+                      <a:prstDash val="solid"/>
+                      <a:round/>
+                      <a:headEnd type="none" w="med" len="med"/>
+                      <a:tailEnd type="none" w="med" len="med"/>
+                    </a:lnT>
+                    <a:lnB w="6350" cap="flat" cmpd="sng" algn="ctr">
+                      <a:solidFill>
+                        <a:srgbClr val="E9F1EC"/>
+                      </a:solidFill>
+                      <a:prstDash val="solid"/>
+                      <a:round/>
+                      <a:headEnd type="none" w="med" len="med"/>
+                      <a:tailEnd type="none" w="med" len="med"/>
+                    </a:lnB>
+                    <a:solidFill>
+                      <a:srgbClr val="E9F1EC"/>
+                    </a:solidFill>
+                  </a:tcPr>
+                </a:tc>
+                <a:tc>
+                  <a:txBody>
+                    <a:bodyPr/>
+                    <a:lstStyle/>
+                    <a:p>
+                      <a:pPr indent="0" marL="0">
+                        <a:buNone/>
+                      </a:pPr>
+                      <a:r>
+                        <a:rPr lang="en-US" sz="900" dirty="0">
+                          <a:solidFill>
+                            <a:srgbClr val="17201B"/>
+                          </a:solidFill>
+                        </a:rPr>
+                        <a:t>median switch</a:t>
+                      </a:r>
+                      <a:endParaRPr lang="en-US" sz="900" dirty="0"/>
+                    </a:p>
+                  </a:txBody>
+                  <a:tcPr marL="91440" marR="91440" marT="45720" marB="45720">
+                    <a:lnL w="6350" cap="flat" cmpd="sng" algn="ctr">
+                      <a:solidFill>
+                        <a:srgbClr val="E9F1EC"/>
+                      </a:solidFill>
+                      <a:prstDash val="solid"/>
+                      <a:round/>
+                      <a:headEnd type="none" w="med" len="med"/>
+                      <a:tailEnd type="none" w="med" len="med"/>
+                    </a:lnL>
+                    <a:lnR w="6350" cap="flat" cmpd="sng" algn="ctr">
+                      <a:solidFill>
+                        <a:srgbClr val="E9F1EC"/>
+                      </a:solidFill>
+                      <a:prstDash val="solid"/>
+                      <a:round/>
+                      <a:headEnd type="none" w="med" len="med"/>
+                      <a:tailEnd type="none" w="med" len="med"/>
+                    </a:lnR>
+                    <a:lnT w="6350" cap="flat" cmpd="sng" algn="ctr">
+                      <a:solidFill>
+                        <a:srgbClr val="E9F1EC"/>
+                      </a:solidFill>
+                      <a:prstDash val="solid"/>
+                      <a:round/>
+                      <a:headEnd type="none" w="med" len="med"/>
+                      <a:tailEnd type="none" w="med" len="med"/>
+                    </a:lnT>
+                    <a:lnB w="6350" cap="flat" cmpd="sng" algn="ctr">
+                      <a:solidFill>
+                        <a:srgbClr val="E9F1EC"/>
+                      </a:solidFill>
+                      <a:prstDash val="solid"/>
+                      <a:round/>
+                      <a:headEnd type="none" w="med" len="med"/>
+                      <a:tailEnd type="none" w="med" len="med"/>
+                    </a:lnB>
+                    <a:solidFill>
+                      <a:srgbClr val="E9F1EC"/>
+                    </a:solidFill>
+                  </a:tcPr>
+                </a:tc>
+              </a:tr>
+              <a:tr h="384048">
+                <a:tc>
+                  <a:txBody>
+                    <a:bodyPr/>
+                    <a:lstStyle/>
+                    <a:p>
+                      <a:pPr indent="0" marL="0">
+                        <a:buNone/>
+                      </a:pPr>
+                      <a:r>
+                        <a:rPr lang="en-US" sz="900" b="1" dirty="0">
+                          <a:solidFill>
+                            <a:srgbClr val="17201B"/>
+                          </a:solidFill>
+                        </a:rPr>
+                        <a:t>cl.18</a:t>
+                      </a:r>
+                      <a:endParaRPr lang="en-US" sz="900" dirty="0"/>
+                    </a:p>
+                  </a:txBody>
+                  <a:tcPr marL="91440" marR="91440" marT="45720" marB="45720">
+                    <a:lnL w="6350" cap="flat" cmpd="sng" algn="ctr">
+                      <a:solidFill>
+                        <a:srgbClr val="E9F1EC"/>
+                      </a:solidFill>
+                      <a:prstDash val="solid"/>
+                      <a:round/>
+                      <a:headEnd type="none" w="med" len="med"/>
+                      <a:tailEnd type="none" w="med" len="med"/>
+                    </a:lnL>
+                    <a:lnR w="6350" cap="flat" cmpd="sng" algn="ctr">
+                      <a:solidFill>
+                        <a:srgbClr val="E9F1EC"/>
+                      </a:solidFill>
+                      <a:prstDash val="solid"/>
+                      <a:round/>
+                      <a:headEnd type="none" w="med" len="med"/>
+                      <a:tailEnd type="none" w="med" len="med"/>
+                    </a:lnR>
+                    <a:lnT w="6350" cap="flat" cmpd="sng" algn="ctr">
+                      <a:solidFill>
+                        <a:srgbClr val="E9F1EC"/>
+                      </a:solidFill>
+                      <a:prstDash val="solid"/>
+                      <a:round/>
+                      <a:headEnd type="none" w="med" len="med"/>
+                      <a:tailEnd type="none" w="med" len="med"/>
+                    </a:lnT>
+                    <a:lnB w="6350" cap="flat" cmpd="sng" algn="ctr">
+                      <a:solidFill>
+                        <a:srgbClr val="E9F1EC"/>
+                      </a:solidFill>
+                      <a:prstDash val="solid"/>
+                      <a:round/>
+                      <a:headEnd type="none" w="med" len="med"/>
+                      <a:tailEnd type="none" w="med" len="med"/>
+                    </a:lnB>
+                    <a:solidFill>
+                      <a:srgbClr val="FFFFFF"/>
+                    </a:solidFill>
+                  </a:tcPr>
+                </a:tc>
+                <a:tc>
+                  <a:txBody>
+                    <a:bodyPr/>
+                    <a:lstStyle/>
+                    <a:p>
+                      <a:pPr indent="0" marL="0">
+                        <a:buNone/>
+                      </a:pPr>
+                      <a:r>
+                        <a:rPr lang="en-US" sz="900" dirty="0">
+                          <a:solidFill>
+                            <a:srgbClr val="17201B"/>
+                          </a:solidFill>
+                        </a:rPr>
+                        <a:t>Receipts credited to the borrower's and co-borrower's bank accounts count as income («банк ҳисобварақларига тушган тушумларини инобатга олади»)</a:t>
+                      </a:r>
+                      <a:endParaRPr lang="en-US" sz="900" dirty="0"/>
+                    </a:p>
+                  </a:txBody>
+                  <a:tcPr marL="91440" marR="91440" marT="45720" marB="45720">
+                    <a:lnL w="6350" cap="flat" cmpd="sng" algn="ctr">
+                      <a:solidFill>
+                        <a:srgbClr val="E9F1EC"/>
+                      </a:solidFill>
+                      <a:prstDash val="solid"/>
+                      <a:round/>
+                      <a:headEnd type="none" w="med" len="med"/>
+                      <a:tailEnd type="none" w="med" len="med"/>
+                    </a:lnL>
+                    <a:lnR w="6350" cap="flat" cmpd="sng" algn="ctr">
+                      <a:solidFill>
+                        <a:srgbClr val="E9F1EC"/>
+                      </a:solidFill>
+                      <a:prstDash val="solid"/>
+                      <a:round/>
+                      <a:headEnd type="none" w="med" len="med"/>
+                      <a:tailEnd type="none" w="med" len="med"/>
+                    </a:lnR>
+                    <a:lnT w="6350" cap="flat" cmpd="sng" algn="ctr">
+                      <a:solidFill>
+                        <a:srgbClr val="E9F1EC"/>
+                      </a:solidFill>
+                      <a:prstDash val="solid"/>
+                      <a:round/>
+                      <a:headEnd type="none" w="med" len="med"/>
+                      <a:tailEnd type="none" w="med" len="med"/>
+                    </a:lnT>
+                    <a:lnB w="6350" cap="flat" cmpd="sng" algn="ctr">
+                      <a:solidFill>
+                        <a:srgbClr val="E9F1EC"/>
+                      </a:solidFill>
+                      <a:prstDash val="solid"/>
+                      <a:round/>
+                      <a:headEnd type="none" w="med" len="med"/>
+                      <a:tailEnd type="none" w="med" len="med"/>
+                    </a:lnB>
+                    <a:solidFill>
+                      <a:srgbClr val="FFFFFF"/>
+                    </a:solidFill>
+                  </a:tcPr>
+                </a:tc>
+                <a:tc>
+                  <a:txBody>
+                    <a:bodyPr/>
+                    <a:lstStyle/>
+                    <a:p>
+                      <a:pPr indent="0" marL="0">
+                        <a:buNone/>
+                      </a:pPr>
+                      <a:r>
+                        <a:rPr lang="en-US" sz="900" dirty="0">
+                          <a:solidFill>
+                            <a:srgbClr val="17201B"/>
+                          </a:solidFill>
+                        </a:rPr>
+                        <a:t>statement-based income</a:t>
+                      </a:r>
+                      <a:endParaRPr lang="en-US" sz="900" dirty="0"/>
+                    </a:p>
+                  </a:txBody>
+                  <a:tcPr marL="91440" marR="91440" marT="45720" marB="45720">
+                    <a:lnL w="6350" cap="flat" cmpd="sng" algn="ctr">
+                      <a:solidFill>
+                        <a:srgbClr val="E9F1EC"/>
+                      </a:solidFill>
+                      <a:prstDash val="solid"/>
+                      <a:round/>
+                      <a:headEnd type="none" w="med" len="med"/>
+                      <a:tailEnd type="none" w="med" len="med"/>
+                    </a:lnL>
+                    <a:lnR w="6350" cap="flat" cmpd="sng" algn="ctr">
+                      <a:solidFill>
+                        <a:srgbClr val="E9F1EC"/>
+                      </a:solidFill>
+                      <a:prstDash val="solid"/>
+                      <a:round/>
+                      <a:headEnd type="none" w="med" len="med"/>
+                      <a:tailEnd type="none" w="med" len="med"/>
+                    </a:lnR>
+                    <a:lnT w="6350" cap="flat" cmpd="sng" algn="ctr">
+                      <a:solidFill>
+                        <a:srgbClr val="E9F1EC"/>
+                      </a:solidFill>
+                      <a:prstDash val="solid"/>
+                      <a:round/>
+                      <a:headEnd type="none" w="med" len="med"/>
+                      <a:tailEnd type="none" w="med" len="med"/>
+                    </a:lnT>
+                    <a:lnB w="6350" cap="flat" cmpd="sng" algn="ctr">
+                      <a:solidFill>
+                        <a:srgbClr val="E9F1EC"/>
+                      </a:solidFill>
+                      <a:prstDash val="solid"/>
+                      <a:round/>
+                      <a:headEnd type="none" w="med" len="med"/>
+                      <a:tailEnd type="none" w="med" len="med"/>
+                    </a:lnB>
+                    <a:solidFill>
+                      <a:srgbClr val="FFFFFF"/>
+                    </a:solidFill>
+                  </a:tcPr>
+                </a:tc>
+              </a:tr>
+              <a:tr h="384048">
+                <a:tc>
+                  <a:txBody>
+                    <a:bodyPr/>
+                    <a:lstStyle/>
+                    <a:p>
+                      <a:pPr indent="0" marL="0">
+                        <a:buNone/>
+                      </a:pPr>
+                      <a:r>
+                        <a:rPr lang="en-US" sz="900" b="1" dirty="0">
+                          <a:solidFill>
+                            <a:srgbClr val="17201B"/>
+                          </a:solidFill>
+                        </a:rPr>
+                        <a:t>cl.19</a:t>
+                      </a:r>
+                      <a:endParaRPr lang="en-US" sz="900" dirty="0"/>
+                    </a:p>
+                  </a:txBody>
+                  <a:tcPr marL="91440" marR="91440" marT="45720" marB="45720">
+                    <a:lnL w="6350" cap="flat" cmpd="sng" algn="ctr">
+                      <a:solidFill>
+                        <a:srgbClr val="E9F1EC"/>
+                      </a:solidFill>
+                      <a:prstDash val="solid"/>
+                      <a:round/>
+                      <a:headEnd type="none" w="med" len="med"/>
+                      <a:tailEnd type="none" w="med" len="med"/>
+                    </a:lnL>
+                    <a:lnR w="6350" cap="flat" cmpd="sng" algn="ctr">
+                      <a:solidFill>
+                        <a:srgbClr val="E9F1EC"/>
+                      </a:solidFill>
+                      <a:prstDash val="solid"/>
+                      <a:round/>
+                      <a:headEnd type="none" w="med" len="med"/>
+                      <a:tailEnd type="none" w="med" len="med"/>
+                    </a:lnR>
+                    <a:lnT w="6350" cap="flat" cmpd="sng" algn="ctr">
+                      <a:solidFill>
+                        <a:srgbClr val="E9F1EC"/>
+                      </a:solidFill>
+                      <a:prstDash val="solid"/>
+                      <a:round/>
+                      <a:headEnd type="none" w="med" len="med"/>
+                      <a:tailEnd type="none" w="med" len="med"/>
+                    </a:lnT>
+                    <a:lnB w="6350" cap="flat" cmpd="sng" algn="ctr">
+                      <a:solidFill>
+                        <a:srgbClr val="E9F1EC"/>
+                      </a:solidFill>
+                      <a:prstDash val="solid"/>
+                      <a:round/>
+                      <a:headEnd type="none" w="med" len="med"/>
+                      <a:tailEnd type="none" w="med" len="med"/>
+                    </a:lnB>
+                    <a:solidFill>
+                      <a:srgbClr val="E9F1EC"/>
+                    </a:solidFill>
+                  </a:tcPr>
+                </a:tc>
+                <a:tc>
+                  <a:txBody>
+                    <a:bodyPr/>
+                    <a:lstStyle/>
+                    <a:p>
+                      <a:pPr indent="0" marL="0">
+                        <a:buNone/>
+                      </a:pPr>
+                      <a:r>
+                        <a:rPr lang="en-US" sz="900" dirty="0">
+                          <a:solidFill>
+                            <a:srgbClr val="17201B"/>
+                          </a:solidFill>
+                        </a:rPr>
+                        <a:t>Documented evidence: salary, pension, funded-pension contributions, tax data incl. the annual declaration, interest/dividends/rent — net of taxes</a:t>
+                      </a:r>
+                      <a:endParaRPr lang="en-US" sz="900" dirty="0"/>
+                    </a:p>
+                  </a:txBody>
+                  <a:tcPr marL="91440" marR="91440" marT="45720" marB="45720">
+                    <a:lnL w="6350" cap="flat" cmpd="sng" algn="ctr">
+                      <a:solidFill>
+                        <a:srgbClr val="E9F1EC"/>
+                      </a:solidFill>
+                      <a:prstDash val="solid"/>
+                      <a:round/>
+                      <a:headEnd type="none" w="med" len="med"/>
+                      <a:tailEnd type="none" w="med" len="med"/>
+                    </a:lnL>
+                    <a:lnR w="6350" cap="flat" cmpd="sng" algn="ctr">
+                      <a:solidFill>
+                        <a:srgbClr val="E9F1EC"/>
+                      </a:solidFill>
+                      <a:prstDash val="solid"/>
+                      <a:round/>
+                      <a:headEnd type="none" w="med" len="med"/>
+                      <a:tailEnd type="none" w="med" len="med"/>
+                    </a:lnR>
+                    <a:lnT w="6350" cap="flat" cmpd="sng" algn="ctr">
+                      <a:solidFill>
+                        <a:srgbClr val="E9F1EC"/>
+                      </a:solidFill>
+                      <a:prstDash val="solid"/>
+                      <a:round/>
+                      <a:headEnd type="none" w="med" len="med"/>
+                      <a:tailEnd type="none" w="med" len="med"/>
+                    </a:lnT>
+                    <a:lnB w="6350" cap="flat" cmpd="sng" algn="ctr">
+                      <a:solidFill>
+                        <a:srgbClr val="E9F1EC"/>
+                      </a:solidFill>
+                      <a:prstDash val="solid"/>
+                      <a:round/>
+                      <a:headEnd type="none" w="med" len="med"/>
+                      <a:tailEnd type="none" w="med" len="med"/>
+                    </a:lnB>
+                    <a:solidFill>
+                      <a:srgbClr val="E9F1EC"/>
                     </a:solidFill>
                   </a:tcPr>
                 </a:tc>
@@ -4753,377 +5488,7 @@
                       <a:tailEnd type="none" w="med" len="med"/>
                     </a:lnB>
                     <a:solidFill>
-                      <a:srgbClr val="FFFFFF"/>
-                    </a:solidFill>
-                  </a:tcPr>
-                </a:tc>
-              </a:tr>
-              <a:tr h="384048">
-                <a:tc>
-                  <a:txBody>
-                    <a:bodyPr/>
-                    <a:lstStyle/>
-                    <a:p>
-                      <a:pPr indent="0" marL="0">
-                        <a:buNone/>
-                      </a:pPr>
-                      <a:r>
-                        <a:rPr lang="en-US" sz="900" b="1" dirty="0">
-                          <a:solidFill>
-                            <a:srgbClr val="17201B"/>
-                          </a:solidFill>
-                        </a:rPr>
-                        <a:t>cl.10</a:t>
-                      </a:r>
-                      <a:endParaRPr lang="en-US" sz="900" dirty="0"/>
-                    </a:p>
-                  </a:txBody>
-                  <a:tcPr marL="91440" marR="91440" marT="45720" marB="45720">
-                    <a:lnL w="6350" cap="flat" cmpd="sng" algn="ctr">
-                      <a:solidFill>
-                        <a:srgbClr val="E9F1EC"/>
-                      </a:solidFill>
-                      <a:prstDash val="solid"/>
-                      <a:round/>
-                      <a:headEnd type="none" w="med" len="med"/>
-                      <a:tailEnd type="none" w="med" len="med"/>
-                    </a:lnL>
-                    <a:lnR w="6350" cap="flat" cmpd="sng" algn="ctr">
-                      <a:solidFill>
-                        <a:srgbClr val="E9F1EC"/>
-                      </a:solidFill>
-                      <a:prstDash val="solid"/>
-                      <a:round/>
-                      <a:headEnd type="none" w="med" len="med"/>
-                      <a:tailEnd type="none" w="med" len="med"/>
-                    </a:lnR>
-                    <a:lnT w="6350" cap="flat" cmpd="sng" algn="ctr">
-                      <a:solidFill>
-                        <a:srgbClr val="E9F1EC"/>
-                      </a:solidFill>
-                      <a:prstDash val="solid"/>
-                      <a:round/>
-                      <a:headEnd type="none" w="med" len="med"/>
-                      <a:tailEnd type="none" w="med" len="med"/>
-                    </a:lnT>
-                    <a:lnB w="6350" cap="flat" cmpd="sng" algn="ctr">
-                      <a:solidFill>
-                        <a:srgbClr val="E9F1EC"/>
-                      </a:solidFill>
-                      <a:prstDash val="solid"/>
-                      <a:round/>
-                      <a:headEnd type="none" w="med" len="med"/>
-                      <a:tailEnd type="none" w="med" len="med"/>
-                    </a:lnB>
-                    <a:solidFill>
                       <a:srgbClr val="E9F1EC"/>
-                    </a:solidFill>
-                  </a:tcPr>
-                </a:tc>
-                <a:tc>
-                  <a:txBody>
-                    <a:bodyPr/>
-                    <a:lstStyle/>
-                    <a:p>
-                      <a:pPr indent="0" marL="0">
-                        <a:buNone/>
-                      </a:pPr>
-                      <a:r>
-                        <a:rPr lang="en-US" sz="900" dirty="0">
-                          <a:solidFill>
-                            <a:srgbClr val="17201B"/>
-                          </a:solidFill>
-                        </a:rPr>
-                        <a:t>Ratio ≤ 50% from 1 January 2025 (60% between 1 July 2024 and 1 January 2025)</a:t>
-                      </a:r>
-                      <a:endParaRPr lang="en-US" sz="900" dirty="0"/>
-                    </a:p>
-                  </a:txBody>
-                  <a:tcPr marL="91440" marR="91440" marT="45720" marB="45720">
-                    <a:lnL w="6350" cap="flat" cmpd="sng" algn="ctr">
-                      <a:solidFill>
-                        <a:srgbClr val="E9F1EC"/>
-                      </a:solidFill>
-                      <a:prstDash val="solid"/>
-                      <a:round/>
-                      <a:headEnd type="none" w="med" len="med"/>
-                      <a:tailEnd type="none" w="med" len="med"/>
-                    </a:lnL>
-                    <a:lnR w="6350" cap="flat" cmpd="sng" algn="ctr">
-                      <a:solidFill>
-                        <a:srgbClr val="E9F1EC"/>
-                      </a:solidFill>
-                      <a:prstDash val="solid"/>
-                      <a:round/>
-                      <a:headEnd type="none" w="med" len="med"/>
-                      <a:tailEnd type="none" w="med" len="med"/>
-                    </a:lnR>
-                    <a:lnT w="6350" cap="flat" cmpd="sng" algn="ctr">
-                      <a:solidFill>
-                        <a:srgbClr val="E9F1EC"/>
-                      </a:solidFill>
-                      <a:prstDash val="solid"/>
-                      <a:round/>
-                      <a:headEnd type="none" w="med" len="med"/>
-                      <a:tailEnd type="none" w="med" len="med"/>
-                    </a:lnT>
-                    <a:lnB w="6350" cap="flat" cmpd="sng" algn="ctr">
-                      <a:solidFill>
-                        <a:srgbClr val="E9F1EC"/>
-                      </a:solidFill>
-                      <a:prstDash val="solid"/>
-                      <a:round/>
-                      <a:headEnd type="none" w="med" len="med"/>
-                      <a:tailEnd type="none" w="med" len="med"/>
-                    </a:lnB>
-                    <a:solidFill>
-                      <a:srgbClr val="E9F1EC"/>
-                    </a:solidFill>
-                  </a:tcPr>
-                </a:tc>
-                <a:tc>
-                  <a:txBody>
-                    <a:bodyPr/>
-                    <a:lstStyle/>
-                    <a:p>
-                      <a:pPr indent="0" marL="0">
-                        <a:buNone/>
-                      </a:pPr>
-                      <a:r>
-                        <a:rPr lang="en-US" sz="900" dirty="0">
-                          <a:solidFill>
-                            <a:srgbClr val="17201B"/>
-                          </a:solidFill>
-                        </a:rPr>
-                        <a:t>cap, pass/fail</a:t>
-                      </a:r>
-                      <a:endParaRPr lang="en-US" sz="900" dirty="0"/>
-                    </a:p>
-                  </a:txBody>
-                  <a:tcPr marL="91440" marR="91440" marT="45720" marB="45720">
-                    <a:lnL w="6350" cap="flat" cmpd="sng" algn="ctr">
-                      <a:solidFill>
-                        <a:srgbClr val="E9F1EC"/>
-                      </a:solidFill>
-                      <a:prstDash val="solid"/>
-                      <a:round/>
-                      <a:headEnd type="none" w="med" len="med"/>
-                      <a:tailEnd type="none" w="med" len="med"/>
-                    </a:lnL>
-                    <a:lnR w="6350" cap="flat" cmpd="sng" algn="ctr">
-                      <a:solidFill>
-                        <a:srgbClr val="E9F1EC"/>
-                      </a:solidFill>
-                      <a:prstDash val="solid"/>
-                      <a:round/>
-                      <a:headEnd type="none" w="med" len="med"/>
-                      <a:tailEnd type="none" w="med" len="med"/>
-                    </a:lnR>
-                    <a:lnT w="6350" cap="flat" cmpd="sng" algn="ctr">
-                      <a:solidFill>
-                        <a:srgbClr val="E9F1EC"/>
-                      </a:solidFill>
-                      <a:prstDash val="solid"/>
-                      <a:round/>
-                      <a:headEnd type="none" w="med" len="med"/>
-                      <a:tailEnd type="none" w="med" len="med"/>
-                    </a:lnT>
-                    <a:lnB w="6350" cap="flat" cmpd="sng" algn="ctr">
-                      <a:solidFill>
-                        <a:srgbClr val="E9F1EC"/>
-                      </a:solidFill>
-                      <a:prstDash val="solid"/>
-                      <a:round/>
-                      <a:headEnd type="none" w="med" len="med"/>
-                      <a:tailEnd type="none" w="med" len="med"/>
-                    </a:lnB>
-                    <a:solidFill>
-                      <a:srgbClr val="E9F1EC"/>
-                    </a:solidFill>
-                  </a:tcPr>
-                </a:tc>
-              </a:tr>
-              <a:tr h="384048">
-                <a:tc>
-                  <a:txBody>
-                    <a:bodyPr/>
-                    <a:lstStyle/>
-                    <a:p>
-                      <a:pPr indent="0" marL="0">
-                        <a:buNone/>
-                      </a:pPr>
-                      <a:r>
-                        <a:rPr lang="en-US" sz="900" b="1" dirty="0">
-                          <a:solidFill>
-                            <a:srgbClr val="17201B"/>
-                          </a:solidFill>
-                        </a:rPr>
-                        <a:t>cl.11</a:t>
-                      </a:r>
-                      <a:endParaRPr lang="en-US" sz="900" dirty="0"/>
-                    </a:p>
-                  </a:txBody>
-                  <a:tcPr marL="91440" marR="91440" marT="45720" marB="45720">
-                    <a:lnL w="6350" cap="flat" cmpd="sng" algn="ctr">
-                      <a:solidFill>
-                        <a:srgbClr val="E9F1EC"/>
-                      </a:solidFill>
-                      <a:prstDash val="solid"/>
-                      <a:round/>
-                      <a:headEnd type="none" w="med" len="med"/>
-                      <a:tailEnd type="none" w="med" len="med"/>
-                    </a:lnL>
-                    <a:lnR w="6350" cap="flat" cmpd="sng" algn="ctr">
-                      <a:solidFill>
-                        <a:srgbClr val="E9F1EC"/>
-                      </a:solidFill>
-                      <a:prstDash val="solid"/>
-                      <a:round/>
-                      <a:headEnd type="none" w="med" len="med"/>
-                      <a:tailEnd type="none" w="med" len="med"/>
-                    </a:lnR>
-                    <a:lnT w="6350" cap="flat" cmpd="sng" algn="ctr">
-                      <a:solidFill>
-                        <a:srgbClr val="E9F1EC"/>
-                      </a:solidFill>
-                      <a:prstDash val="solid"/>
-                      <a:round/>
-                      <a:headEnd type="none" w="med" len="med"/>
-                      <a:tailEnd type="none" w="med" len="med"/>
-                    </a:lnT>
-                    <a:lnB w="6350" cap="flat" cmpd="sng" algn="ctr">
-                      <a:solidFill>
-                        <a:srgbClr val="E9F1EC"/>
-                      </a:solidFill>
-                      <a:prstDash val="solid"/>
-                      <a:round/>
-                      <a:headEnd type="none" w="med" len="med"/>
-                      <a:tailEnd type="none" w="med" len="med"/>
-                    </a:lnB>
-                    <a:solidFill>
-                      <a:srgbClr val="FFFFFF"/>
-                    </a:solidFill>
-                  </a:tcPr>
-                </a:tc>
-                <a:tc>
-                  <a:txBody>
-                    <a:bodyPr/>
-                    <a:lstStyle/>
-                    <a:p>
-                      <a:pPr indent="0" marL="0">
-                        <a:buNone/>
-                      </a:pPr>
-                      <a:r>
-                        <a:rPr lang="en-US" sz="900" dirty="0">
-                          <a:solidFill>
-                            <a:srgbClr val="17201B"/>
-                          </a:solidFill>
-                        </a:rPr>
-                        <a:t>Family-entrepreneurship programme loans exempt from the ratio requirement</a:t>
-                      </a:r>
-                      <a:endParaRPr lang="en-US" sz="900" dirty="0"/>
-                    </a:p>
-                  </a:txBody>
-                  <a:tcPr marL="91440" marR="91440" marT="45720" marB="45720">
-                    <a:lnL w="6350" cap="flat" cmpd="sng" algn="ctr">
-                      <a:solidFill>
-                        <a:srgbClr val="E9F1EC"/>
-                      </a:solidFill>
-                      <a:prstDash val="solid"/>
-                      <a:round/>
-                      <a:headEnd type="none" w="med" len="med"/>
-                      <a:tailEnd type="none" w="med" len="med"/>
-                    </a:lnL>
-                    <a:lnR w="6350" cap="flat" cmpd="sng" algn="ctr">
-                      <a:solidFill>
-                        <a:srgbClr val="E9F1EC"/>
-                      </a:solidFill>
-                      <a:prstDash val="solid"/>
-                      <a:round/>
-                      <a:headEnd type="none" w="med" len="med"/>
-                      <a:tailEnd type="none" w="med" len="med"/>
-                    </a:lnR>
-                    <a:lnT w="6350" cap="flat" cmpd="sng" algn="ctr">
-                      <a:solidFill>
-                        <a:srgbClr val="E9F1EC"/>
-                      </a:solidFill>
-                      <a:prstDash val="solid"/>
-                      <a:round/>
-                      <a:headEnd type="none" w="med" len="med"/>
-                      <a:tailEnd type="none" w="med" len="med"/>
-                    </a:lnT>
-                    <a:lnB w="6350" cap="flat" cmpd="sng" algn="ctr">
-                      <a:solidFill>
-                        <a:srgbClr val="E9F1EC"/>
-                      </a:solidFill>
-                      <a:prstDash val="solid"/>
-                      <a:round/>
-                      <a:headEnd type="none" w="med" len="med"/>
-                      <a:tailEnd type="none" w="med" len="med"/>
-                    </a:lnB>
-                    <a:solidFill>
-                      <a:srgbClr val="FFFFFF"/>
-                    </a:solidFill>
-                  </a:tcPr>
-                </a:tc>
-                <a:tc>
-                  <a:txBody>
-                    <a:bodyPr/>
-                    <a:lstStyle/>
-                    <a:p>
-                      <a:pPr indent="0" marL="0">
-                        <a:buNone/>
-                      </a:pPr>
-                      <a:r>
-                        <a:rPr lang="en-US" sz="900" dirty="0">
-                          <a:solidFill>
-                            <a:srgbClr val="17201B"/>
-                          </a:solidFill>
-                        </a:rPr>
-                        <a:t>exemption badge</a:t>
-                      </a:r>
-                      <a:endParaRPr lang="en-US" sz="900" dirty="0"/>
-                    </a:p>
-                  </a:txBody>
-                  <a:tcPr marL="91440" marR="91440" marT="45720" marB="45720">
-                    <a:lnL w="6350" cap="flat" cmpd="sng" algn="ctr">
-                      <a:solidFill>
-                        <a:srgbClr val="E9F1EC"/>
-                      </a:solidFill>
-                      <a:prstDash val="solid"/>
-                      <a:round/>
-                      <a:headEnd type="none" w="med" len="med"/>
-                      <a:tailEnd type="none" w="med" len="med"/>
-                    </a:lnL>
-                    <a:lnR w="6350" cap="flat" cmpd="sng" algn="ctr">
-                      <a:solidFill>
-                        <a:srgbClr val="E9F1EC"/>
-                      </a:solidFill>
-                      <a:prstDash val="solid"/>
-                      <a:round/>
-                      <a:headEnd type="none" w="med" len="med"/>
-                      <a:tailEnd type="none" w="med" len="med"/>
-                    </a:lnR>
-                    <a:lnT w="6350" cap="flat" cmpd="sng" algn="ctr">
-                      <a:solidFill>
-                        <a:srgbClr val="E9F1EC"/>
-                      </a:solidFill>
-                      <a:prstDash val="solid"/>
-                      <a:round/>
-                      <a:headEnd type="none" w="med" len="med"/>
-                      <a:tailEnd type="none" w="med" len="med"/>
-                    </a:lnT>
-                    <a:lnB w="6350" cap="flat" cmpd="sng" algn="ctr">
-                      <a:solidFill>
-                        <a:srgbClr val="E9F1EC"/>
-                      </a:solidFill>
-                      <a:prstDash val="solid"/>
-                      <a:round/>
-                      <a:headEnd type="none" w="med" len="med"/>
-                      <a:tailEnd type="none" w="med" len="med"/>
-                    </a:lnB>
-                    <a:solidFill>
-                      <a:srgbClr val="FFFFFF"/>
                     </a:solidFill>
                   </a:tcPr>
                 </a:tc>
@@ -5162,7 +5527,7 @@
                   <a:srgbClr val="5C6B63"/>
                 </a:solidFill>
               </a:rPr>
-              <a:t>BRV = 440,000 UZS from 1 September 2026 (previously 412,000); 50 BRV = 22,000,000 UZS. Clause mapping checked against lex.uz/docs/4654149 and 6809992 on 10 Oct 2026; quotes verbatim in docs/REGULATION_QUOTES.md.</a:t>
+              <a:t>CBU Board decision 7/3 of 8 Apr 2025, reg. No. 3618 (22 Apr 2025), in force 24 Jul 2025, amended 5 Dec 2025 (in force 21 Jan 2026) — lex.uz/uz/docs/7491592. Regulation 3205 (lex.uz 4654149) covers MFOs and pawnshops only since 24 Jul 2025 and is not used. Checked 11 Oct 2026; quotes in docs/REGULATION_QUOTES.md.</a:t>
             </a:r>
             <a:endParaRPr lang="en-US" sz="900" dirty="0"/>
           </a:p>
@@ -6922,7 +7287,7 @@
                             <a:srgbClr val="17201B"/>
                           </a:solidFill>
                         </a:rPr>
-                        <a:t>CBU regulation texts (lex.uz 4654149, 6809992)</a:t>
+                        <a:t>CBU Regulation No. 3618 for banks (lex.uz/uz/docs/7491592)</a:t>
                       </a:r>
                       <a:endParaRPr lang="en-US" sz="1050" dirty="0"/>
                     </a:p>
@@ -7370,6 +7735,1256 @@
 </p:sld>
 </file>
 
+<file path=ppt/slides/slide14.xml><?xml version="1.0" encoding="utf-8"?>
+<p:sld xmlns:a="http://schemas.openxmlformats.org/drawingml/2006/main" xmlns:r="http://schemas.openxmlformats.org/officeDocument/2006/relationships" xmlns:p="http://schemas.openxmlformats.org/presentationml/2006/main">
+  <p:cSld name="Slide 14">
+    <p:spTree>
+      <p:nvGrpSpPr>
+        <p:cNvPr id="1" name=""/>
+        <p:cNvGrpSpPr/>
+        <p:nvPr/>
+      </p:nvGrpSpPr>
+      <p:grpSpPr>
+        <a:xfrm>
+          <a:off x="0" y="0"/>
+          <a:ext cx="0" cy="0"/>
+          <a:chOff x="0" y="0"/>
+          <a:chExt cx="0" cy="0"/>
+        </a:xfrm>
+      </p:grpSpPr>
+      <p:sp>
+        <p:nvSpPr>
+          <p:cNvPr id="2" name="Text 0"/>
+          <p:cNvSpPr/>
+          <p:nvPr>
+            <p:ph idx="100" type="title" hasCustomPrompt="1"/>
+          </p:nvPr>
+        </p:nvSpPr>
+        <p:spPr>
+          <a:xfrm>
+            <a:off x="548640" y="365760"/>
+            <a:ext cx="11064240" cy="822960"/>
+          </a:xfrm>
+          <a:prstGeom prst="rect">
+            <a:avLst/>
+          </a:prstGeom>
+          <a:noFill/>
+          <a:ln/>
+        </p:spPr>
+        <p:txBody>
+          <a:bodyPr wrap="square" lIns="0" tIns="0" rIns="0" bIns="0" rtlCol="0" anchor="t"/>
+          <a:lstStyle/>
+          <a:p>
+            <a:pPr algn="l" indent="0" marL="0">
+              <a:buNone/>
+            </a:pPr>
+            <a:r>
+              <a:rPr lang="en-US" sz="2800" b="1" dirty="0">
+                <a:solidFill>
+                  <a:srgbClr val="1F4E3D"/>
+                </a:solidFill>
+              </a:rPr>
+              <a:t>Appendix D · References, Westminster Harvard (1/2)</a:t>
+            </a:r>
+            <a:endParaRPr lang="en-US" sz="2800" dirty="0"/>
+          </a:p>
+        </p:txBody>
+      </p:sp>
+      <p:sp>
+        <p:nvSpPr>
+          <p:cNvPr id="3" name="references 1"/>
+          <p:cNvSpPr txBox="1"/>
+          <p:nvPr/>
+        </p:nvSpPr>
+        <p:spPr>
+          <a:xfrm>
+            <a:off x="548640" y="1280160"/>
+            <a:ext cx="11064240" cy="5029200"/>
+          </a:xfrm>
+          <a:prstGeom prst="rect">
+            <a:avLst/>
+          </a:prstGeom>
+          <a:noFill/>
+          <a:ln/>
+        </p:spPr>
+        <p:txBody>
+          <a:bodyPr wrap="square" lIns="0" tIns="0" rIns="0" bIns="0" rtlCol="0" anchor="t"/>
+          <a:lstStyle/>
+          <a:p>
+            <a:pPr indent="0" marL="0">
+              <a:spcAft>
+                <a:spcPts val="500"/>
+              </a:spcAft>
+              <a:buNone/>
+            </a:pPr>
+            <a:r>
+              <a:rPr lang="en-US" sz="1100" dirty="0">
+                <a:solidFill>
+                  <a:srgbClr val="17201B"/>
+                </a:solidFill>
+              </a:rPr>
+              <a:t>Agency of Statistics under the President of the Republic of Uzbekistan (2026). </a:t>
+            </a:r>
+            <a:pPr indent="0" marL="0">
+              <a:spcAft>
+                <a:spcPts val="500"/>
+              </a:spcAft>
+              <a:buNone/>
+            </a:pPr>
+            <a:r>
+              <a:rPr lang="en-US" sz="1100" i="1" dirty="0">
+                <a:solidFill>
+                  <a:srgbClr val="17201B"/>
+                </a:solidFill>
+              </a:rPr>
+              <a:t>Average monthly nominal wages: official statistics.</a:t>
+            </a:r>
+            <a:pPr indent="0" marL="0">
+              <a:spcAft>
+                <a:spcPts val="500"/>
+              </a:spcAft>
+              <a:buNone/>
+            </a:pPr>
+            <a:r>
+              <a:rPr lang="en-US" sz="1100" dirty="0">
+                <a:solidFill>
+                  <a:srgbClr val="17201B"/>
+                </a:solidFill>
+              </a:rPr>
+              <a:t> Tashkent: Agency of Statistics. Available from https://stat.uz/en/ [Accessed 10 October 2026].</a:t>
+            </a:r>
+            <a:endParaRPr lang="en-US" sz="1100" dirty="0"/>
+          </a:p>
+          <a:p>
+            <a:pPr indent="0" marL="0">
+              <a:spcAft>
+                <a:spcPts val="500"/>
+              </a:spcAft>
+              <a:buNone/>
+            </a:pPr>
+            <a:r>
+              <a:rPr lang="en-US" sz="1100" dirty="0">
+                <a:solidFill>
+                  <a:srgbClr val="17201B"/>
+                </a:solidFill>
+              </a:rPr>
+              <a:t>Berka, P. and Sochorová, M. (1999). Guide to the financial data set. In: </a:t>
+            </a:r>
+            <a:pPr indent="0" marL="0">
+              <a:spcAft>
+                <a:spcPts val="500"/>
+              </a:spcAft>
+              <a:buNone/>
+            </a:pPr>
+            <a:r>
+              <a:rPr lang="en-US" sz="1100" i="1" dirty="0">
+                <a:solidFill>
+                  <a:srgbClr val="17201B"/>
+                </a:solidFill>
+              </a:rPr>
+              <a:t>PKDD'99 Discovery Challenge: workshop notes.</a:t>
+            </a:r>
+            <a:pPr indent="0" marL="0">
+              <a:spcAft>
+                <a:spcPts val="500"/>
+              </a:spcAft>
+              <a:buNone/>
+            </a:pPr>
+            <a:r>
+              <a:rPr lang="en-US" sz="1100" dirty="0">
+                <a:solidFill>
+                  <a:srgbClr val="17201B"/>
+                </a:solidFill>
+              </a:rPr>
+              <a:t> Prague: University of Economics. Available from https://sorry.vse.cz/~berka/challenge/pkdd1999/berka.htm [Accessed 10 October 2026].</a:t>
+            </a:r>
+            <a:endParaRPr lang="en-US" sz="1100" dirty="0"/>
+          </a:p>
+          <a:p>
+            <a:pPr indent="0" marL="0">
+              <a:spcAft>
+                <a:spcPts val="500"/>
+              </a:spcAft>
+              <a:buNone/>
+            </a:pPr>
+            <a:r>
+              <a:rPr lang="en-US" sz="1100" dirty="0">
+                <a:solidFill>
+                  <a:srgbClr val="17201B"/>
+                </a:solidFill>
+              </a:rPr>
+              <a:t>Bradski, G. (2000). The OpenCV library. </a:t>
+            </a:r>
+            <a:pPr indent="0" marL="0">
+              <a:spcAft>
+                <a:spcPts val="500"/>
+              </a:spcAft>
+              <a:buNone/>
+            </a:pPr>
+            <a:r>
+              <a:rPr lang="en-US" sz="1100" i="1" dirty="0">
+                <a:solidFill>
+                  <a:srgbClr val="17201B"/>
+                </a:solidFill>
+              </a:rPr>
+              <a:t>Dr. Dobb's Journal of Software Tools,</a:t>
+            </a:r>
+            <a:pPr indent="0" marL="0">
+              <a:spcAft>
+                <a:spcPts val="500"/>
+              </a:spcAft>
+              <a:buNone/>
+            </a:pPr>
+            <a:r>
+              <a:rPr lang="en-US" sz="1100" dirty="0">
+                <a:solidFill>
+                  <a:srgbClr val="17201B"/>
+                </a:solidFill>
+              </a:rPr>
+              <a:t> 25 (11), 120-125.</a:t>
+            </a:r>
+            <a:endParaRPr lang="en-US" sz="1100" dirty="0"/>
+          </a:p>
+          <a:p>
+            <a:pPr indent="0" marL="0">
+              <a:spcAft>
+                <a:spcPts val="500"/>
+              </a:spcAft>
+              <a:buNone/>
+            </a:pPr>
+            <a:r>
+              <a:rPr lang="en-US" sz="1100" dirty="0">
+                <a:solidFill>
+                  <a:srgbClr val="17201B"/>
+                </a:solidFill>
+              </a:rPr>
+              <a:t>Central Bank of the Republic of Uzbekistan (2019). </a:t>
+            </a:r>
+            <a:pPr indent="0" marL="0">
+              <a:spcAft>
+                <a:spcPts val="500"/>
+              </a:spcAft>
+              <a:buNone/>
+            </a:pPr>
+            <a:r>
+              <a:rPr lang="en-US" sz="1100" i="1" dirty="0">
+                <a:solidFill>
+                  <a:srgbClr val="17201B"/>
+                </a:solidFill>
+              </a:rPr>
+              <a:t>Микромолия ташкилоти ва ломбард томонидан бериладиган кредитлар (микроқарзлар) бўйича қарз олувчи жисмоний шахсларнинг қарз юкини тартибга солиш тўғрисидаги низомни тасдиқлаш ҳақида [On approval of the Regulation on regulating the debt burden of individuals borrowing from microfinance organisations and pawnshops].</a:t>
+            </a:r>
+            <a:pPr indent="0" marL="0">
+              <a:spcAft>
+                <a:spcPts val="500"/>
+              </a:spcAft>
+              <a:buNone/>
+            </a:pPr>
+            <a:r>
+              <a:rPr lang="en-US" sz="1100" dirty="0">
+                <a:solidFill>
+                  <a:srgbClr val="17201B"/>
+                </a:solidFill>
+              </a:rPr>
+              <a:t> Board decision No. 24/5 of 28 September 2019, registration No. 3205 of 19 December 2019, as amended to 24 July 2025. Tashkent: National Database of Legislation of the Republic of Uzbekistan. Available from https://lex.uz/docs/4654149 [Accessed 11 October 2026].</a:t>
+            </a:r>
+            <a:endParaRPr lang="en-US" sz="1100" dirty="0"/>
+          </a:p>
+          <a:p>
+            <a:pPr indent="0" marL="0">
+              <a:spcAft>
+                <a:spcPts val="500"/>
+              </a:spcAft>
+              <a:buNone/>
+            </a:pPr>
+            <a:r>
+              <a:rPr lang="en-US" sz="1100" dirty="0">
+                <a:solidFill>
+                  <a:srgbClr val="17201B"/>
+                </a:solidFill>
+              </a:rPr>
+              <a:t>Central Bank of the Republic of Uzbekistan (2025). </a:t>
+            </a:r>
+            <a:pPr indent="0" marL="0">
+              <a:spcAft>
+                <a:spcPts val="500"/>
+              </a:spcAft>
+              <a:buNone/>
+            </a:pPr>
+            <a:r>
+              <a:rPr lang="en-US" sz="1100" i="1" dirty="0">
+                <a:solidFill>
+                  <a:srgbClr val="17201B"/>
+                </a:solidFill>
+              </a:rPr>
+              <a:t>Банкларга ўрнатиладиган макропруденциал нормативлар ҳамда улар томонидан бериладиган кредитлар (микроқарзлар) бўйича тўловларнинг энг юқори қийматларига доир талаблар тўғрисидаги низомни тасдиқлаш ҳақида [On approval of the Regulation on macroprudential norms set for banks and on the maximum values of payments on loans (microloans) issued by them].</a:t>
+            </a:r>
+            <a:pPr indent="0" marL="0">
+              <a:spcAft>
+                <a:spcPts val="500"/>
+              </a:spcAft>
+              <a:buNone/>
+            </a:pPr>
+            <a:r>
+              <a:rPr lang="en-US" sz="1100" dirty="0">
+                <a:solidFill>
+                  <a:srgbClr val="17201B"/>
+                </a:solidFill>
+              </a:rPr>
+              <a:t> Board decision No. 7/3 of 8 April 2025, registration No. 3618 of 22 April 2025, as amended by Board decision No. 31/9 of 5 December 2025. Tashkent: National Database of Legislation of the Republic of Uzbekistan. Available from https://lex.uz/uz/docs/7491592 [Accessed 11 October 2026].</a:t>
+            </a:r>
+            <a:endParaRPr lang="en-US" sz="1100" dirty="0"/>
+          </a:p>
+          <a:p>
+            <a:pPr indent="0" marL="0">
+              <a:spcAft>
+                <a:spcPts val="500"/>
+              </a:spcAft>
+              <a:buNone/>
+            </a:pPr>
+            <a:r>
+              <a:rPr lang="en-US" sz="1100" dirty="0">
+                <a:solidFill>
+                  <a:srgbClr val="17201B"/>
+                </a:solidFill>
+              </a:rPr>
+              <a:t>Chen, T. and Guestrin, C. (2016). XGBoost: a scalable tree boosting system. In: </a:t>
+            </a:r>
+            <a:pPr indent="0" marL="0">
+              <a:spcAft>
+                <a:spcPts val="500"/>
+              </a:spcAft>
+              <a:buNone/>
+            </a:pPr>
+            <a:r>
+              <a:rPr lang="en-US" sz="1100" i="1" dirty="0">
+                <a:solidFill>
+                  <a:srgbClr val="17201B"/>
+                </a:solidFill>
+              </a:rPr>
+              <a:t>Proceedings of the 22nd ACM SIGKDD International Conference on Knowledge Discovery and Data Mining (KDD '16).</a:t>
+            </a:r>
+            <a:pPr indent="0" marL="0">
+              <a:spcAft>
+                <a:spcPts val="500"/>
+              </a:spcAft>
+              <a:buNone/>
+            </a:pPr>
+            <a:r>
+              <a:rPr lang="en-US" sz="1100" dirty="0">
+                <a:solidFill>
+                  <a:srgbClr val="17201B"/>
+                </a:solidFill>
+              </a:rPr>
+              <a:t> New York: ACM, 785-794. Available from https://doi.org/10.1145/2939672.2939785 [Accessed 10 October 2026].</a:t>
+            </a:r>
+            <a:endParaRPr lang="en-US" sz="1100" dirty="0"/>
+          </a:p>
+          <a:p>
+            <a:pPr indent="0" marL="0">
+              <a:spcAft>
+                <a:spcPts val="500"/>
+              </a:spcAft>
+              <a:buNone/>
+            </a:pPr>
+            <a:r>
+              <a:rPr lang="en-US" sz="1100" dirty="0">
+                <a:solidFill>
+                  <a:srgbClr val="17201B"/>
+                </a:solidFill>
+              </a:rPr>
+              <a:t>e965 (2024). </a:t>
+            </a:r>
+            <a:pPr indent="0" marL="0">
+              <a:spcAft>
+                <a:spcPts val="500"/>
+              </a:spcAft>
+              <a:buNone/>
+            </a:pPr>
+            <a:r>
+              <a:rPr lang="en-US" sz="1100" i="1" dirty="0">
+                <a:solidFill>
+                  <a:srgbClr val="17201B"/>
+                </a:solidFill>
+              </a:rPr>
+              <a:t>sheetjs-npm-publisher: automated npm releases of SheetJS Community Edition (Version 0.20.3) [Computer program].</a:t>
+            </a:r>
+            <a:pPr indent="0" marL="0">
+              <a:spcAft>
+                <a:spcPts val="500"/>
+              </a:spcAft>
+              <a:buNone/>
+            </a:pPr>
+            <a:r>
+              <a:rPr lang="en-US" sz="1100" dirty="0">
+                <a:solidFill>
+                  <a:srgbClr val="17201B"/>
+                </a:solidFill>
+              </a:rPr>
+              <a:t> Available from https://github.com/e965/sheetjs-npm-publisher [Accessed 10 October 2026].</a:t>
+            </a:r>
+            <a:endParaRPr lang="en-US" sz="1100" dirty="0"/>
+          </a:p>
+          <a:p>
+            <a:pPr indent="0" marL="0">
+              <a:spcAft>
+                <a:spcPts val="500"/>
+              </a:spcAft>
+              <a:buNone/>
+            </a:pPr>
+            <a:r>
+              <a:rPr lang="en-US" sz="1100" dirty="0">
+                <a:solidFill>
+                  <a:srgbClr val="17201B"/>
+                </a:solidFill>
+              </a:rPr>
+              <a:t>Harris, C.R. et al. (2020). Array programming with NumPy. </a:t>
+            </a:r>
+            <a:pPr indent="0" marL="0">
+              <a:spcAft>
+                <a:spcPts val="500"/>
+              </a:spcAft>
+              <a:buNone/>
+            </a:pPr>
+            <a:r>
+              <a:rPr lang="en-US" sz="1100" i="1" dirty="0">
+                <a:solidFill>
+                  <a:srgbClr val="17201B"/>
+                </a:solidFill>
+              </a:rPr>
+              <a:t>Nature,</a:t>
+            </a:r>
+            <a:pPr indent="0" marL="0">
+              <a:spcAft>
+                <a:spcPts val="500"/>
+              </a:spcAft>
+              <a:buNone/>
+            </a:pPr>
+            <a:r>
+              <a:rPr lang="en-US" sz="1100" dirty="0">
+                <a:solidFill>
+                  <a:srgbClr val="17201B"/>
+                </a:solidFill>
+              </a:rPr>
+              <a:t> 585 (7825), 357-362. Available from https://doi.org/10.1038/s41586-020-2649-2 [Accessed 10 October 2026].</a:t>
+            </a:r>
+            <a:endParaRPr lang="en-US" sz="1100" dirty="0"/>
+          </a:p>
+          <a:p>
+            <a:pPr indent="0" marL="0">
+              <a:spcAft>
+                <a:spcPts val="500"/>
+              </a:spcAft>
+              <a:buNone/>
+            </a:pPr>
+            <a:r>
+              <a:rPr lang="en-US" sz="1100" dirty="0">
+                <a:solidFill>
+                  <a:srgbClr val="17201B"/>
+                </a:solidFill>
+              </a:rPr>
+              <a:t>Lacko, J. (no date). </a:t>
+            </a:r>
+            <a:pPr indent="0" marL="0">
+              <a:spcAft>
+                <a:spcPts val="500"/>
+              </a:spcAft>
+              <a:buNone/>
+            </a:pPr>
+            <a:r>
+              <a:rPr lang="en-US" sz="1100" i="1" dirty="0">
+                <a:solidFill>
+                  <a:srgbClr val="17201B"/>
+                </a:solidFill>
+              </a:rPr>
+              <a:t>berka-dataset: mirror of the PKDD'99 financial data set [Dataset].</a:t>
+            </a:r>
+            <a:pPr indent="0" marL="0">
+              <a:spcAft>
+                <a:spcPts val="500"/>
+              </a:spcAft>
+              <a:buNone/>
+            </a:pPr>
+            <a:r>
+              <a:rPr lang="en-US" sz="1100" dirty="0">
+                <a:solidFill>
+                  <a:srgbClr val="17201B"/>
+                </a:solidFill>
+              </a:rPr>
+              <a:t> Available from https://github.com/jlacko/berka-dataset [Accessed 10 October 2026].</a:t>
+            </a:r>
+            <a:endParaRPr lang="en-US" sz="1100" dirty="0"/>
+          </a:p>
+          <a:p>
+            <a:pPr indent="0" marL="0">
+              <a:spcAft>
+                <a:spcPts val="500"/>
+              </a:spcAft>
+              <a:buNone/>
+            </a:pPr>
+            <a:r>
+              <a:rPr lang="en-US" sz="1100" dirty="0">
+                <a:solidFill>
+                  <a:srgbClr val="17201B"/>
+                </a:solidFill>
+              </a:rPr>
+              <a:t>McKinney, W. (2010). Data structures for statistical computing in Python. In: van der Walt, S. and Millman, J. (eds.) </a:t>
+            </a:r>
+            <a:pPr indent="0" marL="0">
+              <a:spcAft>
+                <a:spcPts val="500"/>
+              </a:spcAft>
+              <a:buNone/>
+            </a:pPr>
+            <a:r>
+              <a:rPr lang="en-US" sz="1100" i="1" dirty="0">
+                <a:solidFill>
+                  <a:srgbClr val="17201B"/>
+                </a:solidFill>
+              </a:rPr>
+              <a:t>Proceedings of the 9th Python in Science Conference.</a:t>
+            </a:r>
+            <a:pPr indent="0" marL="0">
+              <a:spcAft>
+                <a:spcPts val="500"/>
+              </a:spcAft>
+              <a:buNone/>
+            </a:pPr>
+            <a:r>
+              <a:rPr lang="en-US" sz="1100" dirty="0">
+                <a:solidFill>
+                  <a:srgbClr val="17201B"/>
+                </a:solidFill>
+              </a:rPr>
+              <a:t> Austin, TX: SciPy, 56-61.</a:t>
+            </a:r>
+            <a:endParaRPr lang="en-US" sz="1100" dirty="0"/>
+          </a:p>
+          <a:p>
+            <a:pPr indent="0" marL="0">
+              <a:spcAft>
+                <a:spcPts val="500"/>
+              </a:spcAft>
+              <a:buNone/>
+            </a:pPr>
+            <a:r>
+              <a:rPr lang="en-US" sz="1100" dirty="0">
+                <a:solidFill>
+                  <a:srgbClr val="17201B"/>
+                </a:solidFill>
+              </a:rPr>
+              <a:t>Meta Platforms (2026). </a:t>
+            </a:r>
+            <a:pPr indent="0" marL="0">
+              <a:spcAft>
+                <a:spcPts val="500"/>
+              </a:spcAft>
+              <a:buNone/>
+            </a:pPr>
+            <a:r>
+              <a:rPr lang="en-US" sz="1100" i="1" dirty="0">
+                <a:solidFill>
+                  <a:srgbClr val="17201B"/>
+                </a:solidFill>
+              </a:rPr>
+              <a:t>React (Version 19) [Computer program].</a:t>
+            </a:r>
+            <a:pPr indent="0" marL="0">
+              <a:spcAft>
+                <a:spcPts val="500"/>
+              </a:spcAft>
+              <a:buNone/>
+            </a:pPr>
+            <a:r>
+              <a:rPr lang="en-US" sz="1100" dirty="0">
+                <a:solidFill>
+                  <a:srgbClr val="17201B"/>
+                </a:solidFill>
+              </a:rPr>
+              <a:t> Available from https://react.dev [Accessed 10 October 2026].</a:t>
+            </a:r>
+            <a:endParaRPr lang="en-US" sz="1100" dirty="0"/>
+          </a:p>
+        </p:txBody>
+      </p:sp>
+      <p:sp>
+        <p:nvSpPr>
+          <p:cNvPr id="25" name="Slide Number Placeholder 0"/>
+          <p:cNvSpPr>
+            <a:spLocks noGrp="1"/>
+          </p:cNvSpPr>
+          <p:nvPr>
+            <p:ph type="sldNum" sz="quarter" idx="4294967295"/>
+          </p:nvPr>
+        </p:nvSpPr>
+        <p:spPr>
+          <a:xfrm>
+            <a:off x="11247120" y="6446520"/>
+            <a:ext cx="548640" cy="274320"/>
+          </a:xfrm>
+          <a:prstGeom prst="rect">
+            <a:avLst/>
+          </a:prstGeom>
+          <a:extLst>
+            <a:ext uri="{C572A759-6A51-4108-AA02-DFA0A04FC94B}">
+              <ma14:wrappingTextBoxFlag xmlns:ma14="http://schemas.microsoft.com/office/mac/drawingml/2011/main" val="0"/>
+            </a:ext>
+          </a:extLst>
+        </p:spPr>
+        <p:txBody>
+          <a:bodyPr/>
+          <a:lstStyle>
+            <a:lvl1pPr>
+              <a:defRPr sz="900">
+                <a:solidFill>
+                  <a:srgbClr val="5C6B63"/>
+                </a:solidFill>
+              </a:defRPr>
+            </a:lvl1pPr>
+          </a:lstStyle>
+          <a:p>
+            <a:pPr algn="l"/>
+            <a:fld id="{F7021451-1387-4CA6-816F-3879F97B5CBC}" type="slidenum">
+              <a:rPr b="0" lang="en-US"/>
+              <a:t>14</a:t>
+            </a:fld>
+            <a:endParaRPr lang="en-US"/>
+          </a:p>
+        </p:txBody>
+      </p:sp>
+    </p:spTree>
+  </p:cSld>
+  <p:clrMapOvr>
+    <a:masterClrMapping/>
+  </p:clrMapOvr>
+</p:sld>
+</file>
+
+<file path=ppt/slides/slide15.xml><?xml version="1.0" encoding="utf-8"?>
+<p:sld xmlns:a="http://schemas.openxmlformats.org/drawingml/2006/main" xmlns:r="http://schemas.openxmlformats.org/officeDocument/2006/relationships" xmlns:p="http://schemas.openxmlformats.org/presentationml/2006/main">
+  <p:cSld name="Slide 15">
+    <p:spTree>
+      <p:nvGrpSpPr>
+        <p:cNvPr id="1" name=""/>
+        <p:cNvGrpSpPr/>
+        <p:nvPr/>
+      </p:nvGrpSpPr>
+      <p:grpSpPr>
+        <a:xfrm>
+          <a:off x="0" y="0"/>
+          <a:ext cx="0" cy="0"/>
+          <a:chOff x="0" y="0"/>
+          <a:chExt cx="0" cy="0"/>
+        </a:xfrm>
+      </p:grpSpPr>
+      <p:sp>
+        <p:nvSpPr>
+          <p:cNvPr id="2" name="Text 0"/>
+          <p:cNvSpPr/>
+          <p:nvPr>
+            <p:ph idx="100" type="title" hasCustomPrompt="1"/>
+          </p:nvPr>
+        </p:nvSpPr>
+        <p:spPr>
+          <a:xfrm>
+            <a:off x="548640" y="365760"/>
+            <a:ext cx="11064240" cy="822960"/>
+          </a:xfrm>
+          <a:prstGeom prst="rect">
+            <a:avLst/>
+          </a:prstGeom>
+          <a:noFill/>
+          <a:ln/>
+        </p:spPr>
+        <p:txBody>
+          <a:bodyPr wrap="square" lIns="0" tIns="0" rIns="0" bIns="0" rtlCol="0" anchor="t"/>
+          <a:lstStyle/>
+          <a:p>
+            <a:pPr algn="l" indent="0" marL="0">
+              <a:buNone/>
+            </a:pPr>
+            <a:r>
+              <a:rPr lang="en-US" sz="2800" b="1" dirty="0">
+                <a:solidFill>
+                  <a:srgbClr val="1F4E3D"/>
+                </a:solidFill>
+              </a:rPr>
+              <a:t>Appendix D · References, Westminster Harvard (2/2)</a:t>
+            </a:r>
+            <a:endParaRPr lang="en-US" sz="2800" dirty="0"/>
+          </a:p>
+        </p:txBody>
+      </p:sp>
+      <p:sp>
+        <p:nvSpPr>
+          <p:cNvPr id="3" name="references 2"/>
+          <p:cNvSpPr txBox="1"/>
+          <p:nvPr/>
+        </p:nvSpPr>
+        <p:spPr>
+          <a:xfrm>
+            <a:off x="548640" y="1280160"/>
+            <a:ext cx="11064240" cy="5029200"/>
+          </a:xfrm>
+          <a:prstGeom prst="rect">
+            <a:avLst/>
+          </a:prstGeom>
+          <a:noFill/>
+          <a:ln/>
+        </p:spPr>
+        <p:txBody>
+          <a:bodyPr wrap="square" lIns="0" tIns="0" rIns="0" bIns="0" rtlCol="0" anchor="t"/>
+          <a:lstStyle/>
+          <a:p>
+            <a:pPr indent="0" marL="0">
+              <a:spcAft>
+                <a:spcPts val="500"/>
+              </a:spcAft>
+              <a:buNone/>
+            </a:pPr>
+            <a:r>
+              <a:rPr lang="en-US" sz="1100" dirty="0">
+                <a:solidFill>
+                  <a:srgbClr val="17201B"/>
+                </a:solidFill>
+              </a:rPr>
+              <a:t>Microsoft (2026). </a:t>
+            </a:r>
+            <a:pPr indent="0" marL="0">
+              <a:spcAft>
+                <a:spcPts val="500"/>
+              </a:spcAft>
+              <a:buNone/>
+            </a:pPr>
+            <a:r>
+              <a:rPr lang="en-US" sz="1100" i="1" dirty="0">
+                <a:solidFill>
+                  <a:srgbClr val="17201B"/>
+                </a:solidFill>
+              </a:rPr>
+              <a:t>Playwright [Computer program].</a:t>
+            </a:r>
+            <a:pPr indent="0" marL="0">
+              <a:spcAft>
+                <a:spcPts val="500"/>
+              </a:spcAft>
+              <a:buNone/>
+            </a:pPr>
+            <a:r>
+              <a:rPr lang="en-US" sz="1100" dirty="0">
+                <a:solidFill>
+                  <a:srgbClr val="17201B"/>
+                </a:solidFill>
+              </a:rPr>
+              <a:t> Available from https://playwright.dev [Accessed 10 October 2026].</a:t>
+            </a:r>
+            <a:endParaRPr lang="en-US" sz="1100" dirty="0"/>
+          </a:p>
+          <a:p>
+            <a:pPr indent="0" marL="0">
+              <a:spcAft>
+                <a:spcPts val="500"/>
+              </a:spcAft>
+              <a:buNone/>
+            </a:pPr>
+            <a:r>
+              <a:rPr lang="en-US" sz="1100" dirty="0">
+                <a:solidFill>
+                  <a:srgbClr val="17201B"/>
+                </a:solidFill>
+              </a:rPr>
+              <a:t>Mikrokreditbank (2026). </a:t>
+            </a:r>
+            <a:pPr indent="0" marL="0">
+              <a:spcAft>
+                <a:spcPts val="500"/>
+              </a:spcAft>
+              <a:buNone/>
+            </a:pPr>
+            <a:r>
+              <a:rPr lang="en-US" sz="1100" i="1" dirty="0">
+                <a:solidFill>
+                  <a:srgbClr val="17201B"/>
+                </a:solidFill>
+              </a:rPr>
+              <a:t>Credit products: Ommabop 2, Express, Business Online 2 and family-entrepreneurship programmes.</a:t>
+            </a:r>
+            <a:pPr indent="0" marL="0">
+              <a:spcAft>
+                <a:spcPts val="500"/>
+              </a:spcAft>
+              <a:buNone/>
+            </a:pPr>
+            <a:r>
+              <a:rPr lang="en-US" sz="1100" dirty="0">
+                <a:solidFill>
+                  <a:srgbClr val="17201B"/>
+                </a:solidFill>
+              </a:rPr>
+              <a:t> Available from https://mkbank.uz [Accessed 10 October 2026].</a:t>
+            </a:r>
+            <a:endParaRPr lang="en-US" sz="1100" dirty="0"/>
+          </a:p>
+          <a:p>
+            <a:pPr indent="0" marL="0">
+              <a:spcAft>
+                <a:spcPts val="500"/>
+              </a:spcAft>
+              <a:buNone/>
+            </a:pPr>
+            <a:r>
+              <a:rPr lang="en-US" sz="1100" dirty="0">
+                <a:solidFill>
+                  <a:srgbClr val="17201B"/>
+                </a:solidFill>
+              </a:rPr>
+              <a:t>Mozilla (2025). </a:t>
+            </a:r>
+            <a:pPr indent="0" marL="0">
+              <a:spcAft>
+                <a:spcPts val="500"/>
+              </a:spcAft>
+              <a:buNone/>
+            </a:pPr>
+            <a:r>
+              <a:rPr lang="en-US" sz="1100" i="1" dirty="0">
+                <a:solidFill>
+                  <a:srgbClr val="17201B"/>
+                </a:solidFill>
+              </a:rPr>
+              <a:t>PDF.js (pdfjs-dist Version 4.10) [Computer program].</a:t>
+            </a:r>
+            <a:pPr indent="0" marL="0">
+              <a:spcAft>
+                <a:spcPts val="500"/>
+              </a:spcAft>
+              <a:buNone/>
+            </a:pPr>
+            <a:r>
+              <a:rPr lang="en-US" sz="1100" dirty="0">
+                <a:solidFill>
+                  <a:srgbClr val="17201B"/>
+                </a:solidFill>
+              </a:rPr>
+              <a:t> Available from https://github.com/mozilla/pdf.js [Accessed 10 October 2026].</a:t>
+            </a:r>
+            <a:endParaRPr lang="en-US" sz="1100" dirty="0"/>
+          </a:p>
+          <a:p>
+            <a:pPr indent="0" marL="0">
+              <a:spcAft>
+                <a:spcPts val="500"/>
+              </a:spcAft>
+              <a:buNone/>
+            </a:pPr>
+            <a:r>
+              <a:rPr lang="en-US" sz="1100" dirty="0">
+                <a:solidFill>
+                  <a:srgbClr val="17201B"/>
+                </a:solidFill>
+              </a:rPr>
+              <a:t>Pedregosa, F. et al. (2011). Scikit-learn: machine learning in Python. </a:t>
+            </a:r>
+            <a:pPr indent="0" marL="0">
+              <a:spcAft>
+                <a:spcPts val="500"/>
+              </a:spcAft>
+              <a:buNone/>
+            </a:pPr>
+            <a:r>
+              <a:rPr lang="en-US" sz="1100" i="1" dirty="0">
+                <a:solidFill>
+                  <a:srgbClr val="17201B"/>
+                </a:solidFill>
+              </a:rPr>
+              <a:t>Journal of Machine Learning Research,</a:t>
+            </a:r>
+            <a:pPr indent="0" marL="0">
+              <a:spcAft>
+                <a:spcPts val="500"/>
+              </a:spcAft>
+              <a:buNone/>
+            </a:pPr>
+            <a:r>
+              <a:rPr lang="en-US" sz="1100" dirty="0">
+                <a:solidFill>
+                  <a:srgbClr val="17201B"/>
+                </a:solidFill>
+              </a:rPr>
+              <a:t> 12, 2825-2830.</a:t>
+            </a:r>
+            <a:endParaRPr lang="en-US" sz="1100" dirty="0"/>
+          </a:p>
+          <a:p>
+            <a:pPr indent="0" marL="0">
+              <a:spcAft>
+                <a:spcPts val="500"/>
+              </a:spcAft>
+              <a:buNone/>
+            </a:pPr>
+            <a:r>
+              <a:rPr lang="en-US" sz="1100" dirty="0">
+                <a:solidFill>
+                  <a:srgbClr val="17201B"/>
+                </a:solidFill>
+              </a:rPr>
+              <a:t>SheetJS LLC (2024). </a:t>
+            </a:r>
+            <a:pPr indent="0" marL="0">
+              <a:spcAft>
+                <a:spcPts val="500"/>
+              </a:spcAft>
+              <a:buNone/>
+            </a:pPr>
+            <a:r>
+              <a:rPr lang="en-US" sz="1100" i="1" dirty="0">
+                <a:solidFill>
+                  <a:srgbClr val="17201B"/>
+                </a:solidFill>
+              </a:rPr>
+              <a:t>SheetJS Community Edition (Version 0.20.3) [Computer program].</a:t>
+            </a:r>
+            <a:pPr indent="0" marL="0">
+              <a:spcAft>
+                <a:spcPts val="500"/>
+              </a:spcAft>
+              <a:buNone/>
+            </a:pPr>
+            <a:r>
+              <a:rPr lang="en-US" sz="1100" dirty="0">
+                <a:solidFill>
+                  <a:srgbClr val="17201B"/>
+                </a:solidFill>
+              </a:rPr>
+              <a:t> Available from https://sheetjs.com [Accessed 10 October 2026].</a:t>
+            </a:r>
+            <a:endParaRPr lang="en-US" sz="1100" dirty="0"/>
+          </a:p>
+          <a:p>
+            <a:pPr indent="0" marL="0">
+              <a:spcAft>
+                <a:spcPts val="500"/>
+              </a:spcAft>
+              <a:buNone/>
+            </a:pPr>
+            <a:r>
+              <a:rPr lang="en-US" sz="1100" dirty="0">
+                <a:solidFill>
+                  <a:srgbClr val="17201B"/>
+                </a:solidFill>
+              </a:rPr>
+              <a:t>Smith, R. (2007). An overview of the Tesseract OCR engine. In: </a:t>
+            </a:r>
+            <a:pPr indent="0" marL="0">
+              <a:spcAft>
+                <a:spcPts val="500"/>
+              </a:spcAft>
+              <a:buNone/>
+            </a:pPr>
+            <a:r>
+              <a:rPr lang="en-US" sz="1100" i="1" dirty="0">
+                <a:solidFill>
+                  <a:srgbClr val="17201B"/>
+                </a:solidFill>
+              </a:rPr>
+              <a:t>Ninth International Conference on Document Analysis and Recognition (ICDAR 2007).</a:t>
+            </a:r>
+            <a:pPr indent="0" marL="0">
+              <a:spcAft>
+                <a:spcPts val="500"/>
+              </a:spcAft>
+              <a:buNone/>
+            </a:pPr>
+            <a:r>
+              <a:rPr lang="en-US" sz="1100" dirty="0">
+                <a:solidFill>
+                  <a:srgbClr val="17201B"/>
+                </a:solidFill>
+              </a:rPr>
+              <a:t> Washington, DC: IEEE Computer Society, 629-633. Available from https://doi.org/10.1109/ICDAR.2007.4376991 [Accessed 10 October 2026].</a:t>
+            </a:r>
+            <a:endParaRPr lang="en-US" sz="1100" dirty="0"/>
+          </a:p>
+          <a:p>
+            <a:pPr indent="0" marL="0">
+              <a:spcAft>
+                <a:spcPts val="500"/>
+              </a:spcAft>
+              <a:buNone/>
+            </a:pPr>
+            <a:r>
+              <a:rPr lang="en-US" sz="1100" dirty="0">
+                <a:solidFill>
+                  <a:srgbClr val="17201B"/>
+                </a:solidFill>
+              </a:rPr>
+              <a:t>Spot (2026). </a:t>
+            </a:r>
+            <a:pPr indent="0" marL="0">
+              <a:spcAft>
+                <a:spcPts val="500"/>
+              </a:spcAft>
+              <a:buNone/>
+            </a:pPr>
+            <a:r>
+              <a:rPr lang="en-US" sz="1100" i="1" dirty="0">
+                <a:solidFill>
+                  <a:srgbClr val="17201B"/>
+                </a:solidFill>
+              </a:rPr>
+              <a:t>«Микрокредитбанк» выделит 7,4 трлн сумов малому и среднему бизнесу в 2026 году [Mikrokreditbank will allocate 7.4 trillion soums to small and medium business in 2026].</a:t>
+            </a:r>
+            <a:pPr indent="0" marL="0">
+              <a:spcAft>
+                <a:spcPts val="500"/>
+              </a:spcAft>
+              <a:buNone/>
+            </a:pPr>
+            <a:r>
+              <a:rPr lang="en-US" sz="1100" dirty="0">
+                <a:solidFill>
+                  <a:srgbClr val="17201B"/>
+                </a:solidFill>
+              </a:rPr>
+              <a:t> Sponsored article, 27 March. Available from https://www.spot.uz/ru/2026/03/27/mk-bank/ [Accessed 10 October 2026].</a:t>
+            </a:r>
+            <a:endParaRPr lang="en-US" sz="1100" dirty="0"/>
+          </a:p>
+          <a:p>
+            <a:pPr indent="0" marL="0">
+              <a:spcAft>
+                <a:spcPts val="500"/>
+              </a:spcAft>
+              <a:buNone/>
+            </a:pPr>
+            <a:r>
+              <a:rPr lang="en-US" sz="1100" dirty="0">
+                <a:solidFill>
+                  <a:srgbClr val="17201B"/>
+                </a:solidFill>
+              </a:rPr>
+              <a:t>Tesseract OCR (no date). </a:t>
+            </a:r>
+            <a:pPr indent="0" marL="0">
+              <a:spcAft>
+                <a:spcPts val="500"/>
+              </a:spcAft>
+              <a:buNone/>
+            </a:pPr>
+            <a:r>
+              <a:rPr lang="en-US" sz="1100" i="1" dirty="0">
+                <a:solidFill>
+                  <a:srgbClr val="17201B"/>
+                </a:solidFill>
+              </a:rPr>
+              <a:t>tessdata_fast: fast integer versions of trained LSTM models (uzb, uzb_cyrl, rus, eng) [Data files].</a:t>
+            </a:r>
+            <a:pPr indent="0" marL="0">
+              <a:spcAft>
+                <a:spcPts val="500"/>
+              </a:spcAft>
+              <a:buNone/>
+            </a:pPr>
+            <a:r>
+              <a:rPr lang="en-US" sz="1100" dirty="0">
+                <a:solidFill>
+                  <a:srgbClr val="17201B"/>
+                </a:solidFill>
+              </a:rPr>
+              <a:t> Available from https://github.com/tesseract-ocr/tessdata_fast [Accessed 10 October 2026].</a:t>
+            </a:r>
+            <a:endParaRPr lang="en-US" sz="1100" dirty="0"/>
+          </a:p>
+          <a:p>
+            <a:pPr indent="0" marL="0">
+              <a:spcAft>
+                <a:spcPts val="500"/>
+              </a:spcAft>
+              <a:buNone/>
+            </a:pPr>
+            <a:r>
+              <a:rPr lang="en-US" sz="1100" dirty="0">
+                <a:solidFill>
+                  <a:srgbClr val="17201B"/>
+                </a:solidFill>
+              </a:rPr>
+              <a:t>Tesseract.js contributors (2025). </a:t>
+            </a:r>
+            <a:pPr indent="0" marL="0">
+              <a:spcAft>
+                <a:spcPts val="500"/>
+              </a:spcAft>
+              <a:buNone/>
+            </a:pPr>
+            <a:r>
+              <a:rPr lang="en-US" sz="1100" i="1" dirty="0">
+                <a:solidFill>
+                  <a:srgbClr val="17201B"/>
+                </a:solidFill>
+              </a:rPr>
+              <a:t>Tesseract.js (Version 6) [Computer program].</a:t>
+            </a:r>
+            <a:pPr indent="0" marL="0">
+              <a:spcAft>
+                <a:spcPts val="500"/>
+              </a:spcAft>
+              <a:buNone/>
+            </a:pPr>
+            <a:r>
+              <a:rPr lang="en-US" sz="1100" dirty="0">
+                <a:solidFill>
+                  <a:srgbClr val="17201B"/>
+                </a:solidFill>
+              </a:rPr>
+              <a:t> Available from https://github.com/naptha/tesseract.js [Accessed 10 October 2026].</a:t>
+            </a:r>
+            <a:endParaRPr lang="en-US" sz="1100" dirty="0"/>
+          </a:p>
+          <a:p>
+            <a:pPr indent="0" marL="0">
+              <a:spcAft>
+                <a:spcPts val="500"/>
+              </a:spcAft>
+              <a:buNone/>
+            </a:pPr>
+            <a:r>
+              <a:rPr lang="en-US" sz="1100" dirty="0">
+                <a:solidFill>
+                  <a:srgbClr val="17201B"/>
+                </a:solidFill>
+              </a:rPr>
+              <a:t>Vercel (2026). </a:t>
+            </a:r>
+            <a:pPr indent="0" marL="0">
+              <a:spcAft>
+                <a:spcPts val="500"/>
+              </a:spcAft>
+              <a:buNone/>
+            </a:pPr>
+            <a:r>
+              <a:rPr lang="en-US" sz="1100" i="1" dirty="0">
+                <a:solidFill>
+                  <a:srgbClr val="17201B"/>
+                </a:solidFill>
+              </a:rPr>
+              <a:t>Next.js (Version 16) [Computer program].</a:t>
+            </a:r>
+            <a:pPr indent="0" marL="0">
+              <a:spcAft>
+                <a:spcPts val="500"/>
+              </a:spcAft>
+              <a:buNone/>
+            </a:pPr>
+            <a:r>
+              <a:rPr lang="en-US" sz="1100" dirty="0">
+                <a:solidFill>
+                  <a:srgbClr val="17201B"/>
+                </a:solidFill>
+              </a:rPr>
+              <a:t> Available from https://nextjs.org [Accessed 10 October 2026].</a:t>
+            </a:r>
+            <a:endParaRPr lang="en-US" sz="1100" dirty="0"/>
+          </a:p>
+          <a:p>
+            <a:pPr indent="0" marL="0">
+              <a:spcAft>
+                <a:spcPts val="500"/>
+              </a:spcAft>
+              <a:buNone/>
+            </a:pPr>
+            <a:r>
+              <a:rPr lang="en-US" sz="1100" dirty="0">
+                <a:solidFill>
+                  <a:srgbClr val="17201B"/>
+                </a:solidFill>
+              </a:rPr>
+              <a:t>Yuz.uz (2021). </a:t>
+            </a:r>
+            <a:pPr indent="0" marL="0">
+              <a:spcAft>
+                <a:spcPts val="500"/>
+              </a:spcAft>
+              <a:buNone/>
+            </a:pPr>
+            <a:r>
+              <a:rPr lang="en-US" sz="1100" i="1" dirty="0">
+                <a:solidFill>
+                  <a:srgbClr val="17201B"/>
+                </a:solidFill>
+              </a:rPr>
+              <a:t>Почти 800 тысяч граждан Узбекистана выбрали самозанятость [Nearly 800 thousand citizens of Uzbekistan chose self-employment].</a:t>
+            </a:r>
+            <a:pPr indent="0" marL="0">
+              <a:spcAft>
+                <a:spcPts val="500"/>
+              </a:spcAft>
+              <a:buNone/>
+            </a:pPr>
+            <a:r>
+              <a:rPr lang="en-US" sz="1100" dirty="0">
+                <a:solidFill>
+                  <a:srgbClr val="17201B"/>
+                </a:solidFill>
+              </a:rPr>
+              <a:t> 6 May. Available from https://yuz.uz/ru/news/pochti-800-tsyach-grajdan-uzbekistana-vbrali-samozanyatost [Accessed 10 October 2026].</a:t>
+            </a:r>
+            <a:endParaRPr lang="en-US" sz="1100" dirty="0"/>
+          </a:p>
+        </p:txBody>
+      </p:sp>
+      <p:sp>
+        <p:nvSpPr>
+          <p:cNvPr id="25" name="Slide Number Placeholder 0"/>
+          <p:cNvSpPr>
+            <a:spLocks noGrp="1"/>
+          </p:cNvSpPr>
+          <p:nvPr>
+            <p:ph type="sldNum" sz="quarter" idx="4294967295"/>
+          </p:nvPr>
+        </p:nvSpPr>
+        <p:spPr>
+          <a:xfrm>
+            <a:off x="11247120" y="6446520"/>
+            <a:ext cx="548640" cy="274320"/>
+          </a:xfrm>
+          <a:prstGeom prst="rect">
+            <a:avLst/>
+          </a:prstGeom>
+          <a:extLst>
+            <a:ext uri="{C572A759-6A51-4108-AA02-DFA0A04FC94B}">
+              <ma14:wrappingTextBoxFlag xmlns:ma14="http://schemas.microsoft.com/office/mac/drawingml/2011/main" val="0"/>
+            </a:ext>
+          </a:extLst>
+        </p:spPr>
+        <p:txBody>
+          <a:bodyPr/>
+          <a:lstStyle>
+            <a:lvl1pPr>
+              <a:defRPr sz="900">
+                <a:solidFill>
+                  <a:srgbClr val="5C6B63"/>
+                </a:solidFill>
+              </a:defRPr>
+            </a:lvl1pPr>
+          </a:lstStyle>
+          <a:p>
+            <a:pPr algn="l"/>
+            <a:fld id="{F7021451-1387-4CA6-816F-3879F97B5CBC}" type="slidenum">
+              <a:rPr b="0" lang="en-US"/>
+              <a:t>15</a:t>
+            </a:fld>
+            <a:endParaRPr lang="en-US"/>
+          </a:p>
+        </p:txBody>
+      </p:sp>
+    </p:spTree>
+  </p:cSld>
+  <p:clrMapOvr>
+    <a:masterClrMapping/>
+  </p:clrMapOvr>
+</p:sld>
+</file>
+
 <file path=ppt/slides/slide2.xml><?xml version="1.0" encoding="utf-8"?>
 <p:sld xmlns:a="http://schemas.openxmlformats.org/drawingml/2006/main" xmlns:r="http://schemas.openxmlformats.org/officeDocument/2006/relationships" xmlns:p="http://schemas.openxmlformats.org/presentationml/2006/main">
   <p:cSld name="Slide 2">
@@ -7455,7 +9070,7 @@
                   <a:srgbClr val="5C6B63"/>
                 </a:solidFill>
               </a:rPr>
-              <a:t>CBU regulation on the debt-burden ratio, cl.9 — income a lender may rely on</a:t>
+              <a:t>CBU Regulation No. 3618 for banks, cl.19 — documented income; cl.18 — receipts on the borrower's accounts</a:t>
             </a:r>
             <a:endParaRPr lang="en-US" sz="1400" dirty="0"/>
           </a:p>
@@ -7836,7 +9451,7 @@
                   <a:srgbClr val="17201B"/>
                 </a:solidFill>
               </a:rPr>
-              <a:t>Income credited to the borrower's bank accounts</a:t>
+              <a:t>Receipts credited to the borrower's bank accounts (cl.18)</a:t>
             </a:r>
             <a:pPr indent="0" marL="0">
               <a:buNone/>
@@ -7934,7 +9549,7 @@
                   <a:srgbClr val="17201B"/>
                 </a:solidFill>
               </a:rPr>
-              <a:t>Taxes paid</a:t>
+              <a:t>Tax data incl. the annual income declaration</a:t>
             </a:r>
             <a:pPr indent="0" marL="0">
               <a:buNone/>
@@ -7945,7 +9560,7 @@
                   <a:srgbClr val="17201B"/>
                 </a:solidFill>
               </a:rPr>
-              <a:t>  — self-employed income is untaxed; no return is filed</a:t>
+              <a:t>  — self-employed income is untaxed; no declaration is filed</a:t>
             </a:r>
             <a:endParaRPr lang="en-US" sz="1200" dirty="0"/>
           </a:p>
@@ -8051,7 +9666,7 @@
       </p:sp>
       <p:sp>
         <p:nvSpPr>
-          <p:cNvPr id="22" name="tile ПДН limit for all loans since 1 Jan 2025 (cl.10); 12-month arithmetic mean of income (cl.7)"/>
+          <p:cNvPr id="22" name="tile ПДН limit for bank loans (cl.3); income = mean of 6–12 months of receipts (cl.13, cl.18); 50–100% only inside a 15% quota"/>
           <p:cNvSpPr/>
           <p:nvPr/>
         </p:nvSpPr>
@@ -8078,7 +9693,7 @@
       </p:sp>
       <p:sp>
         <p:nvSpPr>
-          <p:cNvPr id="23" name="tile value ПДН limit for all loans since 1 Jan 2025 (cl.10); 12-month arithmetic mean of income (cl.7)"/>
+          <p:cNvPr id="23" name="tile value ПДН limit for bank loans (cl.3); income = mean of 6–12 months of receipts (cl.13, cl.18); 50–100% only inside a 15% quota"/>
           <p:cNvSpPr txBox="1"/>
           <p:nvPr/>
         </p:nvSpPr>
@@ -8106,7 +9721,7 @@
                   <a:srgbClr val="FFFFFF"/>
                 </a:solidFill>
               </a:rPr>
-              <a:t>50% cap</a:t>
+              <a:t>50% limit</a:t>
             </a:r>
             <a:endParaRPr lang="en-US" sz="2800" dirty="0"/>
           </a:p>
@@ -8114,7 +9729,7 @@
       </p:sp>
       <p:sp>
         <p:nvSpPr>
-          <p:cNvPr id="24" name="tile label ПДН limit for all loans since 1 Jan 2025 (cl.10); 12-month arithmetic mean of income (cl.7)"/>
+          <p:cNvPr id="24" name="tile label ПДН limit for bank loans (cl.3); income = mean of 6–12 months of receipts (cl.13, cl.18); 50–100% only inside a 15% quota"/>
           <p:cNvSpPr txBox="1"/>
           <p:nvPr/>
         </p:nvSpPr>
@@ -8142,7 +9757,7 @@
                   <a:srgbClr val="8FB8A5"/>
                 </a:solidFill>
               </a:rPr>
-              <a:t>ПДН limit for all loans since 1 Jan 2025 (cl.10); 12-month arithmetic mean of income (cl.7)</a:t>
+              <a:t>ПДН limit for bank loans (cl.3); income = mean of 6–12 months of receipts (cl.13, cl.18); 50–100% only inside a 15% quota</a:t>
             </a:r>
             <a:endParaRPr lang="en-US" sz="1100" dirty="0"/>
           </a:p>
@@ -8150,7 +9765,7 @@
       </p:sp>
       <p:sp>
         <p:nvSpPr>
-          <p:cNvPr id="25" name="tile micro-projects MKBANK targets in 2026 (47,975 in 2025); 1,062 mahalla agents"/>
+          <p:cNvPr id="25" name="tile projects MKBANK plans under its lending programmes in 2026 (47,975 micro-projects financed in 2025); 1,062 mahalla agents"/>
           <p:cNvSpPr/>
           <p:nvPr/>
         </p:nvSpPr>
@@ -8177,7 +9792,7 @@
       </p:sp>
       <p:sp>
         <p:nvSpPr>
-          <p:cNvPr id="26" name="tile value micro-projects MKBANK targets in 2026 (47,975 in 2025); 1,062 mahalla agents"/>
+          <p:cNvPr id="26" name="tile value projects MKBANK plans under its lending programmes in 2026 (47,975 micro-projects financed in 2025); 1,062 mahalla agents"/>
           <p:cNvSpPr txBox="1"/>
           <p:nvPr/>
         </p:nvSpPr>
@@ -8213,7 +9828,7 @@
       </p:sp>
       <p:sp>
         <p:nvSpPr>
-          <p:cNvPr id="27" name="tile label micro-projects MKBANK targets in 2026 (47,975 in 2025); 1,062 mahalla agents"/>
+          <p:cNvPr id="27" name="tile label projects MKBANK plans under its lending programmes in 2026 (47,975 micro-projects financed in 2025); 1,062 mahalla agents"/>
           <p:cNvSpPr txBox="1"/>
           <p:nvPr/>
         </p:nvSpPr>
@@ -8241,7 +9856,7 @@
                   <a:srgbClr val="8FB8A5"/>
                 </a:solidFill>
               </a:rPr>
-              <a:t>micro-projects MKBANK targets in 2026 (47,975 in 2025); 1,062 mahalla agents</a:t>
+              <a:t>projects MKBANK plans under its lending programmes in 2026 (47,975 micro-projects financed in 2025); 1,062 mahalla agents</a:t>
             </a:r>
             <a:endParaRPr lang="en-US" sz="1100" dirty="0"/>
           </a:p>
@@ -8475,7 +10090,7 @@
                   <a:srgbClr val="5C6B63"/>
                 </a:solidFill>
               </a:rPr>
-              <a:t>Sources: lex.uz/docs/4654149 and 6809992 (CBU regulation and 2024 amendments) · spot.uz 27 Mar 2026 (MKBANK, bank's own figures) · yuz.uz (self-employed registrations, 2021) · buxgalter.uz</a:t>
+              <a:t>Sources: CBU Regulation No. 3618 (Board decision 7/3, 8 Apr 2025; lex.uz/uz/docs/7491592) · spot.uz 27 Mar 2026 (MKBANK, bank's own figures) · yuz.uz (self-employed registrations, 2021) — full list in Appendix D</a:t>
             </a:r>
             <a:endParaRPr lang="en-US" sz="900" dirty="0"/>
           </a:p>
@@ -8716,7 +10331,7 @@
                   <a:srgbClr val="1F4E3D"/>
                 </a:solidFill>
               </a:rPr>
-              <a:t>12-month regulatory income</a:t>
+              <a:t>Regulatory income</a:t>
             </a:r>
             <a:endParaRPr lang="en-US" sz="1400" dirty="0"/>
           </a:p>
@@ -8752,7 +10367,7 @@
                   <a:srgbClr val="17201B"/>
                 </a:solidFill>
               </a:rPr>
-              <a:t>cl.7 mean, cl.9 definition; own-card transfers, loan proceeds, refunds and cash deposits excluded</a:t>
+              <a:t>cl.13 mean of 6–12 months (median option, cl.14) of account receipts (cl.18); own-card transfers, loan proceeds, refunds and cash deposits excluded</a:t>
             </a:r>
             <a:endParaRPr lang="en-US" sz="1050" dirty="0"/>
           </a:p>
@@ -8873,7 +10488,7 @@
                   <a:srgbClr val="17201B"/>
                 </a:solidFill>
               </a:rPr>
-              <a:t>36-month spreading, guarantor rule, family-programme exemption, lender-type rules (banks: no small-loan exclusion, 15% quota is portfolio-level), 50% cap, maximum affordable amount</a:t>
+              <a:t>36/60/180-month spreading, guarantor rule, cl.4 exemptions, 50% limit, the 50–100% quota band and the new-self-employed quota (cl.3), maximum affordable amount</a:t>
             </a:r>
             <a:endParaRPr lang="en-US" sz="1050" dirty="0"/>
           </a:p>
@@ -9378,7 +10993,7 @@
                   <a:srgbClr val="17201B"/>
                 </a:solidFill>
               </a:rPr>
-              <a:t>2.  Income series, ПДН with clause citations, maximum affordable amount; drag the slider to cross the 50% cap</a:t>
+              <a:t>2.  Income series, ПДН with clause citations, maximum affordable amount; drag the slider to cross the 50% limit</a:t>
             </a:r>
             <a:endParaRPr lang="en-US" sz="1250" dirty="0"/>
           </a:p>
@@ -10254,7 +11869,7 @@
                   <a:srgbClr val="17201B"/>
                 </a:solidFill>
               </a:rPr>
-              <a:t>ПДН clause by clause: 36/180-month spreading, guarantor rule, lender-type exclusions, family-programme exemption, 50% cap, back-solved amount</a:t>
+              <a:t>ПДН clause by clause (Regulation 3618): 36/60/180-month spreading, guarantor rule, cl.4 exemptions, 50% limit, 15% quota bands, back-solved amount</a:t>
             </a:r>
             <a:endParaRPr lang="en-US" sz="1050" dirty="0"/>
           </a:p>
@@ -14352,7 +15967,7 @@
       </p:sp>
       <p:sp>
         <p:nvSpPr>
-          <p:cNvPr id="11" name="tile addressable applications: 30% of MKBANK's 140,000 micro-projects (bank's own 2026 target) — those outside the ПДН-exempt family programme (assumption 2)"/>
+          <p:cNvPr id="11" name="tile addressable applications: 30% of MKBANK's 140,000 micro-projects (bank's own 2026 target) — those outside the cl.4-exempt family programme (assumption 2)"/>
           <p:cNvSpPr/>
           <p:nvPr/>
         </p:nvSpPr>
@@ -14379,7 +15994,7 @@
       </p:sp>
       <p:sp>
         <p:nvSpPr>
-          <p:cNvPr id="12" name="tile value addressable applications: 30% of MKBANK&amp;apos;s 140,000 micro-projects (bank&amp;apos;s own 2026 target) — those outside the ПДН-exempt family programme (assumption 2)"/>
+          <p:cNvPr id="12" name="tile value addressable applications: 30% of MKBANK&amp;apos;s 140,000 micro-projects (bank&amp;apos;s own 2026 target) — those outside the cl.4-exempt family programme (assumption 2)"/>
           <p:cNvSpPr txBox="1"/>
           <p:nvPr/>
         </p:nvSpPr>
@@ -14415,7 +16030,7 @@
       </p:sp>
       <p:sp>
         <p:nvSpPr>
-          <p:cNvPr id="13" name="tile label addressable applications: 30% of MKBANK&amp;apos;s 140,000 micro-projects (bank&amp;apos;s own 2026 target) — those outside the ПДН-exempt family programme (assumption 2)"/>
+          <p:cNvPr id="13" name="tile label addressable applications: 30% of MKBANK&amp;apos;s 140,000 micro-projects (bank&amp;apos;s own 2026 target) — those outside the cl.4-exempt family programme (assumption 2)"/>
           <p:cNvSpPr txBox="1"/>
           <p:nvPr/>
         </p:nvSpPr>
@@ -14443,7 +16058,7 @@
                   <a:srgbClr val="5C6B63"/>
                 </a:solidFill>
               </a:rPr>
-              <a:t>addressable applications: 30% of MKBANK's 140,000 micro-projects (bank's own 2026 target) — those outside the ПДН-exempt family programme (assumption 2)</a:t>
+              <a:t>addressable applications: 30% of MKBANK's 140,000 micro-projects (bank's own 2026 target) — those outside the cl.4-exempt family programme (assumption 2)</a:t>
             </a:r>
             <a:endParaRPr lang="en-US" sz="850" dirty="0"/>
           </a:p>
@@ -14995,7 +16610,7 @@
                   <a:srgbClr val="17201B"/>
                 </a:solidFill>
               </a:rPr>
-              <a:t>A rule engine mapped clause by clause to the live ПДН regulation, with its exemptions and the back-solved maximum amount</a:t>
+              <a:t>A rule engine mapped clause by clause to the live bank regulation (No. 3618), with its exemptions, quota bands and the back-solved maximum amount</a:t>
             </a:r>
             <a:endParaRPr lang="en-US" sz="1150" dirty="0"/>
           </a:p>

</xml_diff>